<commit_message>
Connect prediction performance to OEE value
</commit_message>
<xml_diff>
--- a/trexCloud_Sunum.pptx
+++ b/trexCloud_Sunum.pptx
@@ -1072,7 +1072,7 @@
           <a:lstStyle/>
           <a:p>
             <a:r>
-              <a:t>Madalya tahmin istemiyordu ama biz duruşu 60 dakika önceden tahmin ediyoruz. Dürüst çerçeve: iyi bir risk sıralayıcı, kâhin değil; ve neden yalnız Fanuc'a sınırlı olduğunu biliyoruz. Canlı demo: risk zaman çizgisi.</a:t>
+              <a:t>Tahmini ilk kez doğrudan OEE ve euroya bağlıyoruz. Recall yakalanabilecek duruş havuzunu, alarm isabeti ve alarm sayısı ise müdahale maliyetini belirliyor. Varsayılan 300 euro kontrol maliyetinde dağıtılan eşik ekonomik değil; bunu saklamıyoruz. Retrospektif ekonomik eşik daha az alarm ve pozitif net değer üretiyor, ama canlı model seçimi olarak sunulmuyor.</a:t>
             </a:r>
           </a:p>
         </p:txBody>
@@ -1212,7 +1212,7 @@
           <a:lstStyle/>
           <a:p>
             <a:r>
-              <a:t>Çözümün etkisini sayısallaştırıyoruz. Kaydırıcıyı oynatınca OEE ve euro canlı güncelleniyor. Maliyet verisi olmadığından varsayımları açıkça etiketliyoruz. Canlı demo: What-If kaydırıcısı.</a:t>
+              <a:t>Dört senaryo aynı hesap sözleşmesiyle incelenebilir. S1 gerçek OEE ve zaman kazanımıdır. S2 runtime yaratmadan A'yı yükseltir; bu yüzden finansal faydası yoktur. S3 veri yokluğunda bilerek inerttir. S4 bağlantı görünürlüğünü geri getirir ama makine OEE'sine yazılmaz.</a:t>
             </a:r>
           </a:p>
         </p:txBody>
@@ -9467,7 +9467,7 @@
                 </a:solidFill>
                 <a:latin typeface="Helvetica Neue"/>
               </a:rPr>
-              <a:t>TAHMIN · BONUS</a:t>
+              <a:t>TAHMIN · DEĞER</a:t>
             </a:r>
           </a:p>
         </p:txBody>
@@ -9509,7 +9509,7 @@
                 </a:solidFill>
                 <a:latin typeface="Helvetica Neue"/>
               </a:rPr>
-              <a:t>Duruşu önceden tahmin</a:t>
+              <a:t>ROC / lift katmanından OEE ve €'ya</a:t>
             </a:r>
           </a:p>
         </p:txBody>
@@ -9650,8 +9650,8 @@
         </p:nvSpPr>
         <p:spPr>
           <a:xfrm>
-            <a:off x="777240" y="2697480"/>
-            <a:ext cx="3301898" cy="1371600"/>
+            <a:off x="777240" y="2331720"/>
+            <a:ext cx="2487853" cy="1234440"/>
           </a:xfrm>
           <a:prstGeom prst="rect">
             <a:avLst/>
@@ -9696,8 +9696,8 @@
         </p:nvSpPr>
         <p:spPr>
           <a:xfrm>
-            <a:off x="777240" y="2880360"/>
-            <a:ext cx="3301898" cy="731520"/>
+            <a:off x="777240" y="2523744"/>
+            <a:ext cx="2487853" cy="502920"/>
           </a:xfrm>
           <a:prstGeom prst="rect">
             <a:avLst/>
@@ -9719,7 +9719,7 @@
               </a:spcAft>
             </a:pPr>
             <a:r>
-              <a:rPr sz="3800" b="1">
+              <a:rPr sz="3000" b="1">
                 <a:solidFill>
                   <a:srgbClr val="127145"/>
                 </a:solidFill>
@@ -9738,8 +9738,8 @@
         </p:nvSpPr>
         <p:spPr>
           <a:xfrm>
-            <a:off x="777240" y="3657600"/>
-            <a:ext cx="3301898" cy="365760"/>
+            <a:off x="850392" y="3127248"/>
+            <a:ext cx="2341549" cy="310896"/>
           </a:xfrm>
           <a:prstGeom prst="rect">
             <a:avLst/>
@@ -9761,7 +9761,7 @@
               </a:spcAft>
             </a:pPr>
             <a:r>
-              <a:rPr sz="1250" b="0">
+              <a:rPr sz="1050" b="0">
                 <a:solidFill>
                   <a:srgbClr val="6B7771"/>
                 </a:solidFill>
@@ -9780,8 +9780,8 @@
         </p:nvSpPr>
         <p:spPr>
           <a:xfrm>
-            <a:off x="4444898" y="2697480"/>
-            <a:ext cx="3301898" cy="1371600"/>
+            <a:off x="3493693" y="2331720"/>
+            <a:ext cx="2487853" cy="1234440"/>
           </a:xfrm>
           <a:prstGeom prst="rect">
             <a:avLst/>
@@ -9826,8 +9826,8 @@
         </p:nvSpPr>
         <p:spPr>
           <a:xfrm>
-            <a:off x="4444898" y="2880360"/>
-            <a:ext cx="3301898" cy="731520"/>
+            <a:off x="3493693" y="2523744"/>
+            <a:ext cx="2487853" cy="502920"/>
           </a:xfrm>
           <a:prstGeom prst="rect">
             <a:avLst/>
@@ -9849,7 +9849,7 @@
               </a:spcAft>
             </a:pPr>
             <a:r>
-              <a:rPr sz="3800" b="1">
+              <a:rPr sz="3000" b="1">
                 <a:solidFill>
                   <a:srgbClr val="127145"/>
                 </a:solidFill>
@@ -9868,8 +9868,8 @@
         </p:nvSpPr>
         <p:spPr>
           <a:xfrm>
-            <a:off x="4444898" y="3657600"/>
-            <a:ext cx="3301898" cy="365760"/>
+            <a:off x="3566845" y="3127248"/>
+            <a:ext cx="2341549" cy="310896"/>
           </a:xfrm>
           <a:prstGeom prst="rect">
             <a:avLst/>
@@ -9891,7 +9891,7 @@
               </a:spcAft>
             </a:pPr>
             <a:r>
-              <a:rPr sz="1250" b="0">
+              <a:rPr sz="1050" b="0">
                 <a:solidFill>
                   <a:srgbClr val="6B7771"/>
                 </a:solidFill>
@@ -9910,8 +9910,8 @@
         </p:nvSpPr>
         <p:spPr>
           <a:xfrm>
-            <a:off x="8112556" y="2697480"/>
-            <a:ext cx="3301898" cy="1371600"/>
+            <a:off x="6210147" y="2331720"/>
+            <a:ext cx="2487853" cy="1234440"/>
           </a:xfrm>
           <a:prstGeom prst="rect">
             <a:avLst/>
@@ -9956,8 +9956,8 @@
         </p:nvSpPr>
         <p:spPr>
           <a:xfrm>
-            <a:off x="8112556" y="2880360"/>
-            <a:ext cx="3301898" cy="731520"/>
+            <a:off x="6210147" y="2523744"/>
+            <a:ext cx="2487853" cy="502920"/>
           </a:xfrm>
           <a:prstGeom prst="rect">
             <a:avLst/>
@@ -9979,13 +9979,13 @@
               </a:spcAft>
             </a:pPr>
             <a:r>
-              <a:rPr sz="3800" b="1">
+              <a:rPr sz="3000" b="1">
                 <a:solidFill>
                   <a:srgbClr val="127145"/>
                 </a:solidFill>
                 <a:latin typeface="Helvetica Neue"/>
               </a:rPr>
-              <a:t>%44</a:t>
+              <a:t>%69</a:t>
             </a:r>
           </a:p>
         </p:txBody>
@@ -9998,8 +9998,8 @@
         </p:nvSpPr>
         <p:spPr>
           <a:xfrm>
-            <a:off x="8112556" y="3657600"/>
-            <a:ext cx="3301898" cy="365760"/>
+            <a:off x="6283299" y="3127248"/>
+            <a:ext cx="2341549" cy="310896"/>
           </a:xfrm>
           <a:prstGeom prst="rect">
             <a:avLst/>
@@ -10021,93 +10021,60 @@
               </a:spcAft>
             </a:pPr>
             <a:r>
-              <a:rPr sz="1250" b="0">
+              <a:rPr sz="1050" b="0">
                 <a:solidFill>
                   <a:srgbClr val="6B7771"/>
                 </a:solidFill>
                 <a:latin typeface="Helvetica Neue"/>
               </a:rPr>
-              <a:t>dönem isabeti · taban %18</a:t>
-            </a:r>
-          </a:p>
-        </p:txBody>
-      </p:sp>
-      <p:sp>
-        <p:nvSpPr>
-          <p:cNvPr id="17" name="TextBox 16"/>
-          <p:cNvSpPr txBox="1"/>
-          <p:nvPr/>
-        </p:nvSpPr>
-        <p:spPr>
-          <a:xfrm>
-            <a:off x="777240" y="4572000"/>
-            <a:ext cx="10637215" cy="1463040"/>
-          </a:xfrm>
-          <a:prstGeom prst="rect">
-            <a:avLst/>
-          </a:prstGeom>
-          <a:noFill/>
-        </p:spPr>
-        <p:txBody>
-          <a:bodyPr wrap="square" lIns="0" rIns="0" tIns="0">
-            <a:spAutoFit/>
-          </a:bodyPr>
-          <a:lstStyle/>
-          <a:p>
-            <a:pPr>
-              <a:lnSpc>
-                <a:spcPct val="116000"/>
-              </a:lnSpc>
-              <a:spcAft>
-                <a:spcPts val="1100"/>
-              </a:spcAft>
-            </a:pPr>
-            <a:r>
-              <a:rPr sz="1600" b="1">
-                <a:solidFill>
-                  <a:srgbClr val="127145"/>
-                </a:solidFill>
-                <a:latin typeface="Helvetica Neue"/>
-              </a:rPr>
-              <a:t>—  </a:t>
-            </a:r>
-            <a:r>
-              <a:rPr sz="1600" b="0">
-                <a:solidFill>
-                  <a:srgbClr val="1A1F1D"/>
-                </a:solidFill>
-                <a:latin typeface="Helvetica Neue"/>
-              </a:rPr>
-              <a:t>Sızıntısız kurulum: makine-içi kronolojik ayrım, geçmiş-yalnız öznitelik, makine-içi normalizasyon.</a:t>
-            </a:r>
-          </a:p>
-          <a:p>
-            <a:pPr>
-              <a:lnSpc>
-                <a:spcPct val="116000"/>
-              </a:lnSpc>
-              <a:spcAft>
-                <a:spcPts val="1100"/>
-              </a:spcAft>
-            </a:pPr>
-            <a:r>
-              <a:rPr sz="1600" b="1">
-                <a:solidFill>
-                  <a:srgbClr val="127145"/>
-                </a:solidFill>
-                <a:latin typeface="Helvetica Neue"/>
-              </a:rPr>
-              <a:t>—  </a:t>
-            </a:r>
-            <a:r>
-              <a:rPr sz="1600" b="0">
-                <a:solidFill>
-                  <a:srgbClr val="1A1F1D"/>
-                </a:solidFill>
-                <a:latin typeface="Helvetica Neue"/>
-              </a:rPr>
-              <a:t>Kapsam Fanuc üretim hücresi — duruş öncesi sinyali (cycle-time, run-state) yalnız orada akıyor.</a:t>
-            </a:r>
+              <a:t>duruş yakalama · held-out</a:t>
+            </a:r>
+          </a:p>
+        </p:txBody>
+      </p:sp>
+      <p:sp>
+        <p:nvSpPr>
+          <p:cNvPr id="17" name="Rectangle 16"/>
+          <p:cNvSpPr/>
+          <p:nvPr/>
+        </p:nvSpPr>
+        <p:spPr>
+          <a:xfrm>
+            <a:off x="8926601" y="2331720"/>
+            <a:ext cx="2487853" cy="1234440"/>
+          </a:xfrm>
+          <a:prstGeom prst="rect">
+            <a:avLst/>
+          </a:prstGeom>
+          <a:solidFill>
+            <a:srgbClr val="FFFFFF"/>
+          </a:solidFill>
+          <a:ln w="12700">
+            <a:solidFill>
+              <a:srgbClr val="D9DFDB"/>
+            </a:solidFill>
+          </a:ln>
+          <a:effectLst/>
+        </p:spPr>
+        <p:style>
+          <a:lnRef idx="1">
+            <a:schemeClr val="accent1"/>
+          </a:lnRef>
+          <a:fillRef idx="3">
+            <a:schemeClr val="accent1"/>
+          </a:fillRef>
+          <a:effectRef idx="2">
+            <a:schemeClr val="accent1"/>
+          </a:effectRef>
+          <a:fontRef idx="minor">
+            <a:schemeClr val="lt1"/>
+          </a:fontRef>
+        </p:style>
+        <p:txBody>
+          <a:bodyPr rtlCol="0" anchor="ctr"/>
+          <a:lstStyle/>
+          <a:p>
+            <a:pPr algn="ctr"/>
           </a:p>
         </p:txBody>
       </p:sp>
@@ -10119,8 +10086,8 @@
         </p:nvSpPr>
         <p:spPr>
           <a:xfrm>
-            <a:off x="777240" y="5715000"/>
-            <a:ext cx="10637215" cy="365760"/>
+            <a:off x="8926601" y="2523744"/>
+            <a:ext cx="2487853" cy="502920"/>
           </a:xfrm>
           <a:prstGeom prst="rect">
             <a:avLst/>
@@ -10133,7 +10100,7 @@
           </a:bodyPr>
           <a:lstStyle/>
           <a:p>
-            <a:pPr algn="l">
+            <a:pPr algn="ctr">
               <a:lnSpc>
                 <a:spcPct val="112000"/>
               </a:lnSpc>
@@ -10142,13 +10109,294 @@
               </a:spcAft>
             </a:pPr>
             <a:r>
+              <a:rPr sz="3000" b="1">
+                <a:solidFill>
+                  <a:srgbClr val="127145"/>
+                </a:solidFill>
+                <a:latin typeface="Helvetica Neue"/>
+              </a:rPr>
+              <a:t>+10,44</a:t>
+            </a:r>
+          </a:p>
+        </p:txBody>
+      </p:sp>
+      <p:sp>
+        <p:nvSpPr>
+          <p:cNvPr id="19" name="TextBox 18"/>
+          <p:cNvSpPr txBox="1"/>
+          <p:nvPr/>
+        </p:nvSpPr>
+        <p:spPr>
+          <a:xfrm>
+            <a:off x="8999753" y="3127248"/>
+            <a:ext cx="2341549" cy="310896"/>
+          </a:xfrm>
+          <a:prstGeom prst="rect">
+            <a:avLst/>
+          </a:prstGeom>
+          <a:noFill/>
+        </p:spPr>
+        <p:txBody>
+          <a:bodyPr wrap="square" anchor="t" lIns="0" rIns="0" tIns="0" bIns="0">
+            <a:spAutoFit/>
+          </a:bodyPr>
+          <a:lstStyle/>
+          <a:p>
+            <a:pPr algn="ctr">
+              <a:lnSpc>
+                <a:spcPct val="112000"/>
+              </a:lnSpc>
+              <a:spcAft>
+                <a:spcPts val="800"/>
+              </a:spcAft>
+            </a:pPr>
+            <a:r>
+              <a:rPr sz="1050" b="0">
+                <a:solidFill>
+                  <a:srgbClr val="6B7771"/>
+                </a:solidFill>
+                <a:latin typeface="Helvetica Neue"/>
+              </a:rPr>
+              <a:t>puan OEE · e=%35</a:t>
+            </a:r>
+          </a:p>
+        </p:txBody>
+      </p:sp>
+      <p:sp>
+        <p:nvSpPr>
+          <p:cNvPr id="20" name="TextBox 19"/>
+          <p:cNvSpPr txBox="1"/>
+          <p:nvPr/>
+        </p:nvSpPr>
+        <p:spPr>
+          <a:xfrm>
+            <a:off x="777240" y="3886200"/>
+            <a:ext cx="10637215" cy="2148840"/>
+          </a:xfrm>
+          <a:prstGeom prst="rect">
+            <a:avLst/>
+          </a:prstGeom>
+          <a:noFill/>
+        </p:spPr>
+        <p:txBody>
+          <a:bodyPr wrap="square" lIns="0" rIns="0" tIns="0">
+            <a:spAutoFit/>
+          </a:bodyPr>
+          <a:lstStyle/>
+          <a:p>
+            <a:pPr>
+              <a:lnSpc>
+                <a:spcPct val="116000"/>
+              </a:lnSpc>
+              <a:spcAft>
+                <a:spcPts val="800"/>
+              </a:spcAft>
+            </a:pPr>
+            <a:r>
+              <a:rPr sz="1600" b="1">
+                <a:solidFill>
+                  <a:srgbClr val="127145"/>
+                </a:solidFill>
+                <a:latin typeface="Helvetica Neue"/>
+              </a:rPr>
+              <a:t>—  </a:t>
+            </a:r>
+            <a:r>
+              <a:rPr sz="1600" b="0">
+                <a:solidFill>
+                  <a:srgbClr val="1A1F1D"/>
+                </a:solidFill>
+                <a:latin typeface="Helvetica Neue"/>
+              </a:rPr>
+              <a:t>Gerçek held-out ölçüm: </a:t>
+            </a:r>
+            <a:r>
+              <a:rPr sz="1600" b="1">
+                <a:solidFill>
+                  <a:srgbClr val="1A1F1D"/>
+                </a:solidFill>
+                <a:latin typeface="Helvetica Neue"/>
+              </a:rPr>
+              <a:t>364/527</a:t>
+            </a:r>
+            <a:r>
+              <a:rPr sz="1600" b="0">
+                <a:solidFill>
+                  <a:srgbClr val="1A1F1D"/>
+                </a:solidFill>
+                <a:latin typeface="Helvetica Neue"/>
+              </a:rPr>
+              <a:t> duruş yakalandı; </a:t>
+            </a:r>
+            <a:r>
+              <a:rPr sz="1600" b="1">
+                <a:solidFill>
+                  <a:srgbClr val="1A1F1D"/>
+                </a:solidFill>
+                <a:latin typeface="Helvetica Neue"/>
+              </a:rPr>
+              <a:t>722</a:t>
+            </a:r>
+            <a:r>
+              <a:rPr sz="1600" b="0">
+                <a:solidFill>
+                  <a:srgbClr val="1A1F1D"/>
+                </a:solidFill>
+                <a:latin typeface="Helvetica Neue"/>
+              </a:rPr>
+              <a:t> alarm döneminin isabeti %44.</a:t>
+            </a:r>
+          </a:p>
+          <a:p>
+            <a:pPr>
+              <a:lnSpc>
+                <a:spcPct val="116000"/>
+              </a:lnSpc>
+              <a:spcAft>
+                <a:spcPts val="800"/>
+              </a:spcAft>
+            </a:pPr>
+            <a:r>
+              <a:rPr sz="1600" b="1">
+                <a:solidFill>
+                  <a:srgbClr val="127145"/>
+                </a:solidFill>
+                <a:latin typeface="Helvetica Neue"/>
+              </a:rPr>
+              <a:t>—  </a:t>
+            </a:r>
+            <a:r>
+              <a:rPr sz="1600" b="0">
+                <a:solidFill>
+                  <a:srgbClr val="1A1F1D"/>
+                </a:solidFill>
+                <a:latin typeface="Helvetica Neue"/>
+              </a:rPr>
+              <a:t>e=%35 varsayımıyla yıllık projeksiyon: </a:t>
+            </a:r>
+            <a:r>
+              <a:rPr sz="1600" b="1">
+                <a:solidFill>
+                  <a:srgbClr val="1A1F1D"/>
+                </a:solidFill>
+                <a:latin typeface="Helvetica Neue"/>
+              </a:rPr>
+              <a:t>2330 saat</a:t>
+            </a:r>
+            <a:r>
+              <a:rPr sz="1600" b="0">
+                <a:solidFill>
+                  <a:srgbClr val="1A1F1D"/>
+                </a:solidFill>
+                <a:latin typeface="Helvetica Neue"/>
+              </a:rPr>
+              <a:t>; fakat 300 €/kontrol varsayımında net </a:t>
+            </a:r>
+            <a:r>
+              <a:rPr sz="1600" b="1">
+                <a:solidFill>
+                  <a:srgbClr val="1A1F1D"/>
+                </a:solidFill>
+                <a:latin typeface="Helvetica Neue"/>
+              </a:rPr>
+              <a:t>-512,666 €</a:t>
+            </a:r>
+            <a:r>
+              <a:rPr sz="1600" b="0">
+                <a:solidFill>
+                  <a:srgbClr val="1A1F1D"/>
+                </a:solidFill>
+                <a:latin typeface="Helvetica Neue"/>
+              </a:rPr>
+              <a:t>.</a:t>
+            </a:r>
+          </a:p>
+        </p:txBody>
+      </p:sp>
+      <p:sp>
+        <p:nvSpPr>
+          <p:cNvPr id="21" name="Rectangle 20"/>
+          <p:cNvSpPr/>
+          <p:nvPr/>
+        </p:nvSpPr>
+        <p:spPr>
+          <a:xfrm>
+            <a:off x="777240" y="5166360"/>
+            <a:ext cx="10637215" cy="658368"/>
+          </a:xfrm>
+          <a:prstGeom prst="rect">
+            <a:avLst/>
+          </a:prstGeom>
+          <a:solidFill>
+            <a:srgbClr val="ECF4EF"/>
+          </a:solidFill>
+          <a:ln w="15240">
+            <a:solidFill>
+              <a:srgbClr val="127145"/>
+            </a:solidFill>
+          </a:ln>
+          <a:effectLst/>
+        </p:spPr>
+        <p:style>
+          <a:lnRef idx="1">
+            <a:schemeClr val="accent1"/>
+          </a:lnRef>
+          <a:fillRef idx="3">
+            <a:schemeClr val="accent1"/>
+          </a:fillRef>
+          <a:effectRef idx="2">
+            <a:schemeClr val="accent1"/>
+          </a:effectRef>
+          <a:fontRef idx="minor">
+            <a:schemeClr val="lt1"/>
+          </a:fontRef>
+        </p:style>
+        <p:txBody>
+          <a:bodyPr rtlCol="0" anchor="ctr"/>
+          <a:lstStyle/>
+          <a:p>
+            <a:pPr algn="ctr"/>
+          </a:p>
+        </p:txBody>
+      </p:sp>
+      <p:sp>
+        <p:nvSpPr>
+          <p:cNvPr id="22" name="TextBox 21"/>
+          <p:cNvSpPr txBox="1"/>
+          <p:nvPr/>
+        </p:nvSpPr>
+        <p:spPr>
+          <a:xfrm>
+            <a:off x="978408" y="5330952"/>
+            <a:ext cx="10234879" cy="329184"/>
+          </a:xfrm>
+          <a:prstGeom prst="rect">
+            <a:avLst/>
+          </a:prstGeom>
+          <a:noFill/>
+        </p:spPr>
+        <p:txBody>
+          <a:bodyPr wrap="square" anchor="t" lIns="0" rIns="0" tIns="0" bIns="0">
+            <a:spAutoFit/>
+          </a:bodyPr>
+          <a:lstStyle/>
+          <a:p>
+            <a:pPr algn="l">
+              <a:lnSpc>
+                <a:spcPct val="110000"/>
+              </a:lnSpc>
+              <a:spcAft>
+                <a:spcPts val="800"/>
+              </a:spcAft>
+            </a:pPr>
+            <a:r>
               <a:rPr sz="1250" b="0">
                 <a:solidFill>
-                  <a:srgbClr val="6B7771"/>
-                </a:solidFill>
-                <a:latin typeface="Helvetica Neue"/>
-              </a:rPr>
-              <a:t>Abartmıyoruz: bu kullanışlı bir risk sıralayıcı; makine-içi ROC ≈ 0,72, kâhin değil.</a:t>
+                  <a:srgbClr val="1A1F1D"/>
+                </a:solidFill>
+                <a:latin typeface="Helvetica Neue"/>
+              </a:rPr>
+              <a:t>Ekonomik duyarlılık (retrospektif): eşik 0.78 → 33 kontrol → 11,013 €/yıl net. Canlı eşiğin yerine geçmez.</a:t>
             </a:r>
           </a:p>
         </p:txBody>
@@ -11133,7 +11381,7 @@
                 </a:solidFill>
                 <a:latin typeface="Helvetica Neue"/>
               </a:rPr>
-              <a:t>ΔOEE ve finansal etki</a:t>
+              <a:t>İncelenebilir senaryo kataloğu</a:t>
             </a:r>
           </a:p>
         </p:txBody>
@@ -11268,14 +11516,58 @@
       </p:sp>
       <p:sp>
         <p:nvSpPr>
-          <p:cNvPr id="8" name="TextBox 7"/>
+          <p:cNvPr id="8" name="Rectangle 7"/>
+          <p:cNvSpPr/>
+          <p:nvPr/>
+        </p:nvSpPr>
+        <p:spPr>
+          <a:xfrm>
+            <a:off x="777240" y="2148840"/>
+            <a:ext cx="3794760" cy="411480"/>
+          </a:xfrm>
+          <a:prstGeom prst="rect">
+            <a:avLst/>
+          </a:prstGeom>
+          <a:solidFill>
+            <a:srgbClr val="1A1F1D"/>
+          </a:solidFill>
+          <a:ln>
+            <a:noFill/>
+          </a:ln>
+          <a:effectLst/>
+        </p:spPr>
+        <p:style>
+          <a:lnRef idx="1">
+            <a:schemeClr val="accent1"/>
+          </a:lnRef>
+          <a:fillRef idx="3">
+            <a:schemeClr val="accent1"/>
+          </a:fillRef>
+          <a:effectRef idx="2">
+            <a:schemeClr val="accent1"/>
+          </a:effectRef>
+          <a:fontRef idx="minor">
+            <a:schemeClr val="lt1"/>
+          </a:fontRef>
+        </p:style>
+        <p:txBody>
+          <a:bodyPr rtlCol="0" anchor="ctr"/>
+          <a:lstStyle/>
+          <a:p>
+            <a:pPr algn="ctr"/>
+          </a:p>
+        </p:txBody>
+      </p:sp>
+      <p:sp>
+        <p:nvSpPr>
+          <p:cNvPr id="9" name="TextBox 8"/>
           <p:cNvSpPr txBox="1"/>
           <p:nvPr/>
         </p:nvSpPr>
         <p:spPr>
           <a:xfrm>
-            <a:off x="777240" y="2084831"/>
-            <a:ext cx="10637215" cy="3950208"/>
+            <a:off x="868680" y="2258568"/>
+            <a:ext cx="3611880" cy="201168"/>
           </a:xfrm>
           <a:prstGeom prst="rect">
             <a:avLst/>
@@ -11283,124 +11575,2583 @@
           <a:noFill/>
         </p:spPr>
         <p:txBody>
-          <a:bodyPr wrap="square" lIns="0" rIns="0" tIns="0">
+          <a:bodyPr wrap="square" anchor="t" lIns="0" rIns="0" tIns="0" bIns="0">
             <a:spAutoFit/>
           </a:bodyPr>
           <a:lstStyle/>
           <a:p>
-            <a:pPr>
+            <a:pPr algn="l">
               <a:lnSpc>
-                <a:spcPct val="116000"/>
+                <a:spcPct val="112000"/>
               </a:lnSpc>
               <a:spcAft>
-                <a:spcPts val="1100"/>
+                <a:spcPts val="800"/>
               </a:spcAft>
             </a:pPr>
             <a:r>
-              <a:rPr sz="1600" b="1">
-                <a:solidFill>
-                  <a:srgbClr val="127145"/>
-                </a:solidFill>
-                <a:latin typeface="Helvetica Neue"/>
-              </a:rPr>
-              <a:t>—  </a:t>
-            </a:r>
-            <a:r>
-              <a:rPr sz="1600" b="0">
-                <a:solidFill>
-                  <a:srgbClr val="1A1F1D"/>
-                </a:solidFill>
-                <a:latin typeface="Helvetica Neue"/>
-              </a:rPr>
-              <a:t>W1 senaryosu: bir makinenin plansız duruşunu azalt → kullanılabilirlik yükselir.</a:t>
-            </a:r>
-          </a:p>
-          <a:p>
-            <a:pPr>
+              <a:rPr sz="1000" b="1">
+                <a:solidFill>
+                  <a:srgbClr val="FFFFFF"/>
+                </a:solidFill>
+                <a:latin typeface="Helvetica Neue"/>
+              </a:rPr>
+              <a:t>Senaryo / kapsam</a:t>
+            </a:r>
+          </a:p>
+        </p:txBody>
+      </p:sp>
+      <p:sp>
+        <p:nvSpPr>
+          <p:cNvPr id="10" name="Rectangle 9"/>
+          <p:cNvSpPr/>
+          <p:nvPr/>
+        </p:nvSpPr>
+        <p:spPr>
+          <a:xfrm>
+            <a:off x="4572000" y="2148840"/>
+            <a:ext cx="960120" cy="411480"/>
+          </a:xfrm>
+          <a:prstGeom prst="rect">
+            <a:avLst/>
+          </a:prstGeom>
+          <a:solidFill>
+            <a:srgbClr val="1A1F1D"/>
+          </a:solidFill>
+          <a:ln>
+            <a:noFill/>
+          </a:ln>
+          <a:effectLst/>
+        </p:spPr>
+        <p:style>
+          <a:lnRef idx="1">
+            <a:schemeClr val="accent1"/>
+          </a:lnRef>
+          <a:fillRef idx="3">
+            <a:schemeClr val="accent1"/>
+          </a:fillRef>
+          <a:effectRef idx="2">
+            <a:schemeClr val="accent1"/>
+          </a:effectRef>
+          <a:fontRef idx="minor">
+            <a:schemeClr val="lt1"/>
+          </a:fontRef>
+        </p:style>
+        <p:txBody>
+          <a:bodyPr rtlCol="0" anchor="ctr"/>
+          <a:lstStyle/>
+          <a:p>
+            <a:pPr algn="ctr"/>
+          </a:p>
+        </p:txBody>
+      </p:sp>
+      <p:sp>
+        <p:nvSpPr>
+          <p:cNvPr id="11" name="TextBox 10"/>
+          <p:cNvSpPr txBox="1"/>
+          <p:nvPr/>
+        </p:nvSpPr>
+        <p:spPr>
+          <a:xfrm>
+            <a:off x="4663440" y="2258568"/>
+            <a:ext cx="777240" cy="201168"/>
+          </a:xfrm>
+          <a:prstGeom prst="rect">
+            <a:avLst/>
+          </a:prstGeom>
+          <a:noFill/>
+        </p:spPr>
+        <p:txBody>
+          <a:bodyPr wrap="square" anchor="t" lIns="0" rIns="0" tIns="0" bIns="0">
+            <a:spAutoFit/>
+          </a:bodyPr>
+          <a:lstStyle/>
+          <a:p>
+            <a:pPr algn="l">
               <a:lnSpc>
-                <a:spcPct val="116000"/>
+                <a:spcPct val="112000"/>
               </a:lnSpc>
               <a:spcAft>
-                <a:spcPts val="1100"/>
+                <a:spcPts val="800"/>
               </a:spcAft>
             </a:pPr>
             <a:r>
-              <a:rPr sz="1600" b="1">
-                <a:solidFill>
-                  <a:srgbClr val="127145"/>
-                </a:solidFill>
-                <a:latin typeface="Helvetica Neue"/>
-              </a:rPr>
-              <a:t>—  </a:t>
-            </a:r>
-            <a:r>
-              <a:rPr sz="1600" b="0">
-                <a:solidFill>
-                  <a:srgbClr val="1A1F1D"/>
-                </a:solidFill>
-                <a:latin typeface="Helvetica Neue"/>
-              </a:rPr>
-              <a:t>Etki, OEE bileşenlerine ayrıştırılır (</a:t>
-            </a:r>
-            <a:r>
-              <a:rPr sz="1600" b="1">
-                <a:solidFill>
-                  <a:srgbClr val="1A1F1D"/>
-                </a:solidFill>
-                <a:latin typeface="Helvetica Neue"/>
-              </a:rPr>
-              <a:t>A / P / Q</a:t>
-            </a:r>
-            <a:r>
-              <a:rPr sz="1600" b="0">
-                <a:solidFill>
-                  <a:srgbClr val="1A1F1D"/>
-                </a:solidFill>
-                <a:latin typeface="Helvetica Neue"/>
-              </a:rPr>
-              <a:t>); geri kazanılan saat ve ek parça hesaplanır.</a:t>
-            </a:r>
-          </a:p>
-          <a:p>
-            <a:pPr>
+              <a:rPr sz="1000" b="1">
+                <a:solidFill>
+                  <a:srgbClr val="FFFFFF"/>
+                </a:solidFill>
+                <a:latin typeface="Helvetica Neue"/>
+              </a:rPr>
+              <a:t>ΔA</a:t>
+            </a:r>
+          </a:p>
+        </p:txBody>
+      </p:sp>
+      <p:sp>
+        <p:nvSpPr>
+          <p:cNvPr id="12" name="Rectangle 11"/>
+          <p:cNvSpPr/>
+          <p:nvPr/>
+        </p:nvSpPr>
+        <p:spPr>
+          <a:xfrm>
+            <a:off x="5532120" y="2148840"/>
+            <a:ext cx="960120" cy="411480"/>
+          </a:xfrm>
+          <a:prstGeom prst="rect">
+            <a:avLst/>
+          </a:prstGeom>
+          <a:solidFill>
+            <a:srgbClr val="1A1F1D"/>
+          </a:solidFill>
+          <a:ln>
+            <a:noFill/>
+          </a:ln>
+          <a:effectLst/>
+        </p:spPr>
+        <p:style>
+          <a:lnRef idx="1">
+            <a:schemeClr val="accent1"/>
+          </a:lnRef>
+          <a:fillRef idx="3">
+            <a:schemeClr val="accent1"/>
+          </a:fillRef>
+          <a:effectRef idx="2">
+            <a:schemeClr val="accent1"/>
+          </a:effectRef>
+          <a:fontRef idx="minor">
+            <a:schemeClr val="lt1"/>
+          </a:fontRef>
+        </p:style>
+        <p:txBody>
+          <a:bodyPr rtlCol="0" anchor="ctr"/>
+          <a:lstStyle/>
+          <a:p>
+            <a:pPr algn="ctr"/>
+          </a:p>
+        </p:txBody>
+      </p:sp>
+      <p:sp>
+        <p:nvSpPr>
+          <p:cNvPr id="13" name="TextBox 12"/>
+          <p:cNvSpPr txBox="1"/>
+          <p:nvPr/>
+        </p:nvSpPr>
+        <p:spPr>
+          <a:xfrm>
+            <a:off x="5623559" y="2258568"/>
+            <a:ext cx="777240" cy="201168"/>
+          </a:xfrm>
+          <a:prstGeom prst="rect">
+            <a:avLst/>
+          </a:prstGeom>
+          <a:noFill/>
+        </p:spPr>
+        <p:txBody>
+          <a:bodyPr wrap="square" anchor="t" lIns="0" rIns="0" tIns="0" bIns="0">
+            <a:spAutoFit/>
+          </a:bodyPr>
+          <a:lstStyle/>
+          <a:p>
+            <a:pPr algn="l">
               <a:lnSpc>
-                <a:spcPct val="116000"/>
+                <a:spcPct val="112000"/>
               </a:lnSpc>
               <a:spcAft>
-                <a:spcPts val="1100"/>
+                <a:spcPts val="800"/>
               </a:spcAft>
             </a:pPr>
             <a:r>
-              <a:rPr sz="1600" b="1">
+              <a:rPr sz="1000" b="1">
+                <a:solidFill>
+                  <a:srgbClr val="FFFFFF"/>
+                </a:solidFill>
+                <a:latin typeface="Helvetica Neue"/>
+              </a:rPr>
+              <a:t>ΔP</a:t>
+            </a:r>
+          </a:p>
+        </p:txBody>
+      </p:sp>
+      <p:sp>
+        <p:nvSpPr>
+          <p:cNvPr id="14" name="Rectangle 13"/>
+          <p:cNvSpPr/>
+          <p:nvPr/>
+        </p:nvSpPr>
+        <p:spPr>
+          <a:xfrm>
+            <a:off x="6492240" y="2148840"/>
+            <a:ext cx="1051560" cy="411480"/>
+          </a:xfrm>
+          <a:prstGeom prst="rect">
+            <a:avLst/>
+          </a:prstGeom>
+          <a:solidFill>
+            <a:srgbClr val="1A1F1D"/>
+          </a:solidFill>
+          <a:ln>
+            <a:noFill/>
+          </a:ln>
+          <a:effectLst/>
+        </p:spPr>
+        <p:style>
+          <a:lnRef idx="1">
+            <a:schemeClr val="accent1"/>
+          </a:lnRef>
+          <a:fillRef idx="3">
+            <a:schemeClr val="accent1"/>
+          </a:fillRef>
+          <a:effectRef idx="2">
+            <a:schemeClr val="accent1"/>
+          </a:effectRef>
+          <a:fontRef idx="minor">
+            <a:schemeClr val="lt1"/>
+          </a:fontRef>
+        </p:style>
+        <p:txBody>
+          <a:bodyPr rtlCol="0" anchor="ctr"/>
+          <a:lstStyle/>
+          <a:p>
+            <a:pPr algn="ctr"/>
+          </a:p>
+        </p:txBody>
+      </p:sp>
+      <p:sp>
+        <p:nvSpPr>
+          <p:cNvPr id="15" name="TextBox 14"/>
+          <p:cNvSpPr txBox="1"/>
+          <p:nvPr/>
+        </p:nvSpPr>
+        <p:spPr>
+          <a:xfrm>
+            <a:off x="6583679" y="2258568"/>
+            <a:ext cx="868680" cy="201168"/>
+          </a:xfrm>
+          <a:prstGeom prst="rect">
+            <a:avLst/>
+          </a:prstGeom>
+          <a:noFill/>
+        </p:spPr>
+        <p:txBody>
+          <a:bodyPr wrap="square" anchor="t" lIns="0" rIns="0" tIns="0" bIns="0">
+            <a:spAutoFit/>
+          </a:bodyPr>
+          <a:lstStyle/>
+          <a:p>
+            <a:pPr algn="l">
+              <a:lnSpc>
+                <a:spcPct val="112000"/>
+              </a:lnSpc>
+              <a:spcAft>
+                <a:spcPts val="800"/>
+              </a:spcAft>
+            </a:pPr>
+            <a:r>
+              <a:rPr sz="1000" b="1">
+                <a:solidFill>
+                  <a:srgbClr val="FFFFFF"/>
+                </a:solidFill>
+                <a:latin typeface="Helvetica Neue"/>
+              </a:rPr>
+              <a:t>ΔOEE</a:t>
+            </a:r>
+          </a:p>
+        </p:txBody>
+      </p:sp>
+      <p:sp>
+        <p:nvSpPr>
+          <p:cNvPr id="16" name="Rectangle 15"/>
+          <p:cNvSpPr/>
+          <p:nvPr/>
+        </p:nvSpPr>
+        <p:spPr>
+          <a:xfrm>
+            <a:off x="7543800" y="2148840"/>
+            <a:ext cx="1097280" cy="411480"/>
+          </a:xfrm>
+          <a:prstGeom prst="rect">
+            <a:avLst/>
+          </a:prstGeom>
+          <a:solidFill>
+            <a:srgbClr val="1A1F1D"/>
+          </a:solidFill>
+          <a:ln>
+            <a:noFill/>
+          </a:ln>
+          <a:effectLst/>
+        </p:spPr>
+        <p:style>
+          <a:lnRef idx="1">
+            <a:schemeClr val="accent1"/>
+          </a:lnRef>
+          <a:fillRef idx="3">
+            <a:schemeClr val="accent1"/>
+          </a:fillRef>
+          <a:effectRef idx="2">
+            <a:schemeClr val="accent1"/>
+          </a:effectRef>
+          <a:fontRef idx="minor">
+            <a:schemeClr val="lt1"/>
+          </a:fontRef>
+        </p:style>
+        <p:txBody>
+          <a:bodyPr rtlCol="0" anchor="ctr"/>
+          <a:lstStyle/>
+          <a:p>
+            <a:pPr algn="ctr"/>
+          </a:p>
+        </p:txBody>
+      </p:sp>
+      <p:sp>
+        <p:nvSpPr>
+          <p:cNvPr id="17" name="TextBox 16"/>
+          <p:cNvSpPr txBox="1"/>
+          <p:nvPr/>
+        </p:nvSpPr>
+        <p:spPr>
+          <a:xfrm>
+            <a:off x="7635240" y="2258568"/>
+            <a:ext cx="914400" cy="201168"/>
+          </a:xfrm>
+          <a:prstGeom prst="rect">
+            <a:avLst/>
+          </a:prstGeom>
+          <a:noFill/>
+        </p:spPr>
+        <p:txBody>
+          <a:bodyPr wrap="square" anchor="t" lIns="0" rIns="0" tIns="0" bIns="0">
+            <a:spAutoFit/>
+          </a:bodyPr>
+          <a:lstStyle/>
+          <a:p>
+            <a:pPr algn="l">
+              <a:lnSpc>
+                <a:spcPct val="112000"/>
+              </a:lnSpc>
+              <a:spcAft>
+                <a:spcPts val="800"/>
+              </a:spcAft>
+            </a:pPr>
+            <a:r>
+              <a:rPr sz="1000" b="1">
+                <a:solidFill>
+                  <a:srgbClr val="FFFFFF"/>
+                </a:solidFill>
+                <a:latin typeface="Helvetica Neue"/>
+              </a:rPr>
+              <a:t>Saat</a:t>
+            </a:r>
+          </a:p>
+        </p:txBody>
+      </p:sp>
+      <p:sp>
+        <p:nvSpPr>
+          <p:cNvPr id="18" name="Rectangle 17"/>
+          <p:cNvSpPr/>
+          <p:nvPr/>
+        </p:nvSpPr>
+        <p:spPr>
+          <a:xfrm>
+            <a:off x="8641080" y="2148840"/>
+            <a:ext cx="1417320" cy="411480"/>
+          </a:xfrm>
+          <a:prstGeom prst="rect">
+            <a:avLst/>
+          </a:prstGeom>
+          <a:solidFill>
+            <a:srgbClr val="1A1F1D"/>
+          </a:solidFill>
+          <a:ln>
+            <a:noFill/>
+          </a:ln>
+          <a:effectLst/>
+        </p:spPr>
+        <p:style>
+          <a:lnRef idx="1">
+            <a:schemeClr val="accent1"/>
+          </a:lnRef>
+          <a:fillRef idx="3">
+            <a:schemeClr val="accent1"/>
+          </a:fillRef>
+          <a:effectRef idx="2">
+            <a:schemeClr val="accent1"/>
+          </a:effectRef>
+          <a:fontRef idx="minor">
+            <a:schemeClr val="lt1"/>
+          </a:fontRef>
+        </p:style>
+        <p:txBody>
+          <a:bodyPr rtlCol="0" anchor="ctr"/>
+          <a:lstStyle/>
+          <a:p>
+            <a:pPr algn="ctr"/>
+          </a:p>
+        </p:txBody>
+      </p:sp>
+      <p:sp>
+        <p:nvSpPr>
+          <p:cNvPr id="19" name="TextBox 18"/>
+          <p:cNvSpPr txBox="1"/>
+          <p:nvPr/>
+        </p:nvSpPr>
+        <p:spPr>
+          <a:xfrm>
+            <a:off x="8732519" y="2258568"/>
+            <a:ext cx="1234440" cy="201168"/>
+          </a:xfrm>
+          <a:prstGeom prst="rect">
+            <a:avLst/>
+          </a:prstGeom>
+          <a:noFill/>
+        </p:spPr>
+        <p:txBody>
+          <a:bodyPr wrap="square" anchor="t" lIns="0" rIns="0" tIns="0" bIns="0">
+            <a:spAutoFit/>
+          </a:bodyPr>
+          <a:lstStyle/>
+          <a:p>
+            <a:pPr algn="l">
+              <a:lnSpc>
+                <a:spcPct val="112000"/>
+              </a:lnSpc>
+              <a:spcAft>
+                <a:spcPts val="800"/>
+              </a:spcAft>
+            </a:pPr>
+            <a:r>
+              <a:rPr sz="1000" b="1">
+                <a:solidFill>
+                  <a:srgbClr val="FFFFFF"/>
+                </a:solidFill>
+                <a:latin typeface="Helvetica Neue"/>
+              </a:rPr>
+              <a:t>Net €</a:t>
+            </a:r>
+          </a:p>
+        </p:txBody>
+      </p:sp>
+      <p:sp>
+        <p:nvSpPr>
+          <p:cNvPr id="20" name="Rectangle 19"/>
+          <p:cNvSpPr/>
+          <p:nvPr/>
+        </p:nvSpPr>
+        <p:spPr>
+          <a:xfrm>
+            <a:off x="777240" y="2606040"/>
+            <a:ext cx="3794760" cy="548640"/>
+          </a:xfrm>
+          <a:prstGeom prst="rect">
+            <a:avLst/>
+          </a:prstGeom>
+          <a:solidFill>
+            <a:srgbClr val="ECF4EF"/>
+          </a:solidFill>
+          <a:ln w="8890">
+            <a:solidFill>
+              <a:srgbClr val="D9DFDB"/>
+            </a:solidFill>
+          </a:ln>
+          <a:effectLst/>
+        </p:spPr>
+        <p:style>
+          <a:lnRef idx="1">
+            <a:schemeClr val="accent1"/>
+          </a:lnRef>
+          <a:fillRef idx="3">
+            <a:schemeClr val="accent1"/>
+          </a:fillRef>
+          <a:effectRef idx="2">
+            <a:schemeClr val="accent1"/>
+          </a:effectRef>
+          <a:fontRef idx="minor">
+            <a:schemeClr val="lt1"/>
+          </a:fontRef>
+        </p:style>
+        <p:txBody>
+          <a:bodyPr rtlCol="0" anchor="ctr"/>
+          <a:lstStyle/>
+          <a:p>
+            <a:pPr algn="ctr"/>
+          </a:p>
+        </p:txBody>
+      </p:sp>
+      <p:sp>
+        <p:nvSpPr>
+          <p:cNvPr id="21" name="TextBox 20"/>
+          <p:cNvSpPr txBox="1"/>
+          <p:nvPr/>
+        </p:nvSpPr>
+        <p:spPr>
+          <a:xfrm>
+            <a:off x="868680" y="2743200"/>
+            <a:ext cx="3611880" cy="246888"/>
+          </a:xfrm>
+          <a:prstGeom prst="rect">
+            <a:avLst/>
+          </a:prstGeom>
+          <a:noFill/>
+        </p:spPr>
+        <p:txBody>
+          <a:bodyPr wrap="square" anchor="t" lIns="0" rIns="0" tIns="0" bIns="0">
+            <a:spAutoFit/>
+          </a:bodyPr>
+          <a:lstStyle/>
+          <a:p>
+            <a:pPr algn="l">
+              <a:lnSpc>
+                <a:spcPct val="112000"/>
+              </a:lnSpc>
+              <a:spcAft>
+                <a:spcPts val="800"/>
+              </a:spcAft>
+            </a:pPr>
+            <a:r>
+              <a:rPr sz="1050" b="1">
                 <a:solidFill>
                   <a:srgbClr val="127145"/>
                 </a:solidFill>
                 <a:latin typeface="Helvetica Neue"/>
               </a:rPr>
-              <a:t>—  </a:t>
-            </a:r>
-            <a:r>
-              <a:rPr sz="1600" b="0">
+              <a:t>S1 · Makine 1 · En büyük plansız duruş kalemi -%30</a:t>
+            </a:r>
+          </a:p>
+        </p:txBody>
+      </p:sp>
+      <p:sp>
+        <p:nvSpPr>
+          <p:cNvPr id="22" name="Rectangle 21"/>
+          <p:cNvSpPr/>
+          <p:nvPr/>
+        </p:nvSpPr>
+        <p:spPr>
+          <a:xfrm>
+            <a:off x="4572000" y="2606040"/>
+            <a:ext cx="960120" cy="548640"/>
+          </a:xfrm>
+          <a:prstGeom prst="rect">
+            <a:avLst/>
+          </a:prstGeom>
+          <a:solidFill>
+            <a:srgbClr val="ECF4EF"/>
+          </a:solidFill>
+          <a:ln w="8890">
+            <a:solidFill>
+              <a:srgbClr val="D9DFDB"/>
+            </a:solidFill>
+          </a:ln>
+          <a:effectLst/>
+        </p:spPr>
+        <p:style>
+          <a:lnRef idx="1">
+            <a:schemeClr val="accent1"/>
+          </a:lnRef>
+          <a:fillRef idx="3">
+            <a:schemeClr val="accent1"/>
+          </a:fillRef>
+          <a:effectRef idx="2">
+            <a:schemeClr val="accent1"/>
+          </a:effectRef>
+          <a:fontRef idx="minor">
+            <a:schemeClr val="lt1"/>
+          </a:fontRef>
+        </p:style>
+        <p:txBody>
+          <a:bodyPr rtlCol="0" anchor="ctr"/>
+          <a:lstStyle/>
+          <a:p>
+            <a:pPr algn="ctr"/>
+          </a:p>
+        </p:txBody>
+      </p:sp>
+      <p:sp>
+        <p:nvSpPr>
+          <p:cNvPr id="23" name="TextBox 22"/>
+          <p:cNvSpPr txBox="1"/>
+          <p:nvPr/>
+        </p:nvSpPr>
+        <p:spPr>
+          <a:xfrm>
+            <a:off x="4663440" y="2743200"/>
+            <a:ext cx="777240" cy="246888"/>
+          </a:xfrm>
+          <a:prstGeom prst="rect">
+            <a:avLst/>
+          </a:prstGeom>
+          <a:noFill/>
+        </p:spPr>
+        <p:txBody>
+          <a:bodyPr wrap="square" anchor="t" lIns="0" rIns="0" tIns="0" bIns="0">
+            <a:spAutoFit/>
+          </a:bodyPr>
+          <a:lstStyle/>
+          <a:p>
+            <a:pPr algn="r">
+              <a:lnSpc>
+                <a:spcPct val="112000"/>
+              </a:lnSpc>
+              <a:spcAft>
+                <a:spcPts val="800"/>
+              </a:spcAft>
+            </a:pPr>
+            <a:r>
+              <a:rPr sz="1050" b="1">
+                <a:solidFill>
+                  <a:srgbClr val="127145"/>
+                </a:solidFill>
+                <a:latin typeface="Helvetica Neue"/>
+              </a:rPr>
+              <a:t>26,85</a:t>
+            </a:r>
+          </a:p>
+        </p:txBody>
+      </p:sp>
+      <p:sp>
+        <p:nvSpPr>
+          <p:cNvPr id="24" name="Rectangle 23"/>
+          <p:cNvSpPr/>
+          <p:nvPr/>
+        </p:nvSpPr>
+        <p:spPr>
+          <a:xfrm>
+            <a:off x="5532120" y="2606040"/>
+            <a:ext cx="960120" cy="548640"/>
+          </a:xfrm>
+          <a:prstGeom prst="rect">
+            <a:avLst/>
+          </a:prstGeom>
+          <a:solidFill>
+            <a:srgbClr val="ECF4EF"/>
+          </a:solidFill>
+          <a:ln w="8890">
+            <a:solidFill>
+              <a:srgbClr val="D9DFDB"/>
+            </a:solidFill>
+          </a:ln>
+          <a:effectLst/>
+        </p:spPr>
+        <p:style>
+          <a:lnRef idx="1">
+            <a:schemeClr val="accent1"/>
+          </a:lnRef>
+          <a:fillRef idx="3">
+            <a:schemeClr val="accent1"/>
+          </a:fillRef>
+          <a:effectRef idx="2">
+            <a:schemeClr val="accent1"/>
+          </a:effectRef>
+          <a:fontRef idx="minor">
+            <a:schemeClr val="lt1"/>
+          </a:fontRef>
+        </p:style>
+        <p:txBody>
+          <a:bodyPr rtlCol="0" anchor="ctr"/>
+          <a:lstStyle/>
+          <a:p>
+            <a:pPr algn="ctr"/>
+          </a:p>
+        </p:txBody>
+      </p:sp>
+      <p:sp>
+        <p:nvSpPr>
+          <p:cNvPr id="25" name="TextBox 24"/>
+          <p:cNvSpPr txBox="1"/>
+          <p:nvPr/>
+        </p:nvSpPr>
+        <p:spPr>
+          <a:xfrm>
+            <a:off x="5623559" y="2743200"/>
+            <a:ext cx="777240" cy="246888"/>
+          </a:xfrm>
+          <a:prstGeom prst="rect">
+            <a:avLst/>
+          </a:prstGeom>
+          <a:noFill/>
+        </p:spPr>
+        <p:txBody>
+          <a:bodyPr wrap="square" anchor="t" lIns="0" rIns="0" tIns="0" bIns="0">
+            <a:spAutoFit/>
+          </a:bodyPr>
+          <a:lstStyle/>
+          <a:p>
+            <a:pPr algn="r">
+              <a:lnSpc>
+                <a:spcPct val="112000"/>
+              </a:lnSpc>
+              <a:spcAft>
+                <a:spcPts val="800"/>
+              </a:spcAft>
+            </a:pPr>
+            <a:r>
+              <a:rPr sz="1050" b="1">
+                <a:solidFill>
+                  <a:srgbClr val="127145"/>
+                </a:solidFill>
+                <a:latin typeface="Helvetica Neue"/>
+              </a:rPr>
+              <a:t>0,00</a:t>
+            </a:r>
+          </a:p>
+        </p:txBody>
+      </p:sp>
+      <p:sp>
+        <p:nvSpPr>
+          <p:cNvPr id="26" name="Rectangle 25"/>
+          <p:cNvSpPr/>
+          <p:nvPr/>
+        </p:nvSpPr>
+        <p:spPr>
+          <a:xfrm>
+            <a:off x="6492240" y="2606040"/>
+            <a:ext cx="1051560" cy="548640"/>
+          </a:xfrm>
+          <a:prstGeom prst="rect">
+            <a:avLst/>
+          </a:prstGeom>
+          <a:solidFill>
+            <a:srgbClr val="ECF4EF"/>
+          </a:solidFill>
+          <a:ln w="8890">
+            <a:solidFill>
+              <a:srgbClr val="D9DFDB"/>
+            </a:solidFill>
+          </a:ln>
+          <a:effectLst/>
+        </p:spPr>
+        <p:style>
+          <a:lnRef idx="1">
+            <a:schemeClr val="accent1"/>
+          </a:lnRef>
+          <a:fillRef idx="3">
+            <a:schemeClr val="accent1"/>
+          </a:fillRef>
+          <a:effectRef idx="2">
+            <a:schemeClr val="accent1"/>
+          </a:effectRef>
+          <a:fontRef idx="minor">
+            <a:schemeClr val="lt1"/>
+          </a:fontRef>
+        </p:style>
+        <p:txBody>
+          <a:bodyPr rtlCol="0" anchor="ctr"/>
+          <a:lstStyle/>
+          <a:p>
+            <a:pPr algn="ctr"/>
+          </a:p>
+        </p:txBody>
+      </p:sp>
+      <p:sp>
+        <p:nvSpPr>
+          <p:cNvPr id="27" name="TextBox 26"/>
+          <p:cNvSpPr txBox="1"/>
+          <p:nvPr/>
+        </p:nvSpPr>
+        <p:spPr>
+          <a:xfrm>
+            <a:off x="6583679" y="2743200"/>
+            <a:ext cx="868680" cy="246888"/>
+          </a:xfrm>
+          <a:prstGeom prst="rect">
+            <a:avLst/>
+          </a:prstGeom>
+          <a:noFill/>
+        </p:spPr>
+        <p:txBody>
+          <a:bodyPr wrap="square" anchor="t" lIns="0" rIns="0" tIns="0" bIns="0">
+            <a:spAutoFit/>
+          </a:bodyPr>
+          <a:lstStyle/>
+          <a:p>
+            <a:pPr algn="r">
+              <a:lnSpc>
+                <a:spcPct val="112000"/>
+              </a:lnSpc>
+              <a:spcAft>
+                <a:spcPts val="800"/>
+              </a:spcAft>
+            </a:pPr>
+            <a:r>
+              <a:rPr sz="1050" b="1">
+                <a:solidFill>
+                  <a:srgbClr val="127145"/>
+                </a:solidFill>
+                <a:latin typeface="Helvetica Neue"/>
+              </a:rPr>
+              <a:t>26,85</a:t>
+            </a:r>
+          </a:p>
+        </p:txBody>
+      </p:sp>
+      <p:sp>
+        <p:nvSpPr>
+          <p:cNvPr id="28" name="Rectangle 27"/>
+          <p:cNvSpPr/>
+          <p:nvPr/>
+        </p:nvSpPr>
+        <p:spPr>
+          <a:xfrm>
+            <a:off x="7543800" y="2606040"/>
+            <a:ext cx="1097280" cy="548640"/>
+          </a:xfrm>
+          <a:prstGeom prst="rect">
+            <a:avLst/>
+          </a:prstGeom>
+          <a:solidFill>
+            <a:srgbClr val="ECF4EF"/>
+          </a:solidFill>
+          <a:ln w="8890">
+            <a:solidFill>
+              <a:srgbClr val="D9DFDB"/>
+            </a:solidFill>
+          </a:ln>
+          <a:effectLst/>
+        </p:spPr>
+        <p:style>
+          <a:lnRef idx="1">
+            <a:schemeClr val="accent1"/>
+          </a:lnRef>
+          <a:fillRef idx="3">
+            <a:schemeClr val="accent1"/>
+          </a:fillRef>
+          <a:effectRef idx="2">
+            <a:schemeClr val="accent1"/>
+          </a:effectRef>
+          <a:fontRef idx="minor">
+            <a:schemeClr val="lt1"/>
+          </a:fontRef>
+        </p:style>
+        <p:txBody>
+          <a:bodyPr rtlCol="0" anchor="ctr"/>
+          <a:lstStyle/>
+          <a:p>
+            <a:pPr algn="ctr"/>
+          </a:p>
+        </p:txBody>
+      </p:sp>
+      <p:sp>
+        <p:nvSpPr>
+          <p:cNvPr id="29" name="TextBox 28"/>
+          <p:cNvSpPr txBox="1"/>
+          <p:nvPr/>
+        </p:nvSpPr>
+        <p:spPr>
+          <a:xfrm>
+            <a:off x="7635240" y="2743200"/>
+            <a:ext cx="914400" cy="246888"/>
+          </a:xfrm>
+          <a:prstGeom prst="rect">
+            <a:avLst/>
+          </a:prstGeom>
+          <a:noFill/>
+        </p:spPr>
+        <p:txBody>
+          <a:bodyPr wrap="square" anchor="t" lIns="0" rIns="0" tIns="0" bIns="0">
+            <a:spAutoFit/>
+          </a:bodyPr>
+          <a:lstStyle/>
+          <a:p>
+            <a:pPr algn="r">
+              <a:lnSpc>
+                <a:spcPct val="112000"/>
+              </a:lnSpc>
+              <a:spcAft>
+                <a:spcPts val="800"/>
+              </a:spcAft>
+            </a:pPr>
+            <a:r>
+              <a:rPr sz="1050" b="1">
+                <a:solidFill>
+                  <a:srgbClr val="127145"/>
+                </a:solidFill>
+                <a:latin typeface="Helvetica Neue"/>
+              </a:rPr>
+              <a:t>933</a:t>
+            </a:r>
+          </a:p>
+        </p:txBody>
+      </p:sp>
+      <p:sp>
+        <p:nvSpPr>
+          <p:cNvPr id="30" name="Rectangle 29"/>
+          <p:cNvSpPr/>
+          <p:nvPr/>
+        </p:nvSpPr>
+        <p:spPr>
+          <a:xfrm>
+            <a:off x="8641080" y="2606040"/>
+            <a:ext cx="1417320" cy="548640"/>
+          </a:xfrm>
+          <a:prstGeom prst="rect">
+            <a:avLst/>
+          </a:prstGeom>
+          <a:solidFill>
+            <a:srgbClr val="ECF4EF"/>
+          </a:solidFill>
+          <a:ln w="8890">
+            <a:solidFill>
+              <a:srgbClr val="D9DFDB"/>
+            </a:solidFill>
+          </a:ln>
+          <a:effectLst/>
+        </p:spPr>
+        <p:style>
+          <a:lnRef idx="1">
+            <a:schemeClr val="accent1"/>
+          </a:lnRef>
+          <a:fillRef idx="3">
+            <a:schemeClr val="accent1"/>
+          </a:fillRef>
+          <a:effectRef idx="2">
+            <a:schemeClr val="accent1"/>
+          </a:effectRef>
+          <a:fontRef idx="minor">
+            <a:schemeClr val="lt1"/>
+          </a:fontRef>
+        </p:style>
+        <p:txBody>
+          <a:bodyPr rtlCol="0" anchor="ctr"/>
+          <a:lstStyle/>
+          <a:p>
+            <a:pPr algn="ctr"/>
+          </a:p>
+        </p:txBody>
+      </p:sp>
+      <p:sp>
+        <p:nvSpPr>
+          <p:cNvPr id="31" name="TextBox 30"/>
+          <p:cNvSpPr txBox="1"/>
+          <p:nvPr/>
+        </p:nvSpPr>
+        <p:spPr>
+          <a:xfrm>
+            <a:off x="8732519" y="2743200"/>
+            <a:ext cx="1234440" cy="246888"/>
+          </a:xfrm>
+          <a:prstGeom prst="rect">
+            <a:avLst/>
+          </a:prstGeom>
+          <a:noFill/>
+        </p:spPr>
+        <p:txBody>
+          <a:bodyPr wrap="square" anchor="t" lIns="0" rIns="0" tIns="0" bIns="0">
+            <a:spAutoFit/>
+          </a:bodyPr>
+          <a:lstStyle/>
+          <a:p>
+            <a:pPr algn="r">
+              <a:lnSpc>
+                <a:spcPct val="112000"/>
+              </a:lnSpc>
+              <a:spcAft>
+                <a:spcPts val="800"/>
+              </a:spcAft>
+            </a:pPr>
+            <a:r>
+              <a:rPr sz="1050" b="1">
+                <a:solidFill>
+                  <a:srgbClr val="127145"/>
+                </a:solidFill>
+                <a:latin typeface="Helvetica Neue"/>
+              </a:rPr>
+              <a:t>10,016</a:t>
+            </a:r>
+          </a:p>
+        </p:txBody>
+      </p:sp>
+      <p:sp>
+        <p:nvSpPr>
+          <p:cNvPr id="32" name="Rectangle 31"/>
+          <p:cNvSpPr/>
+          <p:nvPr/>
+        </p:nvSpPr>
+        <p:spPr>
+          <a:xfrm>
+            <a:off x="777240" y="3227832"/>
+            <a:ext cx="3794760" cy="548640"/>
+          </a:xfrm>
+          <a:prstGeom prst="rect">
+            <a:avLst/>
+          </a:prstGeom>
+          <a:solidFill>
+            <a:srgbClr val="FFFFFF"/>
+          </a:solidFill>
+          <a:ln w="8890">
+            <a:solidFill>
+              <a:srgbClr val="D9DFDB"/>
+            </a:solidFill>
+          </a:ln>
+          <a:effectLst/>
+        </p:spPr>
+        <p:style>
+          <a:lnRef idx="1">
+            <a:schemeClr val="accent1"/>
+          </a:lnRef>
+          <a:fillRef idx="3">
+            <a:schemeClr val="accent1"/>
+          </a:fillRef>
+          <a:effectRef idx="2">
+            <a:schemeClr val="accent1"/>
+          </a:effectRef>
+          <a:fontRef idx="minor">
+            <a:schemeClr val="lt1"/>
+          </a:fontRef>
+        </p:style>
+        <p:txBody>
+          <a:bodyPr rtlCol="0" anchor="ctr"/>
+          <a:lstStyle/>
+          <a:p>
+            <a:pPr algn="ctr"/>
+          </a:p>
+        </p:txBody>
+      </p:sp>
+      <p:sp>
+        <p:nvSpPr>
+          <p:cNvPr id="33" name="TextBox 32"/>
+          <p:cNvSpPr txBox="1"/>
+          <p:nvPr/>
+        </p:nvSpPr>
+        <p:spPr>
+          <a:xfrm>
+            <a:off x="868680" y="3364992"/>
+            <a:ext cx="3611880" cy="246888"/>
+          </a:xfrm>
+          <a:prstGeom prst="rect">
+            <a:avLst/>
+          </a:prstGeom>
+          <a:noFill/>
+        </p:spPr>
+        <p:txBody>
+          <a:bodyPr wrap="square" anchor="t" lIns="0" rIns="0" tIns="0" bIns="0">
+            <a:spAutoFit/>
+          </a:bodyPr>
+          <a:lstStyle/>
+          <a:p>
+            <a:pPr algn="l">
+              <a:lnSpc>
+                <a:spcPct val="112000"/>
+              </a:lnSpc>
+              <a:spcAft>
+                <a:spcPts val="800"/>
+              </a:spcAft>
+            </a:pPr>
+            <a:r>
+              <a:rPr sz="1050" b="0">
                 <a:solidFill>
                   <a:srgbClr val="1A1F1D"/>
                 </a:solidFill>
                 <a:latin typeface="Helvetica Neue"/>
               </a:rPr>
-              <a:t>Net fayda ve geri ödeme süresi çıkarılır; kaydırıcı ile canlı güncellenir.</a:t>
-            </a:r>
-          </a:p>
-        </p:txBody>
-      </p:sp>
-      <p:sp>
-        <p:nvSpPr>
-          <p:cNvPr id="9" name="Rectangle 8"/>
+              <a:t>S2 · Makine 2 · 8 saat plansız -&gt; planlı bakım</a:t>
+            </a:r>
+          </a:p>
+        </p:txBody>
+      </p:sp>
+      <p:sp>
+        <p:nvSpPr>
+          <p:cNvPr id="34" name="Rectangle 33"/>
           <p:cNvSpPr/>
           <p:nvPr/>
         </p:nvSpPr>
         <p:spPr>
           <a:xfrm>
-            <a:off x="777240" y="4846320"/>
-            <a:ext cx="10637215" cy="914400"/>
+            <a:off x="4572000" y="3227832"/>
+            <a:ext cx="960120" cy="548640"/>
+          </a:xfrm>
+          <a:prstGeom prst="rect">
+            <a:avLst/>
+          </a:prstGeom>
+          <a:solidFill>
+            <a:srgbClr val="FFFFFF"/>
+          </a:solidFill>
+          <a:ln w="8890">
+            <a:solidFill>
+              <a:srgbClr val="D9DFDB"/>
+            </a:solidFill>
+          </a:ln>
+          <a:effectLst/>
+        </p:spPr>
+        <p:style>
+          <a:lnRef idx="1">
+            <a:schemeClr val="accent1"/>
+          </a:lnRef>
+          <a:fillRef idx="3">
+            <a:schemeClr val="accent1"/>
+          </a:fillRef>
+          <a:effectRef idx="2">
+            <a:schemeClr val="accent1"/>
+          </a:effectRef>
+          <a:fontRef idx="minor">
+            <a:schemeClr val="lt1"/>
+          </a:fontRef>
+        </p:style>
+        <p:txBody>
+          <a:bodyPr rtlCol="0" anchor="ctr"/>
+          <a:lstStyle/>
+          <a:p>
+            <a:pPr algn="ctr"/>
+          </a:p>
+        </p:txBody>
+      </p:sp>
+      <p:sp>
+        <p:nvSpPr>
+          <p:cNvPr id="35" name="TextBox 34"/>
+          <p:cNvSpPr txBox="1"/>
+          <p:nvPr/>
+        </p:nvSpPr>
+        <p:spPr>
+          <a:xfrm>
+            <a:off x="4663440" y="3364992"/>
+            <a:ext cx="777240" cy="246888"/>
+          </a:xfrm>
+          <a:prstGeom prst="rect">
+            <a:avLst/>
+          </a:prstGeom>
+          <a:noFill/>
+        </p:spPr>
+        <p:txBody>
+          <a:bodyPr wrap="square" anchor="t" lIns="0" rIns="0" tIns="0" bIns="0">
+            <a:spAutoFit/>
+          </a:bodyPr>
+          <a:lstStyle/>
+          <a:p>
+            <a:pPr algn="r">
+              <a:lnSpc>
+                <a:spcPct val="112000"/>
+              </a:lnSpc>
+              <a:spcAft>
+                <a:spcPts val="800"/>
+              </a:spcAft>
+            </a:pPr>
+            <a:r>
+              <a:rPr sz="1050" b="0">
+                <a:solidFill>
+                  <a:srgbClr val="1A1F1D"/>
+                </a:solidFill>
+                <a:latin typeface="Helvetica Neue"/>
+              </a:rPr>
+              <a:t>0,32</a:t>
+            </a:r>
+          </a:p>
+        </p:txBody>
+      </p:sp>
+      <p:sp>
+        <p:nvSpPr>
+          <p:cNvPr id="36" name="Rectangle 35"/>
+          <p:cNvSpPr/>
+          <p:nvPr/>
+        </p:nvSpPr>
+        <p:spPr>
+          <a:xfrm>
+            <a:off x="5532120" y="3227832"/>
+            <a:ext cx="960120" cy="548640"/>
+          </a:xfrm>
+          <a:prstGeom prst="rect">
+            <a:avLst/>
+          </a:prstGeom>
+          <a:solidFill>
+            <a:srgbClr val="FFFFFF"/>
+          </a:solidFill>
+          <a:ln w="8890">
+            <a:solidFill>
+              <a:srgbClr val="D9DFDB"/>
+            </a:solidFill>
+          </a:ln>
+          <a:effectLst/>
+        </p:spPr>
+        <p:style>
+          <a:lnRef idx="1">
+            <a:schemeClr val="accent1"/>
+          </a:lnRef>
+          <a:fillRef idx="3">
+            <a:schemeClr val="accent1"/>
+          </a:fillRef>
+          <a:effectRef idx="2">
+            <a:schemeClr val="accent1"/>
+          </a:effectRef>
+          <a:fontRef idx="minor">
+            <a:schemeClr val="lt1"/>
+          </a:fontRef>
+        </p:style>
+        <p:txBody>
+          <a:bodyPr rtlCol="0" anchor="ctr"/>
+          <a:lstStyle/>
+          <a:p>
+            <a:pPr algn="ctr"/>
+          </a:p>
+        </p:txBody>
+      </p:sp>
+      <p:sp>
+        <p:nvSpPr>
+          <p:cNvPr id="37" name="TextBox 36"/>
+          <p:cNvSpPr txBox="1"/>
+          <p:nvPr/>
+        </p:nvSpPr>
+        <p:spPr>
+          <a:xfrm>
+            <a:off x="5623559" y="3364992"/>
+            <a:ext cx="777240" cy="246888"/>
+          </a:xfrm>
+          <a:prstGeom prst="rect">
+            <a:avLst/>
+          </a:prstGeom>
+          <a:noFill/>
+        </p:spPr>
+        <p:txBody>
+          <a:bodyPr wrap="square" anchor="t" lIns="0" rIns="0" tIns="0" bIns="0">
+            <a:spAutoFit/>
+          </a:bodyPr>
+          <a:lstStyle/>
+          <a:p>
+            <a:pPr algn="r">
+              <a:lnSpc>
+                <a:spcPct val="112000"/>
+              </a:lnSpc>
+              <a:spcAft>
+                <a:spcPts val="800"/>
+              </a:spcAft>
+            </a:pPr>
+            <a:r>
+              <a:rPr sz="1050" b="0">
+                <a:solidFill>
+                  <a:srgbClr val="1A1F1D"/>
+                </a:solidFill>
+                <a:latin typeface="Helvetica Neue"/>
+              </a:rPr>
+              <a:t>0,00</a:t>
+            </a:r>
+          </a:p>
+        </p:txBody>
+      </p:sp>
+      <p:sp>
+        <p:nvSpPr>
+          <p:cNvPr id="38" name="Rectangle 37"/>
+          <p:cNvSpPr/>
+          <p:nvPr/>
+        </p:nvSpPr>
+        <p:spPr>
+          <a:xfrm>
+            <a:off x="6492240" y="3227832"/>
+            <a:ext cx="1051560" cy="548640"/>
+          </a:xfrm>
+          <a:prstGeom prst="rect">
+            <a:avLst/>
+          </a:prstGeom>
+          <a:solidFill>
+            <a:srgbClr val="FFFFFF"/>
+          </a:solidFill>
+          <a:ln w="8890">
+            <a:solidFill>
+              <a:srgbClr val="D9DFDB"/>
+            </a:solidFill>
+          </a:ln>
+          <a:effectLst/>
+        </p:spPr>
+        <p:style>
+          <a:lnRef idx="1">
+            <a:schemeClr val="accent1"/>
+          </a:lnRef>
+          <a:fillRef idx="3">
+            <a:schemeClr val="accent1"/>
+          </a:fillRef>
+          <a:effectRef idx="2">
+            <a:schemeClr val="accent1"/>
+          </a:effectRef>
+          <a:fontRef idx="minor">
+            <a:schemeClr val="lt1"/>
+          </a:fontRef>
+        </p:style>
+        <p:txBody>
+          <a:bodyPr rtlCol="0" anchor="ctr"/>
+          <a:lstStyle/>
+          <a:p>
+            <a:pPr algn="ctr"/>
+          </a:p>
+        </p:txBody>
+      </p:sp>
+      <p:sp>
+        <p:nvSpPr>
+          <p:cNvPr id="39" name="TextBox 38"/>
+          <p:cNvSpPr txBox="1"/>
+          <p:nvPr/>
+        </p:nvSpPr>
+        <p:spPr>
+          <a:xfrm>
+            <a:off x="6583679" y="3364992"/>
+            <a:ext cx="868680" cy="246888"/>
+          </a:xfrm>
+          <a:prstGeom prst="rect">
+            <a:avLst/>
+          </a:prstGeom>
+          <a:noFill/>
+        </p:spPr>
+        <p:txBody>
+          <a:bodyPr wrap="square" anchor="t" lIns="0" rIns="0" tIns="0" bIns="0">
+            <a:spAutoFit/>
+          </a:bodyPr>
+          <a:lstStyle/>
+          <a:p>
+            <a:pPr algn="r">
+              <a:lnSpc>
+                <a:spcPct val="112000"/>
+              </a:lnSpc>
+              <a:spcAft>
+                <a:spcPts val="800"/>
+              </a:spcAft>
+            </a:pPr>
+            <a:r>
+              <a:rPr sz="1050" b="0">
+                <a:solidFill>
+                  <a:srgbClr val="1A1F1D"/>
+                </a:solidFill>
+                <a:latin typeface="Helvetica Neue"/>
+              </a:rPr>
+              <a:t>0,32</a:t>
+            </a:r>
+          </a:p>
+        </p:txBody>
+      </p:sp>
+      <p:sp>
+        <p:nvSpPr>
+          <p:cNvPr id="40" name="Rectangle 39"/>
+          <p:cNvSpPr/>
+          <p:nvPr/>
+        </p:nvSpPr>
+        <p:spPr>
+          <a:xfrm>
+            <a:off x="7543800" y="3227832"/>
+            <a:ext cx="1097280" cy="548640"/>
+          </a:xfrm>
+          <a:prstGeom prst="rect">
+            <a:avLst/>
+          </a:prstGeom>
+          <a:solidFill>
+            <a:srgbClr val="FFFFFF"/>
+          </a:solidFill>
+          <a:ln w="8890">
+            <a:solidFill>
+              <a:srgbClr val="D9DFDB"/>
+            </a:solidFill>
+          </a:ln>
+          <a:effectLst/>
+        </p:spPr>
+        <p:style>
+          <a:lnRef idx="1">
+            <a:schemeClr val="accent1"/>
+          </a:lnRef>
+          <a:fillRef idx="3">
+            <a:schemeClr val="accent1"/>
+          </a:fillRef>
+          <a:effectRef idx="2">
+            <a:schemeClr val="accent1"/>
+          </a:effectRef>
+          <a:fontRef idx="minor">
+            <a:schemeClr val="lt1"/>
+          </a:fontRef>
+        </p:style>
+        <p:txBody>
+          <a:bodyPr rtlCol="0" anchor="ctr"/>
+          <a:lstStyle/>
+          <a:p>
+            <a:pPr algn="ctr"/>
+          </a:p>
+        </p:txBody>
+      </p:sp>
+      <p:sp>
+        <p:nvSpPr>
+          <p:cNvPr id="41" name="TextBox 40"/>
+          <p:cNvSpPr txBox="1"/>
+          <p:nvPr/>
+        </p:nvSpPr>
+        <p:spPr>
+          <a:xfrm>
+            <a:off x="7635240" y="3364992"/>
+            <a:ext cx="914400" cy="246888"/>
+          </a:xfrm>
+          <a:prstGeom prst="rect">
+            <a:avLst/>
+          </a:prstGeom>
+          <a:noFill/>
+        </p:spPr>
+        <p:txBody>
+          <a:bodyPr wrap="square" anchor="t" lIns="0" rIns="0" tIns="0" bIns="0">
+            <a:spAutoFit/>
+          </a:bodyPr>
+          <a:lstStyle/>
+          <a:p>
+            <a:pPr algn="r">
+              <a:lnSpc>
+                <a:spcPct val="112000"/>
+              </a:lnSpc>
+              <a:spcAft>
+                <a:spcPts val="800"/>
+              </a:spcAft>
+            </a:pPr>
+            <a:r>
+              <a:rPr sz="1050" b="0">
+                <a:solidFill>
+                  <a:srgbClr val="1A1F1D"/>
+                </a:solidFill>
+                <a:latin typeface="Helvetica Neue"/>
+              </a:rPr>
+              <a:t>0</a:t>
+            </a:r>
+          </a:p>
+        </p:txBody>
+      </p:sp>
+      <p:sp>
+        <p:nvSpPr>
+          <p:cNvPr id="42" name="Rectangle 41"/>
+          <p:cNvSpPr/>
+          <p:nvPr/>
+        </p:nvSpPr>
+        <p:spPr>
+          <a:xfrm>
+            <a:off x="8641080" y="3227832"/>
+            <a:ext cx="1417320" cy="548640"/>
+          </a:xfrm>
+          <a:prstGeom prst="rect">
+            <a:avLst/>
+          </a:prstGeom>
+          <a:solidFill>
+            <a:srgbClr val="FFFFFF"/>
+          </a:solidFill>
+          <a:ln w="8890">
+            <a:solidFill>
+              <a:srgbClr val="D9DFDB"/>
+            </a:solidFill>
+          </a:ln>
+          <a:effectLst/>
+        </p:spPr>
+        <p:style>
+          <a:lnRef idx="1">
+            <a:schemeClr val="accent1"/>
+          </a:lnRef>
+          <a:fillRef idx="3">
+            <a:schemeClr val="accent1"/>
+          </a:fillRef>
+          <a:effectRef idx="2">
+            <a:schemeClr val="accent1"/>
+          </a:effectRef>
+          <a:fontRef idx="minor">
+            <a:schemeClr val="lt1"/>
+          </a:fontRef>
+        </p:style>
+        <p:txBody>
+          <a:bodyPr rtlCol="0" anchor="ctr"/>
+          <a:lstStyle/>
+          <a:p>
+            <a:pPr algn="ctr"/>
+          </a:p>
+        </p:txBody>
+      </p:sp>
+      <p:sp>
+        <p:nvSpPr>
+          <p:cNvPr id="43" name="TextBox 42"/>
+          <p:cNvSpPr txBox="1"/>
+          <p:nvPr/>
+        </p:nvSpPr>
+        <p:spPr>
+          <a:xfrm>
+            <a:off x="8732519" y="3364992"/>
+            <a:ext cx="1234440" cy="246888"/>
+          </a:xfrm>
+          <a:prstGeom prst="rect">
+            <a:avLst/>
+          </a:prstGeom>
+          <a:noFill/>
+        </p:spPr>
+        <p:txBody>
+          <a:bodyPr wrap="square" anchor="t" lIns="0" rIns="0" tIns="0" bIns="0">
+            <a:spAutoFit/>
+          </a:bodyPr>
+          <a:lstStyle/>
+          <a:p>
+            <a:pPr algn="r">
+              <a:lnSpc>
+                <a:spcPct val="112000"/>
+              </a:lnSpc>
+              <a:spcAft>
+                <a:spcPts val="800"/>
+              </a:spcAft>
+            </a:pPr>
+            <a:r>
+              <a:rPr sz="1050" b="0">
+                <a:solidFill>
+                  <a:srgbClr val="1A1F1D"/>
+                </a:solidFill>
+                <a:latin typeface="Helvetica Neue"/>
+              </a:rPr>
+              <a:t>-300</a:t>
+            </a:r>
+          </a:p>
+        </p:txBody>
+      </p:sp>
+      <p:sp>
+        <p:nvSpPr>
+          <p:cNvPr id="44" name="Rectangle 43"/>
+          <p:cNvSpPr/>
+          <p:nvPr/>
+        </p:nvSpPr>
+        <p:spPr>
+          <a:xfrm>
+            <a:off x="777240" y="3849624"/>
+            <a:ext cx="3794760" cy="548640"/>
+          </a:xfrm>
+          <a:prstGeom prst="rect">
+            <a:avLst/>
+          </a:prstGeom>
+          <a:solidFill>
+            <a:srgbClr val="FFFFFF"/>
+          </a:solidFill>
+          <a:ln w="8890">
+            <a:solidFill>
+              <a:srgbClr val="D9DFDB"/>
+            </a:solidFill>
+          </a:ln>
+          <a:effectLst/>
+        </p:spPr>
+        <p:style>
+          <a:lnRef idx="1">
+            <a:schemeClr val="accent1"/>
+          </a:lnRef>
+          <a:fillRef idx="3">
+            <a:schemeClr val="accent1"/>
+          </a:fillRef>
+          <a:effectRef idx="2">
+            <a:schemeClr val="accent1"/>
+          </a:effectRef>
+          <a:fontRef idx="minor">
+            <a:schemeClr val="lt1"/>
+          </a:fontRef>
+        </p:style>
+        <p:txBody>
+          <a:bodyPr rtlCol="0" anchor="ctr"/>
+          <a:lstStyle/>
+          <a:p>
+            <a:pPr algn="ctr"/>
+          </a:p>
+        </p:txBody>
+      </p:sp>
+      <p:sp>
+        <p:nvSpPr>
+          <p:cNvPr id="45" name="TextBox 44"/>
+          <p:cNvSpPr txBox="1"/>
+          <p:nvPr/>
+        </p:nvSpPr>
+        <p:spPr>
+          <a:xfrm>
+            <a:off x="868680" y="3986784"/>
+            <a:ext cx="3611880" cy="246888"/>
+          </a:xfrm>
+          <a:prstGeom prst="rect">
+            <a:avLst/>
+          </a:prstGeom>
+          <a:noFill/>
+        </p:spPr>
+        <p:txBody>
+          <a:bodyPr wrap="square" anchor="t" lIns="0" rIns="0" tIns="0" bIns="0">
+            <a:spAutoFit/>
+          </a:bodyPr>
+          <a:lstStyle/>
+          <a:p>
+            <a:pPr algn="l">
+              <a:lnSpc>
+                <a:spcPct val="112000"/>
+              </a:lnSpc>
+              <a:spcAft>
+                <a:spcPts val="800"/>
+              </a:spcAft>
+            </a:pPr>
+            <a:r>
+              <a:rPr sz="1050" b="0">
+                <a:solidFill>
+                  <a:srgbClr val="1A1F1D"/>
+                </a:solidFill>
+                <a:latin typeface="Helvetica Neue"/>
+              </a:rPr>
+              <a:t>S3 · Makine 4 · Performans/çevrim +%10</a:t>
+            </a:r>
+          </a:p>
+        </p:txBody>
+      </p:sp>
+      <p:sp>
+        <p:nvSpPr>
+          <p:cNvPr id="46" name="Rectangle 45"/>
+          <p:cNvSpPr/>
+          <p:nvPr/>
+        </p:nvSpPr>
+        <p:spPr>
+          <a:xfrm>
+            <a:off x="4572000" y="3849624"/>
+            <a:ext cx="960120" cy="548640"/>
+          </a:xfrm>
+          <a:prstGeom prst="rect">
+            <a:avLst/>
+          </a:prstGeom>
+          <a:solidFill>
+            <a:srgbClr val="FFFFFF"/>
+          </a:solidFill>
+          <a:ln w="8890">
+            <a:solidFill>
+              <a:srgbClr val="D9DFDB"/>
+            </a:solidFill>
+          </a:ln>
+          <a:effectLst/>
+        </p:spPr>
+        <p:style>
+          <a:lnRef idx="1">
+            <a:schemeClr val="accent1"/>
+          </a:lnRef>
+          <a:fillRef idx="3">
+            <a:schemeClr val="accent1"/>
+          </a:fillRef>
+          <a:effectRef idx="2">
+            <a:schemeClr val="accent1"/>
+          </a:effectRef>
+          <a:fontRef idx="minor">
+            <a:schemeClr val="lt1"/>
+          </a:fontRef>
+        </p:style>
+        <p:txBody>
+          <a:bodyPr rtlCol="0" anchor="ctr"/>
+          <a:lstStyle/>
+          <a:p>
+            <a:pPr algn="ctr"/>
+          </a:p>
+        </p:txBody>
+      </p:sp>
+      <p:sp>
+        <p:nvSpPr>
+          <p:cNvPr id="47" name="TextBox 46"/>
+          <p:cNvSpPr txBox="1"/>
+          <p:nvPr/>
+        </p:nvSpPr>
+        <p:spPr>
+          <a:xfrm>
+            <a:off x="4663440" y="3986784"/>
+            <a:ext cx="777240" cy="246888"/>
+          </a:xfrm>
+          <a:prstGeom prst="rect">
+            <a:avLst/>
+          </a:prstGeom>
+          <a:noFill/>
+        </p:spPr>
+        <p:txBody>
+          <a:bodyPr wrap="square" anchor="t" lIns="0" rIns="0" tIns="0" bIns="0">
+            <a:spAutoFit/>
+          </a:bodyPr>
+          <a:lstStyle/>
+          <a:p>
+            <a:pPr algn="r">
+              <a:lnSpc>
+                <a:spcPct val="112000"/>
+              </a:lnSpc>
+              <a:spcAft>
+                <a:spcPts val="800"/>
+              </a:spcAft>
+            </a:pPr>
+            <a:r>
+              <a:rPr sz="1050" b="0">
+                <a:solidFill>
+                  <a:srgbClr val="1A1F1D"/>
+                </a:solidFill>
+                <a:latin typeface="Helvetica Neue"/>
+              </a:rPr>
+              <a:t>0,00</a:t>
+            </a:r>
+          </a:p>
+        </p:txBody>
+      </p:sp>
+      <p:sp>
+        <p:nvSpPr>
+          <p:cNvPr id="48" name="Rectangle 47"/>
+          <p:cNvSpPr/>
+          <p:nvPr/>
+        </p:nvSpPr>
+        <p:spPr>
+          <a:xfrm>
+            <a:off x="5532120" y="3849624"/>
+            <a:ext cx="960120" cy="548640"/>
+          </a:xfrm>
+          <a:prstGeom prst="rect">
+            <a:avLst/>
+          </a:prstGeom>
+          <a:solidFill>
+            <a:srgbClr val="FFFFFF"/>
+          </a:solidFill>
+          <a:ln w="8890">
+            <a:solidFill>
+              <a:srgbClr val="D9DFDB"/>
+            </a:solidFill>
+          </a:ln>
+          <a:effectLst/>
+        </p:spPr>
+        <p:style>
+          <a:lnRef idx="1">
+            <a:schemeClr val="accent1"/>
+          </a:lnRef>
+          <a:fillRef idx="3">
+            <a:schemeClr val="accent1"/>
+          </a:fillRef>
+          <a:effectRef idx="2">
+            <a:schemeClr val="accent1"/>
+          </a:effectRef>
+          <a:fontRef idx="minor">
+            <a:schemeClr val="lt1"/>
+          </a:fontRef>
+        </p:style>
+        <p:txBody>
+          <a:bodyPr rtlCol="0" anchor="ctr"/>
+          <a:lstStyle/>
+          <a:p>
+            <a:pPr algn="ctr"/>
+          </a:p>
+        </p:txBody>
+      </p:sp>
+      <p:sp>
+        <p:nvSpPr>
+          <p:cNvPr id="49" name="TextBox 48"/>
+          <p:cNvSpPr txBox="1"/>
+          <p:nvPr/>
+        </p:nvSpPr>
+        <p:spPr>
+          <a:xfrm>
+            <a:off x="5623559" y="3986784"/>
+            <a:ext cx="777240" cy="246888"/>
+          </a:xfrm>
+          <a:prstGeom prst="rect">
+            <a:avLst/>
+          </a:prstGeom>
+          <a:noFill/>
+        </p:spPr>
+        <p:txBody>
+          <a:bodyPr wrap="square" anchor="t" lIns="0" rIns="0" tIns="0" bIns="0">
+            <a:spAutoFit/>
+          </a:bodyPr>
+          <a:lstStyle/>
+          <a:p>
+            <a:pPr algn="r">
+              <a:lnSpc>
+                <a:spcPct val="112000"/>
+              </a:lnSpc>
+              <a:spcAft>
+                <a:spcPts val="800"/>
+              </a:spcAft>
+            </a:pPr>
+            <a:r>
+              <a:rPr sz="1050" b="0">
+                <a:solidFill>
+                  <a:srgbClr val="1A1F1D"/>
+                </a:solidFill>
+                <a:latin typeface="Helvetica Neue"/>
+              </a:rPr>
+              <a:t>0,00</a:t>
+            </a:r>
+          </a:p>
+        </p:txBody>
+      </p:sp>
+      <p:sp>
+        <p:nvSpPr>
+          <p:cNvPr id="50" name="Rectangle 49"/>
+          <p:cNvSpPr/>
+          <p:nvPr/>
+        </p:nvSpPr>
+        <p:spPr>
+          <a:xfrm>
+            <a:off x="6492240" y="3849624"/>
+            <a:ext cx="1051560" cy="548640"/>
+          </a:xfrm>
+          <a:prstGeom prst="rect">
+            <a:avLst/>
+          </a:prstGeom>
+          <a:solidFill>
+            <a:srgbClr val="FFFFFF"/>
+          </a:solidFill>
+          <a:ln w="8890">
+            <a:solidFill>
+              <a:srgbClr val="D9DFDB"/>
+            </a:solidFill>
+          </a:ln>
+          <a:effectLst/>
+        </p:spPr>
+        <p:style>
+          <a:lnRef idx="1">
+            <a:schemeClr val="accent1"/>
+          </a:lnRef>
+          <a:fillRef idx="3">
+            <a:schemeClr val="accent1"/>
+          </a:fillRef>
+          <a:effectRef idx="2">
+            <a:schemeClr val="accent1"/>
+          </a:effectRef>
+          <a:fontRef idx="minor">
+            <a:schemeClr val="lt1"/>
+          </a:fontRef>
+        </p:style>
+        <p:txBody>
+          <a:bodyPr rtlCol="0" anchor="ctr"/>
+          <a:lstStyle/>
+          <a:p>
+            <a:pPr algn="ctr"/>
+          </a:p>
+        </p:txBody>
+      </p:sp>
+      <p:sp>
+        <p:nvSpPr>
+          <p:cNvPr id="51" name="TextBox 50"/>
+          <p:cNvSpPr txBox="1"/>
+          <p:nvPr/>
+        </p:nvSpPr>
+        <p:spPr>
+          <a:xfrm>
+            <a:off x="6583679" y="3986784"/>
+            <a:ext cx="868680" cy="246888"/>
+          </a:xfrm>
+          <a:prstGeom prst="rect">
+            <a:avLst/>
+          </a:prstGeom>
+          <a:noFill/>
+        </p:spPr>
+        <p:txBody>
+          <a:bodyPr wrap="square" anchor="t" lIns="0" rIns="0" tIns="0" bIns="0">
+            <a:spAutoFit/>
+          </a:bodyPr>
+          <a:lstStyle/>
+          <a:p>
+            <a:pPr algn="r">
+              <a:lnSpc>
+                <a:spcPct val="112000"/>
+              </a:lnSpc>
+              <a:spcAft>
+                <a:spcPts val="800"/>
+              </a:spcAft>
+            </a:pPr>
+            <a:r>
+              <a:rPr sz="1050" b="0">
+                <a:solidFill>
+                  <a:srgbClr val="1A1F1D"/>
+                </a:solidFill>
+                <a:latin typeface="Helvetica Neue"/>
+              </a:rPr>
+              <a:t>0,00</a:t>
+            </a:r>
+          </a:p>
+        </p:txBody>
+      </p:sp>
+      <p:sp>
+        <p:nvSpPr>
+          <p:cNvPr id="52" name="Rectangle 51"/>
+          <p:cNvSpPr/>
+          <p:nvPr/>
+        </p:nvSpPr>
+        <p:spPr>
+          <a:xfrm>
+            <a:off x="7543800" y="3849624"/>
+            <a:ext cx="1097280" cy="548640"/>
+          </a:xfrm>
+          <a:prstGeom prst="rect">
+            <a:avLst/>
+          </a:prstGeom>
+          <a:solidFill>
+            <a:srgbClr val="FFFFFF"/>
+          </a:solidFill>
+          <a:ln w="8890">
+            <a:solidFill>
+              <a:srgbClr val="D9DFDB"/>
+            </a:solidFill>
+          </a:ln>
+          <a:effectLst/>
+        </p:spPr>
+        <p:style>
+          <a:lnRef idx="1">
+            <a:schemeClr val="accent1"/>
+          </a:lnRef>
+          <a:fillRef idx="3">
+            <a:schemeClr val="accent1"/>
+          </a:fillRef>
+          <a:effectRef idx="2">
+            <a:schemeClr val="accent1"/>
+          </a:effectRef>
+          <a:fontRef idx="minor">
+            <a:schemeClr val="lt1"/>
+          </a:fontRef>
+        </p:style>
+        <p:txBody>
+          <a:bodyPr rtlCol="0" anchor="ctr"/>
+          <a:lstStyle/>
+          <a:p>
+            <a:pPr algn="ctr"/>
+          </a:p>
+        </p:txBody>
+      </p:sp>
+      <p:sp>
+        <p:nvSpPr>
+          <p:cNvPr id="53" name="TextBox 52"/>
+          <p:cNvSpPr txBox="1"/>
+          <p:nvPr/>
+        </p:nvSpPr>
+        <p:spPr>
+          <a:xfrm>
+            <a:off x="7635240" y="3986784"/>
+            <a:ext cx="914400" cy="246888"/>
+          </a:xfrm>
+          <a:prstGeom prst="rect">
+            <a:avLst/>
+          </a:prstGeom>
+          <a:noFill/>
+        </p:spPr>
+        <p:txBody>
+          <a:bodyPr wrap="square" anchor="t" lIns="0" rIns="0" tIns="0" bIns="0">
+            <a:spAutoFit/>
+          </a:bodyPr>
+          <a:lstStyle/>
+          <a:p>
+            <a:pPr algn="r">
+              <a:lnSpc>
+                <a:spcPct val="112000"/>
+              </a:lnSpc>
+              <a:spcAft>
+                <a:spcPts val="800"/>
+              </a:spcAft>
+            </a:pPr>
+            <a:r>
+              <a:rPr sz="1050" b="0">
+                <a:solidFill>
+                  <a:srgbClr val="1A1F1D"/>
+                </a:solidFill>
+                <a:latin typeface="Helvetica Neue"/>
+              </a:rPr>
+              <a:t>0</a:t>
+            </a:r>
+          </a:p>
+        </p:txBody>
+      </p:sp>
+      <p:sp>
+        <p:nvSpPr>
+          <p:cNvPr id="54" name="Rectangle 53"/>
+          <p:cNvSpPr/>
+          <p:nvPr/>
+        </p:nvSpPr>
+        <p:spPr>
+          <a:xfrm>
+            <a:off x="8641080" y="3849624"/>
+            <a:ext cx="1417320" cy="548640"/>
+          </a:xfrm>
+          <a:prstGeom prst="rect">
+            <a:avLst/>
+          </a:prstGeom>
+          <a:solidFill>
+            <a:srgbClr val="FFFFFF"/>
+          </a:solidFill>
+          <a:ln w="8890">
+            <a:solidFill>
+              <a:srgbClr val="D9DFDB"/>
+            </a:solidFill>
+          </a:ln>
+          <a:effectLst/>
+        </p:spPr>
+        <p:style>
+          <a:lnRef idx="1">
+            <a:schemeClr val="accent1"/>
+          </a:lnRef>
+          <a:fillRef idx="3">
+            <a:schemeClr val="accent1"/>
+          </a:fillRef>
+          <a:effectRef idx="2">
+            <a:schemeClr val="accent1"/>
+          </a:effectRef>
+          <a:fontRef idx="minor">
+            <a:schemeClr val="lt1"/>
+          </a:fontRef>
+        </p:style>
+        <p:txBody>
+          <a:bodyPr rtlCol="0" anchor="ctr"/>
+          <a:lstStyle/>
+          <a:p>
+            <a:pPr algn="ctr"/>
+          </a:p>
+        </p:txBody>
+      </p:sp>
+      <p:sp>
+        <p:nvSpPr>
+          <p:cNvPr id="55" name="TextBox 54"/>
+          <p:cNvSpPr txBox="1"/>
+          <p:nvPr/>
+        </p:nvSpPr>
+        <p:spPr>
+          <a:xfrm>
+            <a:off x="8732519" y="3986784"/>
+            <a:ext cx="1234440" cy="246888"/>
+          </a:xfrm>
+          <a:prstGeom prst="rect">
+            <a:avLst/>
+          </a:prstGeom>
+          <a:noFill/>
+        </p:spPr>
+        <p:txBody>
+          <a:bodyPr wrap="square" anchor="t" lIns="0" rIns="0" tIns="0" bIns="0">
+            <a:spAutoFit/>
+          </a:bodyPr>
+          <a:lstStyle/>
+          <a:p>
+            <a:pPr algn="r">
+              <a:lnSpc>
+                <a:spcPct val="112000"/>
+              </a:lnSpc>
+              <a:spcAft>
+                <a:spcPts val="800"/>
+              </a:spcAft>
+            </a:pPr>
+            <a:r>
+              <a:rPr sz="1050" b="0">
+                <a:solidFill>
+                  <a:srgbClr val="1A1F1D"/>
+                </a:solidFill>
+                <a:latin typeface="Helvetica Neue"/>
+              </a:rPr>
+              <a:t>-300</a:t>
+            </a:r>
+          </a:p>
+        </p:txBody>
+      </p:sp>
+      <p:sp>
+        <p:nvSpPr>
+          <p:cNvPr id="56" name="Rectangle 55"/>
+          <p:cNvSpPr/>
+          <p:nvPr/>
+        </p:nvSpPr>
+        <p:spPr>
+          <a:xfrm>
+            <a:off x="777240" y="4471416"/>
+            <a:ext cx="3794760" cy="548640"/>
+          </a:xfrm>
+          <a:prstGeom prst="rect">
+            <a:avLst/>
+          </a:prstGeom>
+          <a:solidFill>
+            <a:srgbClr val="FFFFFF"/>
+          </a:solidFill>
+          <a:ln w="8890">
+            <a:solidFill>
+              <a:srgbClr val="D9DFDB"/>
+            </a:solidFill>
+          </a:ln>
+          <a:effectLst/>
+        </p:spPr>
+        <p:style>
+          <a:lnRef idx="1">
+            <a:schemeClr val="accent1"/>
+          </a:lnRef>
+          <a:fillRef idx="3">
+            <a:schemeClr val="accent1"/>
+          </a:fillRef>
+          <a:effectRef idx="2">
+            <a:schemeClr val="accent1"/>
+          </a:effectRef>
+          <a:fontRef idx="minor">
+            <a:schemeClr val="lt1"/>
+          </a:fontRef>
+        </p:style>
+        <p:txBody>
+          <a:bodyPr rtlCol="0" anchor="ctr"/>
+          <a:lstStyle/>
+          <a:p>
+            <a:pPr algn="ctr"/>
+          </a:p>
+        </p:txBody>
+      </p:sp>
+      <p:sp>
+        <p:nvSpPr>
+          <p:cNvPr id="57" name="TextBox 56"/>
+          <p:cNvSpPr txBox="1"/>
+          <p:nvPr/>
+        </p:nvSpPr>
+        <p:spPr>
+          <a:xfrm>
+            <a:off x="868680" y="4608576"/>
+            <a:ext cx="3611880" cy="246888"/>
+          </a:xfrm>
+          <a:prstGeom prst="rect">
+            <a:avLst/>
+          </a:prstGeom>
+          <a:noFill/>
+        </p:spPr>
+        <p:txBody>
+          <a:bodyPr wrap="square" anchor="t" lIns="0" rIns="0" tIns="0" bIns="0">
+            <a:spAutoFit/>
+          </a:bodyPr>
+          <a:lstStyle/>
+          <a:p>
+            <a:pPr algn="l">
+              <a:lnSpc>
+                <a:spcPct val="112000"/>
+              </a:lnSpc>
+              <a:spcAft>
+                <a:spcPts val="800"/>
+              </a:spcAft>
+            </a:pPr>
+            <a:r>
+              <a:rPr sz="1050" b="0">
+                <a:solidFill>
+                  <a:srgbClr val="1A1F1D"/>
+                </a:solidFill>
+                <a:latin typeface="Helvetica Neue"/>
+              </a:rPr>
+              <a:t>S4 · PLANT · Tesis genelinde bağlantı düzeltildi</a:t>
+            </a:r>
+          </a:p>
+        </p:txBody>
+      </p:sp>
+      <p:sp>
+        <p:nvSpPr>
+          <p:cNvPr id="58" name="Rectangle 57"/>
+          <p:cNvSpPr/>
+          <p:nvPr/>
+        </p:nvSpPr>
+        <p:spPr>
+          <a:xfrm>
+            <a:off x="4572000" y="4471416"/>
+            <a:ext cx="960120" cy="548640"/>
+          </a:xfrm>
+          <a:prstGeom prst="rect">
+            <a:avLst/>
+          </a:prstGeom>
+          <a:solidFill>
+            <a:srgbClr val="FFFFFF"/>
+          </a:solidFill>
+          <a:ln w="8890">
+            <a:solidFill>
+              <a:srgbClr val="D9DFDB"/>
+            </a:solidFill>
+          </a:ln>
+          <a:effectLst/>
+        </p:spPr>
+        <p:style>
+          <a:lnRef idx="1">
+            <a:schemeClr val="accent1"/>
+          </a:lnRef>
+          <a:fillRef idx="3">
+            <a:schemeClr val="accent1"/>
+          </a:fillRef>
+          <a:effectRef idx="2">
+            <a:schemeClr val="accent1"/>
+          </a:effectRef>
+          <a:fontRef idx="minor">
+            <a:schemeClr val="lt1"/>
+          </a:fontRef>
+        </p:style>
+        <p:txBody>
+          <a:bodyPr rtlCol="0" anchor="ctr"/>
+          <a:lstStyle/>
+          <a:p>
+            <a:pPr algn="ctr"/>
+          </a:p>
+        </p:txBody>
+      </p:sp>
+      <p:sp>
+        <p:nvSpPr>
+          <p:cNvPr id="59" name="TextBox 58"/>
+          <p:cNvSpPr txBox="1"/>
+          <p:nvPr/>
+        </p:nvSpPr>
+        <p:spPr>
+          <a:xfrm>
+            <a:off x="4663440" y="4608576"/>
+            <a:ext cx="777240" cy="246888"/>
+          </a:xfrm>
+          <a:prstGeom prst="rect">
+            <a:avLst/>
+          </a:prstGeom>
+          <a:noFill/>
+        </p:spPr>
+        <p:txBody>
+          <a:bodyPr wrap="square" anchor="t" lIns="0" rIns="0" tIns="0" bIns="0">
+            <a:spAutoFit/>
+          </a:bodyPr>
+          <a:lstStyle/>
+          <a:p>
+            <a:pPr algn="r">
+              <a:lnSpc>
+                <a:spcPct val="112000"/>
+              </a:lnSpc>
+              <a:spcAft>
+                <a:spcPts val="800"/>
+              </a:spcAft>
+            </a:pPr>
+            <a:r>
+              <a:rPr sz="1050" b="0">
+                <a:solidFill>
+                  <a:srgbClr val="1A1F1D"/>
+                </a:solidFill>
+                <a:latin typeface="Helvetica Neue"/>
+              </a:rPr>
+              <a:t>0,00</a:t>
+            </a:r>
+          </a:p>
+        </p:txBody>
+      </p:sp>
+      <p:sp>
+        <p:nvSpPr>
+          <p:cNvPr id="60" name="Rectangle 59"/>
+          <p:cNvSpPr/>
+          <p:nvPr/>
+        </p:nvSpPr>
+        <p:spPr>
+          <a:xfrm>
+            <a:off x="5532120" y="4471416"/>
+            <a:ext cx="960120" cy="548640"/>
+          </a:xfrm>
+          <a:prstGeom prst="rect">
+            <a:avLst/>
+          </a:prstGeom>
+          <a:solidFill>
+            <a:srgbClr val="FFFFFF"/>
+          </a:solidFill>
+          <a:ln w="8890">
+            <a:solidFill>
+              <a:srgbClr val="D9DFDB"/>
+            </a:solidFill>
+          </a:ln>
+          <a:effectLst/>
+        </p:spPr>
+        <p:style>
+          <a:lnRef idx="1">
+            <a:schemeClr val="accent1"/>
+          </a:lnRef>
+          <a:fillRef idx="3">
+            <a:schemeClr val="accent1"/>
+          </a:fillRef>
+          <a:effectRef idx="2">
+            <a:schemeClr val="accent1"/>
+          </a:effectRef>
+          <a:fontRef idx="minor">
+            <a:schemeClr val="lt1"/>
+          </a:fontRef>
+        </p:style>
+        <p:txBody>
+          <a:bodyPr rtlCol="0" anchor="ctr"/>
+          <a:lstStyle/>
+          <a:p>
+            <a:pPr algn="ctr"/>
+          </a:p>
+        </p:txBody>
+      </p:sp>
+      <p:sp>
+        <p:nvSpPr>
+          <p:cNvPr id="61" name="TextBox 60"/>
+          <p:cNvSpPr txBox="1"/>
+          <p:nvPr/>
+        </p:nvSpPr>
+        <p:spPr>
+          <a:xfrm>
+            <a:off x="5623559" y="4608576"/>
+            <a:ext cx="777240" cy="246888"/>
+          </a:xfrm>
+          <a:prstGeom prst="rect">
+            <a:avLst/>
+          </a:prstGeom>
+          <a:noFill/>
+        </p:spPr>
+        <p:txBody>
+          <a:bodyPr wrap="square" anchor="t" lIns="0" rIns="0" tIns="0" bIns="0">
+            <a:spAutoFit/>
+          </a:bodyPr>
+          <a:lstStyle/>
+          <a:p>
+            <a:pPr algn="r">
+              <a:lnSpc>
+                <a:spcPct val="112000"/>
+              </a:lnSpc>
+              <a:spcAft>
+                <a:spcPts val="800"/>
+              </a:spcAft>
+            </a:pPr>
+            <a:r>
+              <a:rPr sz="1050" b="0">
+                <a:solidFill>
+                  <a:srgbClr val="1A1F1D"/>
+                </a:solidFill>
+                <a:latin typeface="Helvetica Neue"/>
+              </a:rPr>
+              <a:t>0,00</a:t>
+            </a:r>
+          </a:p>
+        </p:txBody>
+      </p:sp>
+      <p:sp>
+        <p:nvSpPr>
+          <p:cNvPr id="62" name="Rectangle 61"/>
+          <p:cNvSpPr/>
+          <p:nvPr/>
+        </p:nvSpPr>
+        <p:spPr>
+          <a:xfrm>
+            <a:off x="6492240" y="4471416"/>
+            <a:ext cx="1051560" cy="548640"/>
+          </a:xfrm>
+          <a:prstGeom prst="rect">
+            <a:avLst/>
+          </a:prstGeom>
+          <a:solidFill>
+            <a:srgbClr val="FFFFFF"/>
+          </a:solidFill>
+          <a:ln w="8890">
+            <a:solidFill>
+              <a:srgbClr val="D9DFDB"/>
+            </a:solidFill>
+          </a:ln>
+          <a:effectLst/>
+        </p:spPr>
+        <p:style>
+          <a:lnRef idx="1">
+            <a:schemeClr val="accent1"/>
+          </a:lnRef>
+          <a:fillRef idx="3">
+            <a:schemeClr val="accent1"/>
+          </a:fillRef>
+          <a:effectRef idx="2">
+            <a:schemeClr val="accent1"/>
+          </a:effectRef>
+          <a:fontRef idx="minor">
+            <a:schemeClr val="lt1"/>
+          </a:fontRef>
+        </p:style>
+        <p:txBody>
+          <a:bodyPr rtlCol="0" anchor="ctr"/>
+          <a:lstStyle/>
+          <a:p>
+            <a:pPr algn="ctr"/>
+          </a:p>
+        </p:txBody>
+      </p:sp>
+      <p:sp>
+        <p:nvSpPr>
+          <p:cNvPr id="63" name="TextBox 62"/>
+          <p:cNvSpPr txBox="1"/>
+          <p:nvPr/>
+        </p:nvSpPr>
+        <p:spPr>
+          <a:xfrm>
+            <a:off x="6583679" y="4608576"/>
+            <a:ext cx="868680" cy="246888"/>
+          </a:xfrm>
+          <a:prstGeom prst="rect">
+            <a:avLst/>
+          </a:prstGeom>
+          <a:noFill/>
+        </p:spPr>
+        <p:txBody>
+          <a:bodyPr wrap="square" anchor="t" lIns="0" rIns="0" tIns="0" bIns="0">
+            <a:spAutoFit/>
+          </a:bodyPr>
+          <a:lstStyle/>
+          <a:p>
+            <a:pPr algn="r">
+              <a:lnSpc>
+                <a:spcPct val="112000"/>
+              </a:lnSpc>
+              <a:spcAft>
+                <a:spcPts val="800"/>
+              </a:spcAft>
+            </a:pPr>
+            <a:r>
+              <a:rPr sz="1050" b="0">
+                <a:solidFill>
+                  <a:srgbClr val="1A1F1D"/>
+                </a:solidFill>
+                <a:latin typeface="Helvetica Neue"/>
+              </a:rPr>
+              <a:t>0,00</a:t>
+            </a:r>
+          </a:p>
+        </p:txBody>
+      </p:sp>
+      <p:sp>
+        <p:nvSpPr>
+          <p:cNvPr id="64" name="Rectangle 63"/>
+          <p:cNvSpPr/>
+          <p:nvPr/>
+        </p:nvSpPr>
+        <p:spPr>
+          <a:xfrm>
+            <a:off x="7543800" y="4471416"/>
+            <a:ext cx="1097280" cy="548640"/>
+          </a:xfrm>
+          <a:prstGeom prst="rect">
+            <a:avLst/>
+          </a:prstGeom>
+          <a:solidFill>
+            <a:srgbClr val="FFFFFF"/>
+          </a:solidFill>
+          <a:ln w="8890">
+            <a:solidFill>
+              <a:srgbClr val="D9DFDB"/>
+            </a:solidFill>
+          </a:ln>
+          <a:effectLst/>
+        </p:spPr>
+        <p:style>
+          <a:lnRef idx="1">
+            <a:schemeClr val="accent1"/>
+          </a:lnRef>
+          <a:fillRef idx="3">
+            <a:schemeClr val="accent1"/>
+          </a:fillRef>
+          <a:effectRef idx="2">
+            <a:schemeClr val="accent1"/>
+          </a:effectRef>
+          <a:fontRef idx="minor">
+            <a:schemeClr val="lt1"/>
+          </a:fontRef>
+        </p:style>
+        <p:txBody>
+          <a:bodyPr rtlCol="0" anchor="ctr"/>
+          <a:lstStyle/>
+          <a:p>
+            <a:pPr algn="ctr"/>
+          </a:p>
+        </p:txBody>
+      </p:sp>
+      <p:sp>
+        <p:nvSpPr>
+          <p:cNvPr id="65" name="TextBox 64"/>
+          <p:cNvSpPr txBox="1"/>
+          <p:nvPr/>
+        </p:nvSpPr>
+        <p:spPr>
+          <a:xfrm>
+            <a:off x="7635240" y="4608576"/>
+            <a:ext cx="914400" cy="246888"/>
+          </a:xfrm>
+          <a:prstGeom prst="rect">
+            <a:avLst/>
+          </a:prstGeom>
+          <a:noFill/>
+        </p:spPr>
+        <p:txBody>
+          <a:bodyPr wrap="square" anchor="t" lIns="0" rIns="0" tIns="0" bIns="0">
+            <a:spAutoFit/>
+          </a:bodyPr>
+          <a:lstStyle/>
+          <a:p>
+            <a:pPr algn="r">
+              <a:lnSpc>
+                <a:spcPct val="112000"/>
+              </a:lnSpc>
+              <a:spcAft>
+                <a:spcPts val="800"/>
+              </a:spcAft>
+            </a:pPr>
+            <a:r>
+              <a:rPr sz="1050" b="0">
+                <a:solidFill>
+                  <a:srgbClr val="1A1F1D"/>
+                </a:solidFill>
+                <a:latin typeface="Helvetica Neue"/>
+              </a:rPr>
+              <a:t>663</a:t>
+            </a:r>
+          </a:p>
+        </p:txBody>
+      </p:sp>
+      <p:sp>
+        <p:nvSpPr>
+          <p:cNvPr id="66" name="Rectangle 65"/>
+          <p:cNvSpPr/>
+          <p:nvPr/>
+        </p:nvSpPr>
+        <p:spPr>
+          <a:xfrm>
+            <a:off x="8641080" y="4471416"/>
+            <a:ext cx="1417320" cy="548640"/>
+          </a:xfrm>
+          <a:prstGeom prst="rect">
+            <a:avLst/>
+          </a:prstGeom>
+          <a:solidFill>
+            <a:srgbClr val="FFFFFF"/>
+          </a:solidFill>
+          <a:ln w="8890">
+            <a:solidFill>
+              <a:srgbClr val="D9DFDB"/>
+            </a:solidFill>
+          </a:ln>
+          <a:effectLst/>
+        </p:spPr>
+        <p:style>
+          <a:lnRef idx="1">
+            <a:schemeClr val="accent1"/>
+          </a:lnRef>
+          <a:fillRef idx="3">
+            <a:schemeClr val="accent1"/>
+          </a:fillRef>
+          <a:effectRef idx="2">
+            <a:schemeClr val="accent1"/>
+          </a:effectRef>
+          <a:fontRef idx="minor">
+            <a:schemeClr val="lt1"/>
+          </a:fontRef>
+        </p:style>
+        <p:txBody>
+          <a:bodyPr rtlCol="0" anchor="ctr"/>
+          <a:lstStyle/>
+          <a:p>
+            <a:pPr algn="ctr"/>
+          </a:p>
+        </p:txBody>
+      </p:sp>
+      <p:sp>
+        <p:nvSpPr>
+          <p:cNvPr id="67" name="TextBox 66"/>
+          <p:cNvSpPr txBox="1"/>
+          <p:nvPr/>
+        </p:nvSpPr>
+        <p:spPr>
+          <a:xfrm>
+            <a:off x="8732519" y="4608576"/>
+            <a:ext cx="1234440" cy="246888"/>
+          </a:xfrm>
+          <a:prstGeom prst="rect">
+            <a:avLst/>
+          </a:prstGeom>
+          <a:noFill/>
+        </p:spPr>
+        <p:txBody>
+          <a:bodyPr wrap="square" anchor="t" lIns="0" rIns="0" tIns="0" bIns="0">
+            <a:spAutoFit/>
+          </a:bodyPr>
+          <a:lstStyle/>
+          <a:p>
+            <a:pPr algn="r">
+              <a:lnSpc>
+                <a:spcPct val="112000"/>
+              </a:lnSpc>
+              <a:spcAft>
+                <a:spcPts val="800"/>
+              </a:spcAft>
+            </a:pPr>
+            <a:r>
+              <a:rPr sz="1050" b="0">
+                <a:solidFill>
+                  <a:srgbClr val="1A1F1D"/>
+                </a:solidFill>
+                <a:latin typeface="Helvetica Neue"/>
+              </a:rPr>
+              <a:t>0</a:t>
+            </a:r>
+          </a:p>
+        </p:txBody>
+      </p:sp>
+      <p:sp>
+        <p:nvSpPr>
+          <p:cNvPr id="68" name="Rectangle 67"/>
+          <p:cNvSpPr/>
+          <p:nvPr/>
+        </p:nvSpPr>
+        <p:spPr>
+          <a:xfrm>
+            <a:off x="777240" y="5285232"/>
+            <a:ext cx="10637215" cy="566928"/>
           </a:xfrm>
           <a:prstGeom prst="rect">
             <a:avLst/>
@@ -11439,14 +14190,14 @@
       </p:sp>
       <p:sp>
         <p:nvSpPr>
-          <p:cNvPr id="10" name="TextBox 9"/>
+          <p:cNvPr id="69" name="TextBox 68"/>
           <p:cNvSpPr txBox="1"/>
           <p:nvPr/>
         </p:nvSpPr>
         <p:spPr>
           <a:xfrm>
-            <a:off x="1005840" y="5047488"/>
-            <a:ext cx="10180015" cy="548640"/>
+            <a:off x="978408" y="5422392"/>
+            <a:ext cx="10234879" cy="274320"/>
           </a:xfrm>
           <a:prstGeom prst="rect">
             <a:avLst/>
@@ -11461,20 +14212,20 @@
           <a:p>
             <a:pPr algn="l">
               <a:lnSpc>
-                <a:spcPct val="120000"/>
+                <a:spcPct val="112000"/>
               </a:lnSpc>
               <a:spcAft>
                 <a:spcPts val="800"/>
               </a:spcAft>
             </a:pPr>
             <a:r>
-              <a:rPr sz="1400" b="0">
+              <a:rPr sz="1150" b="0">
                 <a:solidFill>
                   <a:srgbClr val="1A1F1D"/>
                 </a:solidFill>
                 <a:latin typeface="Helvetica Neue"/>
               </a:rPr>
-              <a:t>Veri setinde maliyet/fiyat yok. Tüm parasal değerler açıkça VARSAYIM olarak etiketlidir — gerçek değil, hipotez.</a:t>
+              <a:t>S2 yalnız sınıflandırmayı değiştirir; S3 üretim sayımı olmadığı için inerttir; S4 IT aksiyonudur ve makine OEE'sine yazılmaz. Tüm € değerleri VARSAYIM.</a:t>
             </a:r>
           </a:p>
         </p:txBody>

</xml_diff>

<commit_message>
Add dashboard walkthrough to presentation
</commit_message>
<xml_diff>
--- a/trexCloud_Sunum.pptx
+++ b/trexCloud_Sunum.pptx
@@ -16,6 +16,13 @@
     <p:sldId id="264" r:id="rId16"/>
     <p:sldId id="265" r:id="rId17"/>
     <p:sldId id="266" r:id="rId18"/>
+    <p:sldId id="267" r:id="rId19"/>
+    <p:sldId id="268" r:id="rId20"/>
+    <p:sldId id="269" r:id="rId21"/>
+    <p:sldId id="270" r:id="rId22"/>
+    <p:sldId id="271" r:id="rId23"/>
+    <p:sldId id="272" r:id="rId24"/>
+    <p:sldId id="273" r:id="rId25"/>
   </p:sldIdLst>
   <p:sldSz cx="12191695" cy="6858000" type="screen4x3"/>
   <p:notesSz cx="6858000" cy="9144000"/>
@@ -653,6 +660,496 @@
           <a:p>
             <a:r>
               <a:t>Kapanış: dürüst, çalışan, uçtan uca bir sistem kurduk. Tahmin eder, açıklar, sayısallaştırır; ve her scoping kararının veri temelli bir gerekçesi var.</a:t>
+            </a:r>
+          </a:p>
+        </p:txBody>
+      </p:sp>
+      <p:sp>
+        <p:nvSpPr>
+          <p:cNvPr id="4" name="Slide Number Placeholder 3"/>
+          <p:cNvSpPr>
+            <a:spLocks noGrp="1"/>
+          </p:cNvSpPr>
+          <p:nvPr>
+            <p:ph type="sldNum" idx="5" sz="quarter"/>
+          </p:nvPr>
+        </p:nvSpPr>
+        <p:spPr/>
+      </p:sp>
+    </p:spTree>
+  </p:cSld>
+  <p:clrMapOvr>
+    <a:masterClrMapping/>
+  </p:clrMapOvr>
+</p:notes>
+</file>
+
+<file path=ppt/notesSlides/notesSlide12.xml><?xml version="1.0" encoding="utf-8"?>
+<p:notes xmlns:a="http://schemas.openxmlformats.org/drawingml/2006/main" xmlns:p="http://schemas.openxmlformats.org/presentationml/2006/main" xmlns:r="http://schemas.openxmlformats.org/officeDocument/2006/relationships">
+  <p:cSld>
+    <p:spTree>
+      <p:nvGrpSpPr>
+        <p:cNvPr id="1" name=""/>
+        <p:cNvGrpSpPr/>
+        <p:nvPr/>
+      </p:nvGrpSpPr>
+      <p:grpSpPr>
+        <a:xfrm>
+          <a:off x="0" y="0"/>
+          <a:ext cx="0" cy="0"/>
+          <a:chOff x="0" y="0"/>
+          <a:chExt cx="0" cy="0"/>
+        </a:xfrm>
+      </p:grpSpPr>
+      <p:sp>
+        <p:nvSpPr>
+          <p:cNvPr id="2" name="Slide Image Placeholder 1"/>
+          <p:cNvSpPr>
+            <a:spLocks noGrp="1"/>
+          </p:cNvSpPr>
+          <p:nvPr>
+            <p:ph type="sldImg" idx="2"/>
+          </p:nvPr>
+        </p:nvSpPr>
+        <p:spPr/>
+      </p:sp>
+      <p:sp>
+        <p:nvSpPr>
+          <p:cNvPr id="3" name="Notes Placeholder 2"/>
+          <p:cNvSpPr>
+            <a:spLocks noGrp="1"/>
+          </p:cNvSpPr>
+          <p:nvPr>
+            <p:ph type="body" idx="3" sz="quarter"/>
+          </p:nvPr>
+        </p:nvSpPr>
+        <p:spPr/>
+        <p:txBody>
+          <a:bodyPr/>
+          <a:lstStyle/>
+          <a:p>
+            <a:r>
+              <a:t>Genel Bakış ekranında önce üç tesis KPI'sını göster. Sonra makine kartlarının rejim renklerini açıkla: yeşil Fanuc tahmin hücresi, kehribar Mitsubishi RCA/OEE, gri telemetrisiz. Bir karta tıklanınca sağda OEE bileşenleri açılır.</a:t>
+            </a:r>
+          </a:p>
+        </p:txBody>
+      </p:sp>
+      <p:sp>
+        <p:nvSpPr>
+          <p:cNvPr id="4" name="Slide Number Placeholder 3"/>
+          <p:cNvSpPr>
+            <a:spLocks noGrp="1"/>
+          </p:cNvSpPr>
+          <p:nvPr>
+            <p:ph type="sldNum" idx="5" sz="quarter"/>
+          </p:nvPr>
+        </p:nvSpPr>
+        <p:spPr/>
+      </p:sp>
+    </p:spTree>
+  </p:cSld>
+  <p:clrMapOvr>
+    <a:masterClrMapping/>
+  </p:clrMapOvr>
+</p:notes>
+</file>
+
+<file path=ppt/notesSlides/notesSlide13.xml><?xml version="1.0" encoding="utf-8"?>
+<p:notes xmlns:a="http://schemas.openxmlformats.org/drawingml/2006/main" xmlns:p="http://schemas.openxmlformats.org/presentationml/2006/main" xmlns:r="http://schemas.openxmlformats.org/officeDocument/2006/relationships">
+  <p:cSld>
+    <p:spTree>
+      <p:nvGrpSpPr>
+        <p:cNvPr id="1" name=""/>
+        <p:cNvGrpSpPr/>
+        <p:nvPr/>
+      </p:nvGrpSpPr>
+      <p:grpSpPr>
+        <a:xfrm>
+          <a:off x="0" y="0"/>
+          <a:ext cx="0" cy="0"/>
+          <a:chOff x="0" y="0"/>
+          <a:chExt cx="0" cy="0"/>
+        </a:xfrm>
+      </p:grpSpPr>
+      <p:sp>
+        <p:nvSpPr>
+          <p:cNvPr id="2" name="Slide Image Placeholder 1"/>
+          <p:cNvSpPr>
+            <a:spLocks noGrp="1"/>
+          </p:cNvSpPr>
+          <p:nvPr>
+            <p:ph type="sldImg" idx="2"/>
+          </p:nvPr>
+        </p:nvSpPr>
+        <p:spPr/>
+      </p:sp>
+      <p:sp>
+        <p:nvSpPr>
+          <p:cNvPr id="3" name="Notes Placeholder 2"/>
+          <p:cNvSpPr>
+            <a:spLocks noGrp="1"/>
+          </p:cNvSpPr>
+          <p:nvPr>
+            <p:ph type="body" idx="3" sz="quarter"/>
+          </p:nvPr>
+        </p:nvSpPr>
+        <p:spPr/>
+        <p:txBody>
+          <a:bodyPr/>
+          <a:lstStyle/>
+          <a:p>
+            <a:r>
+              <a:t>Pareto'da kırmızı ve gri ayrımını vurgula. System Offline makine arızası değildir. Bu ekran aksiyon sahibini belirler: bakım mı, IT/ağ mı?</a:t>
+            </a:r>
+          </a:p>
+        </p:txBody>
+      </p:sp>
+      <p:sp>
+        <p:nvSpPr>
+          <p:cNvPr id="4" name="Slide Number Placeholder 3"/>
+          <p:cNvSpPr>
+            <a:spLocks noGrp="1"/>
+          </p:cNvSpPr>
+          <p:nvPr>
+            <p:ph type="sldNum" idx="5" sz="quarter"/>
+          </p:nvPr>
+        </p:nvSpPr>
+        <p:spPr/>
+      </p:sp>
+    </p:spTree>
+  </p:cSld>
+  <p:clrMapOvr>
+    <a:masterClrMapping/>
+  </p:clrMapOvr>
+</p:notes>
+</file>
+
+<file path=ppt/notesSlides/notesSlide14.xml><?xml version="1.0" encoding="utf-8"?>
+<p:notes xmlns:a="http://schemas.openxmlformats.org/drawingml/2006/main" xmlns:p="http://schemas.openxmlformats.org/presentationml/2006/main" xmlns:r="http://schemas.openxmlformats.org/officeDocument/2006/relationships">
+  <p:cSld>
+    <p:spTree>
+      <p:nvGrpSpPr>
+        <p:cNvPr id="1" name=""/>
+        <p:cNvGrpSpPr/>
+        <p:nvPr/>
+      </p:nvGrpSpPr>
+      <p:grpSpPr>
+        <a:xfrm>
+          <a:off x="0" y="0"/>
+          <a:ext cx="0" cy="0"/>
+          <a:chOff x="0" y="0"/>
+          <a:chExt cx="0" cy="0"/>
+        </a:xfrm>
+      </p:grpSpPr>
+      <p:sp>
+        <p:nvSpPr>
+          <p:cNvPr id="2" name="Slide Image Placeholder 1"/>
+          <p:cNvSpPr>
+            <a:spLocks noGrp="1"/>
+          </p:cNvSpPr>
+          <p:nvPr>
+            <p:ph type="sldImg" idx="2"/>
+          </p:nvPr>
+        </p:nvSpPr>
+        <p:spPr/>
+      </p:sp>
+      <p:sp>
+        <p:nvSpPr>
+          <p:cNvPr id="3" name="Notes Placeholder 2"/>
+          <p:cNvSpPr>
+            <a:spLocks noGrp="1"/>
+          </p:cNvSpPr>
+          <p:nvPr>
+            <p:ph type="body" idx="3" sz="quarter"/>
+          </p:nvPr>
+        </p:nvSpPr>
+        <p:spPr/>
+        <p:txBody>
+          <a:bodyPr/>
+          <a:lstStyle/>
+          <a:p>
+            <a:r>
+              <a:t>Bu ekran modelin tutulmamış gelecekteki riskini gösterir. Yeşil risk çizgisini, sabit alarm eşiğini ve gerçek duruş işaretlerini anlat. Alt dönemlerden biri seçilince RCA ve What-If akışı aynı sayfada devam eder.</a:t>
+            </a:r>
+          </a:p>
+        </p:txBody>
+      </p:sp>
+      <p:sp>
+        <p:nvSpPr>
+          <p:cNvPr id="4" name="Slide Number Placeholder 3"/>
+          <p:cNvSpPr>
+            <a:spLocks noGrp="1"/>
+          </p:cNvSpPr>
+          <p:nvPr>
+            <p:ph type="sldNum" idx="5" sz="quarter"/>
+          </p:nvPr>
+        </p:nvSpPr>
+        <p:spPr/>
+      </p:sp>
+    </p:spTree>
+  </p:cSld>
+  <p:clrMapOvr>
+    <a:masterClrMapping/>
+  </p:clrMapOvr>
+</p:notes>
+</file>
+
+<file path=ppt/notesSlides/notesSlide15.xml><?xml version="1.0" encoding="utf-8"?>
+<p:notes xmlns:a="http://schemas.openxmlformats.org/drawingml/2006/main" xmlns:p="http://schemas.openxmlformats.org/presentationml/2006/main" xmlns:r="http://schemas.openxmlformats.org/officeDocument/2006/relationships">
+  <p:cSld>
+    <p:spTree>
+      <p:nvGrpSpPr>
+        <p:cNvPr id="1" name=""/>
+        <p:cNvGrpSpPr/>
+        <p:nvPr/>
+      </p:nvGrpSpPr>
+      <p:grpSpPr>
+        <a:xfrm>
+          <a:off x="0" y="0"/>
+          <a:ext cx="0" cy="0"/>
+          <a:chOff x="0" y="0"/>
+          <a:chExt cx="0" cy="0"/>
+        </a:xfrm>
+      </p:grpSpPr>
+      <p:sp>
+        <p:nvSpPr>
+          <p:cNvPr id="2" name="Slide Image Placeholder 1"/>
+          <p:cNvSpPr>
+            <a:spLocks noGrp="1"/>
+          </p:cNvSpPr>
+          <p:nvPr>
+            <p:ph type="sldImg" idx="2"/>
+          </p:nvPr>
+        </p:nvSpPr>
+        <p:spPr/>
+      </p:sp>
+      <p:sp>
+        <p:nvSpPr>
+          <p:cNvPr id="3" name="Notes Placeholder 2"/>
+          <p:cNvSpPr>
+            <a:spLocks noGrp="1"/>
+          </p:cNvSpPr>
+          <p:nvPr>
+            <p:ph type="body" idx="3" sz="quarter"/>
+          </p:nvPr>
+        </p:nvSpPr>
+        <p:spPr/>
+        <p:txBody>
+          <a:bodyPr/>
+          <a:lstStyle/>
+          <a:p>
+            <a:r>
+              <a:t>Makine 1 örneğinde alarm sırası ile neden sırasının aynı şey olmadığını anlat. Hava basıncı kök neden, Z ekseni geri dönüş alarmı sonuçtur. Sağdaki hipotezler olasılık ve önerilen aksiyonla birlikte gösterilir.</a:t>
+            </a:r>
+          </a:p>
+        </p:txBody>
+      </p:sp>
+      <p:sp>
+        <p:nvSpPr>
+          <p:cNvPr id="4" name="Slide Number Placeholder 3"/>
+          <p:cNvSpPr>
+            <a:spLocks noGrp="1"/>
+          </p:cNvSpPr>
+          <p:nvPr>
+            <p:ph type="sldNum" idx="5" sz="quarter"/>
+          </p:nvPr>
+        </p:nvSpPr>
+        <p:spPr/>
+      </p:sp>
+    </p:spTree>
+  </p:cSld>
+  <p:clrMapOvr>
+    <a:masterClrMapping/>
+  </p:clrMapOvr>
+</p:notes>
+</file>
+
+<file path=ppt/notesSlides/notesSlide16.xml><?xml version="1.0" encoding="utf-8"?>
+<p:notes xmlns:a="http://schemas.openxmlformats.org/drawingml/2006/main" xmlns:p="http://schemas.openxmlformats.org/presentationml/2006/main" xmlns:r="http://schemas.openxmlformats.org/officeDocument/2006/relationships">
+  <p:cSld>
+    <p:spTree>
+      <p:nvGrpSpPr>
+        <p:cNvPr id="1" name=""/>
+        <p:cNvGrpSpPr/>
+        <p:nvPr/>
+      </p:nvGrpSpPr>
+      <p:grpSpPr>
+        <a:xfrm>
+          <a:off x="0" y="0"/>
+          <a:ext cx="0" cy="0"/>
+          <a:chOff x="0" y="0"/>
+          <a:chExt cx="0" cy="0"/>
+        </a:xfrm>
+      </p:grpSpPr>
+      <p:sp>
+        <p:nvSpPr>
+          <p:cNvPr id="2" name="Slide Image Placeholder 1"/>
+          <p:cNvSpPr>
+            <a:spLocks noGrp="1"/>
+          </p:cNvSpPr>
+          <p:nvPr>
+            <p:ph type="sldImg" idx="2"/>
+          </p:nvPr>
+        </p:nvSpPr>
+        <p:spPr/>
+      </p:sp>
+      <p:sp>
+        <p:nvSpPr>
+          <p:cNvPr id="3" name="Notes Placeholder 2"/>
+          <p:cNvSpPr>
+            <a:spLocks noGrp="1"/>
+          </p:cNvSpPr>
+          <p:nvPr>
+            <p:ph type="body" idx="3" sz="quarter"/>
+          </p:nvPr>
+        </p:nvSpPr>
+        <p:spPr/>
+        <p:txBody>
+          <a:bodyPr/>
+          <a:lstStyle/>
+          <a:p>
+            <a:r>
+              <a:t>Üst kart model-atfedilebilir değerdir: kaçırılan duruşlara değer yazılmaz ve her alarm kontrol maliyeti doğurur. Alt kart genel What-If'tir; kullanıcı yüzdeyi ve finansal varsayımları değiştirerek A/P/Q/OEE etkisini anında görür.</a:t>
+            </a:r>
+          </a:p>
+        </p:txBody>
+      </p:sp>
+      <p:sp>
+        <p:nvSpPr>
+          <p:cNvPr id="4" name="Slide Number Placeholder 3"/>
+          <p:cNvSpPr>
+            <a:spLocks noGrp="1"/>
+          </p:cNvSpPr>
+          <p:nvPr>
+            <p:ph type="sldNum" idx="5" sz="quarter"/>
+          </p:nvPr>
+        </p:nvSpPr>
+        <p:spPr/>
+      </p:sp>
+    </p:spTree>
+  </p:cSld>
+  <p:clrMapOvr>
+    <a:masterClrMapping/>
+  </p:clrMapOvr>
+</p:notes>
+</file>
+
+<file path=ppt/notesSlides/notesSlide17.xml><?xml version="1.0" encoding="utf-8"?>
+<p:notes xmlns:a="http://schemas.openxmlformats.org/drawingml/2006/main" xmlns:p="http://schemas.openxmlformats.org/presentationml/2006/main" xmlns:r="http://schemas.openxmlformats.org/officeDocument/2006/relationships">
+  <p:cSld>
+    <p:spTree>
+      <p:nvGrpSpPr>
+        <p:cNvPr id="1" name=""/>
+        <p:cNvGrpSpPr/>
+        <p:nvPr/>
+      </p:nvGrpSpPr>
+      <p:grpSpPr>
+        <a:xfrm>
+          <a:off x="0" y="0"/>
+          <a:ext cx="0" cy="0"/>
+          <a:chOff x="0" y="0"/>
+          <a:chExt cx="0" cy="0"/>
+        </a:xfrm>
+      </p:grpSpPr>
+      <p:sp>
+        <p:nvSpPr>
+          <p:cNvPr id="2" name="Slide Image Placeholder 1"/>
+          <p:cNvSpPr>
+            <a:spLocks noGrp="1"/>
+          </p:cNvSpPr>
+          <p:nvPr>
+            <p:ph type="sldImg" idx="2"/>
+          </p:nvPr>
+        </p:nvSpPr>
+        <p:spPr/>
+      </p:sp>
+      <p:sp>
+        <p:nvSpPr>
+          <p:cNvPr id="3" name="Notes Placeholder 2"/>
+          <p:cNvSpPr>
+            <a:spLocks noGrp="1"/>
+          </p:cNvSpPr>
+          <p:nvPr>
+            <p:ph type="body" idx="3" sz="quarter"/>
+          </p:nvPr>
+        </p:nvSpPr>
+        <p:spPr/>
+        <p:txBody>
+          <a:bodyPr/>
+          <a:lstStyle/>
+          <a:p>
+            <a:r>
+              <a:t>Katalogdaki dört satırı kısa yorumla. Özellikle S2'nin runtime yaratmadığını, S3'ün ProductSum sıfır olduğu için inert kaldığını ve S4'ün makine OEE'sine yazılmadığını söyle.</a:t>
+            </a:r>
+          </a:p>
+        </p:txBody>
+      </p:sp>
+      <p:sp>
+        <p:nvSpPr>
+          <p:cNvPr id="4" name="Slide Number Placeholder 3"/>
+          <p:cNvSpPr>
+            <a:spLocks noGrp="1"/>
+          </p:cNvSpPr>
+          <p:nvPr>
+            <p:ph type="sldNum" idx="5" sz="quarter"/>
+          </p:nvPr>
+        </p:nvSpPr>
+        <p:spPr/>
+      </p:sp>
+    </p:spTree>
+  </p:cSld>
+  <p:clrMapOvr>
+    <a:masterClrMapping/>
+  </p:clrMapOvr>
+</p:notes>
+</file>
+
+<file path=ppt/notesSlides/notesSlide18.xml><?xml version="1.0" encoding="utf-8"?>
+<p:notes xmlns:a="http://schemas.openxmlformats.org/drawingml/2006/main" xmlns:p="http://schemas.openxmlformats.org/presentationml/2006/main" xmlns:r="http://schemas.openxmlformats.org/officeDocument/2006/relationships">
+  <p:cSld>
+    <p:spTree>
+      <p:nvGrpSpPr>
+        <p:cNvPr id="1" name=""/>
+        <p:cNvGrpSpPr/>
+        <p:nvPr/>
+      </p:nvGrpSpPr>
+      <p:grpSpPr>
+        <a:xfrm>
+          <a:off x="0" y="0"/>
+          <a:ext cx="0" cy="0"/>
+          <a:chOff x="0" y="0"/>
+          <a:chExt cx="0" cy="0"/>
+        </a:xfrm>
+      </p:grpSpPr>
+      <p:sp>
+        <p:nvSpPr>
+          <p:cNvPr id="2" name="Slide Image Placeholder 1"/>
+          <p:cNvSpPr>
+            <a:spLocks noGrp="1"/>
+          </p:cNvSpPr>
+          <p:nvPr>
+            <p:ph type="sldImg" idx="2"/>
+          </p:nvPr>
+        </p:nvSpPr>
+        <p:spPr/>
+      </p:sp>
+      <p:sp>
+        <p:nvSpPr>
+          <p:cNvPr id="3" name="Notes Placeholder 2"/>
+          <p:cNvSpPr>
+            <a:spLocks noGrp="1"/>
+          </p:cNvSpPr>
+          <p:nvPr>
+            <p:ph type="body" idx="3" sz="quarter"/>
+          </p:nvPr>
+        </p:nvSpPr>
+        <p:spPr/>
+        <p:txBody>
+          <a:bodyPr/>
+          <a:lstStyle/>
+          <a:p>
+            <a:r>
+              <a:t>Bu ekranı soru gelirse aç. Eski yöntemin totolojisini, null-model destekli senkronizasyonu, veri rejimlerini ve kümenin dürüst yorumunu tek ekranda gösterir.</a:t>
             </a:r>
           </a:p>
         </p:txBody>
@@ -5418,6 +5915,3928 @@
 </p:sld>
 </file>
 
+<file path=ppt/slides/slide12.xml><?xml version="1.0" encoding="utf-8"?>
+<p:sld xmlns:a="http://schemas.openxmlformats.org/drawingml/2006/main" xmlns:p="http://schemas.openxmlformats.org/presentationml/2006/main" xmlns:r="http://schemas.openxmlformats.org/officeDocument/2006/relationships">
+  <p:cSld>
+    <p:spTree>
+      <p:nvGrpSpPr>
+        <p:cNvPr id="1" name=""/>
+        <p:cNvGrpSpPr/>
+        <p:nvPr/>
+      </p:nvGrpSpPr>
+      <p:grpSpPr/>
+      <p:sp>
+        <p:nvSpPr>
+          <p:cNvPr id="2" name="Rectangle 1"/>
+          <p:cNvSpPr/>
+          <p:nvPr/>
+        </p:nvSpPr>
+        <p:spPr>
+          <a:xfrm>
+            <a:off x="0" y="0"/>
+            <a:ext cx="128016" cy="6858000"/>
+          </a:xfrm>
+          <a:prstGeom prst="rect">
+            <a:avLst/>
+          </a:prstGeom>
+          <a:solidFill>
+            <a:srgbClr val="127145"/>
+          </a:solidFill>
+          <a:ln>
+            <a:noFill/>
+          </a:ln>
+          <a:effectLst/>
+        </p:spPr>
+        <p:style>
+          <a:lnRef idx="1">
+            <a:schemeClr val="accent1"/>
+          </a:lnRef>
+          <a:fillRef idx="3">
+            <a:schemeClr val="accent1"/>
+          </a:fillRef>
+          <a:effectRef idx="2">
+            <a:schemeClr val="accent1"/>
+          </a:effectRef>
+          <a:fontRef idx="minor">
+            <a:schemeClr val="lt1"/>
+          </a:fontRef>
+        </p:style>
+        <p:txBody>
+          <a:bodyPr rtlCol="0" anchor="ctr"/>
+          <a:lstStyle/>
+          <a:p>
+            <a:pPr algn="ctr"/>
+          </a:p>
+        </p:txBody>
+      </p:sp>
+      <p:sp>
+        <p:nvSpPr>
+          <p:cNvPr id="3" name="TextBox 2"/>
+          <p:cNvSpPr txBox="1"/>
+          <p:nvPr/>
+        </p:nvSpPr>
+        <p:spPr>
+          <a:xfrm>
+            <a:off x="777240" y="475488"/>
+            <a:ext cx="10637215" cy="274320"/>
+          </a:xfrm>
+          <a:prstGeom prst="rect">
+            <a:avLst/>
+          </a:prstGeom>
+          <a:noFill/>
+        </p:spPr>
+        <p:txBody>
+          <a:bodyPr wrap="square" anchor="t" lIns="0" rIns="0" tIns="0" bIns="0">
+            <a:spAutoFit/>
+          </a:bodyPr>
+          <a:lstStyle/>
+          <a:p>
+            <a:pPr algn="l">
+              <a:lnSpc>
+                <a:spcPct val="112000"/>
+              </a:lnSpc>
+              <a:spcAft>
+                <a:spcPts val="800"/>
+              </a:spcAft>
+            </a:pPr>
+            <a:r>
+              <a:rPr sz="1150" b="1">
+                <a:solidFill>
+                  <a:srgbClr val="127145"/>
+                </a:solidFill>
+                <a:latin typeface="Helvetica Neue"/>
+              </a:rPr>
+              <a:t>CANLI ARAYÜZ REHBERI</a:t>
+            </a:r>
+          </a:p>
+        </p:txBody>
+      </p:sp>
+      <p:sp>
+        <p:nvSpPr>
+          <p:cNvPr id="4" name="TextBox 3"/>
+          <p:cNvSpPr txBox="1"/>
+          <p:nvPr/>
+        </p:nvSpPr>
+        <p:spPr>
+          <a:xfrm>
+            <a:off x="777240" y="841248"/>
+            <a:ext cx="10637215" cy="868680"/>
+          </a:xfrm>
+          <a:prstGeom prst="rect">
+            <a:avLst/>
+          </a:prstGeom>
+          <a:noFill/>
+        </p:spPr>
+        <p:txBody>
+          <a:bodyPr wrap="square" anchor="t" lIns="0" rIns="0" tIns="0" bIns="0">
+            <a:spAutoFit/>
+          </a:bodyPr>
+          <a:lstStyle/>
+          <a:p>
+            <a:pPr algn="l">
+              <a:lnSpc>
+                <a:spcPct val="102000"/>
+              </a:lnSpc>
+              <a:spcAft>
+                <a:spcPts val="800"/>
+              </a:spcAft>
+            </a:pPr>
+            <a:r>
+              <a:rPr sz="2900" b="1">
+                <a:solidFill>
+                  <a:srgbClr val="1A1F1D"/>
+                </a:solidFill>
+                <a:latin typeface="Helvetica Neue"/>
+              </a:rPr>
+              <a:t>Genel Bakış — tesis ve makine resmi</a:t>
+            </a:r>
+          </a:p>
+        </p:txBody>
+      </p:sp>
+      <p:sp>
+        <p:nvSpPr>
+          <p:cNvPr id="5" name="Rectangle 4"/>
+          <p:cNvSpPr/>
+          <p:nvPr/>
+        </p:nvSpPr>
+        <p:spPr>
+          <a:xfrm>
+            <a:off x="777240" y="1755648"/>
+            <a:ext cx="10637215" cy="10972"/>
+          </a:xfrm>
+          <a:prstGeom prst="rect">
+            <a:avLst/>
+          </a:prstGeom>
+          <a:solidFill>
+            <a:srgbClr val="D9DFDB"/>
+          </a:solidFill>
+          <a:ln>
+            <a:noFill/>
+          </a:ln>
+          <a:effectLst/>
+        </p:spPr>
+        <p:style>
+          <a:lnRef idx="1">
+            <a:schemeClr val="accent1"/>
+          </a:lnRef>
+          <a:fillRef idx="3">
+            <a:schemeClr val="accent1"/>
+          </a:fillRef>
+          <a:effectRef idx="2">
+            <a:schemeClr val="accent1"/>
+          </a:effectRef>
+          <a:fontRef idx="minor">
+            <a:schemeClr val="lt1"/>
+          </a:fontRef>
+        </p:style>
+        <p:txBody>
+          <a:bodyPr rtlCol="0" anchor="ctr"/>
+          <a:lstStyle/>
+          <a:p>
+            <a:pPr algn="ctr"/>
+          </a:p>
+        </p:txBody>
+      </p:sp>
+      <p:sp>
+        <p:nvSpPr>
+          <p:cNvPr id="6" name="TextBox 5"/>
+          <p:cNvSpPr txBox="1"/>
+          <p:nvPr/>
+        </p:nvSpPr>
+        <p:spPr>
+          <a:xfrm>
+            <a:off x="777240" y="6437376"/>
+            <a:ext cx="10088575" cy="274320"/>
+          </a:xfrm>
+          <a:prstGeom prst="rect">
+            <a:avLst/>
+          </a:prstGeom>
+          <a:noFill/>
+        </p:spPr>
+        <p:txBody>
+          <a:bodyPr wrap="square" anchor="t" lIns="0" rIns="0" tIns="0" bIns="0">
+            <a:spAutoFit/>
+          </a:bodyPr>
+          <a:lstStyle/>
+          <a:p>
+            <a:pPr algn="l">
+              <a:lnSpc>
+                <a:spcPct val="112000"/>
+              </a:lnSpc>
+              <a:spcAft>
+                <a:spcPts val="800"/>
+              </a:spcAft>
+            </a:pPr>
+            <a:r>
+              <a:rPr sz="900" b="0">
+                <a:solidFill>
+                  <a:srgbClr val="6B7771"/>
+                </a:solidFill>
+                <a:latin typeface="Helvetica Neue"/>
+              </a:rPr>
+              <a:t>trexCloud · Öngörücü OEE &amp; Kök-Neden Analizi</a:t>
+            </a:r>
+          </a:p>
+        </p:txBody>
+      </p:sp>
+      <p:sp>
+        <p:nvSpPr>
+          <p:cNvPr id="7" name="TextBox 6"/>
+          <p:cNvSpPr txBox="1"/>
+          <p:nvPr/>
+        </p:nvSpPr>
+        <p:spPr>
+          <a:xfrm>
+            <a:off x="10911535" y="6437376"/>
+            <a:ext cx="502920" cy="274320"/>
+          </a:xfrm>
+          <a:prstGeom prst="rect">
+            <a:avLst/>
+          </a:prstGeom>
+          <a:noFill/>
+        </p:spPr>
+        <p:txBody>
+          <a:bodyPr wrap="square" anchor="t" lIns="0" rIns="0" tIns="0" bIns="0">
+            <a:spAutoFit/>
+          </a:bodyPr>
+          <a:lstStyle/>
+          <a:p>
+            <a:pPr algn="r">
+              <a:lnSpc>
+                <a:spcPct val="112000"/>
+              </a:lnSpc>
+              <a:spcAft>
+                <a:spcPts val="800"/>
+              </a:spcAft>
+            </a:pPr>
+            <a:r>
+              <a:rPr sz="900" b="0">
+                <a:solidFill>
+                  <a:srgbClr val="6B7771"/>
+                </a:solidFill>
+                <a:latin typeface="Helvetica Neue"/>
+              </a:rPr>
+              <a:t>12</a:t>
+            </a:r>
+          </a:p>
+        </p:txBody>
+      </p:sp>
+      <p:pic>
+        <p:nvPicPr>
+          <p:cNvPr id="8" name="Picture 7" descr="overview_fleet.png"/>
+          <p:cNvPicPr>
+            <a:picLocks noChangeAspect="1"/>
+          </p:cNvPicPr>
+          <p:nvPr/>
+        </p:nvPicPr>
+        <p:blipFill>
+          <a:blip r:embed="rId2"/>
+          <a:stretch>
+            <a:fillRect/>
+          </a:stretch>
+        </p:blipFill>
+        <p:spPr>
+          <a:xfrm>
+            <a:off x="777240" y="2210021"/>
+            <a:ext cx="7269480" cy="3727260"/>
+          </a:xfrm>
+          <a:prstGeom prst="rect">
+            <a:avLst/>
+          </a:prstGeom>
+        </p:spPr>
+      </p:pic>
+      <p:sp>
+        <p:nvSpPr>
+          <p:cNvPr id="9" name="Rectangle 8"/>
+          <p:cNvSpPr/>
+          <p:nvPr/>
+        </p:nvSpPr>
+        <p:spPr>
+          <a:xfrm>
+            <a:off x="8275320" y="1993392"/>
+            <a:ext cx="3136392" cy="4160520"/>
+          </a:xfrm>
+          <a:prstGeom prst="rect">
+            <a:avLst/>
+          </a:prstGeom>
+          <a:solidFill>
+            <a:srgbClr val="ECF4EF"/>
+          </a:solidFill>
+          <a:ln w="13970">
+            <a:solidFill>
+              <a:srgbClr val="127145"/>
+            </a:solidFill>
+          </a:ln>
+          <a:effectLst/>
+        </p:spPr>
+        <p:style>
+          <a:lnRef idx="1">
+            <a:schemeClr val="accent1"/>
+          </a:lnRef>
+          <a:fillRef idx="3">
+            <a:schemeClr val="accent1"/>
+          </a:fillRef>
+          <a:effectRef idx="2">
+            <a:schemeClr val="accent1"/>
+          </a:effectRef>
+          <a:fontRef idx="minor">
+            <a:schemeClr val="lt1"/>
+          </a:fontRef>
+        </p:style>
+        <p:txBody>
+          <a:bodyPr rtlCol="0" anchor="ctr"/>
+          <a:lstStyle/>
+          <a:p>
+            <a:pPr algn="ctr"/>
+          </a:p>
+        </p:txBody>
+      </p:sp>
+      <p:sp>
+        <p:nvSpPr>
+          <p:cNvPr id="10" name="TextBox 9"/>
+          <p:cNvSpPr txBox="1"/>
+          <p:nvPr/>
+        </p:nvSpPr>
+        <p:spPr>
+          <a:xfrm>
+            <a:off x="8503920" y="2267712"/>
+            <a:ext cx="2697480" cy="320040"/>
+          </a:xfrm>
+          <a:prstGeom prst="rect">
+            <a:avLst/>
+          </a:prstGeom>
+          <a:noFill/>
+        </p:spPr>
+        <p:txBody>
+          <a:bodyPr wrap="square" anchor="t" lIns="0" rIns="0" tIns="0" bIns="0">
+            <a:spAutoFit/>
+          </a:bodyPr>
+          <a:lstStyle/>
+          <a:p>
+            <a:pPr algn="l">
+              <a:lnSpc>
+                <a:spcPct val="112000"/>
+              </a:lnSpc>
+              <a:spcAft>
+                <a:spcPts val="800"/>
+              </a:spcAft>
+            </a:pPr>
+            <a:r>
+              <a:rPr sz="1100" b="1">
+                <a:solidFill>
+                  <a:srgbClr val="127145"/>
+                </a:solidFill>
+                <a:latin typeface="Helvetica Neue"/>
+              </a:rPr>
+              <a:t>NASIL OKUNUR?</a:t>
+            </a:r>
+          </a:p>
+        </p:txBody>
+      </p:sp>
+      <p:sp>
+        <p:nvSpPr>
+          <p:cNvPr id="11" name="TextBox 10"/>
+          <p:cNvSpPr txBox="1"/>
+          <p:nvPr/>
+        </p:nvSpPr>
+        <p:spPr>
+          <a:xfrm>
+            <a:off x="8503920" y="2743200"/>
+            <a:ext cx="2651760" cy="3291840"/>
+          </a:xfrm>
+          <a:prstGeom prst="rect">
+            <a:avLst/>
+          </a:prstGeom>
+          <a:noFill/>
+        </p:spPr>
+        <p:txBody>
+          <a:bodyPr wrap="square" lIns="0" rIns="0" tIns="0">
+            <a:spAutoFit/>
+          </a:bodyPr>
+          <a:lstStyle/>
+          <a:p>
+            <a:pPr>
+              <a:lnSpc>
+                <a:spcPct val="116000"/>
+              </a:lnSpc>
+              <a:spcAft>
+                <a:spcPts val="800"/>
+              </a:spcAft>
+            </a:pPr>
+            <a:r>
+              <a:rPr sz="1150" b="1">
+                <a:solidFill>
+                  <a:srgbClr val="127145"/>
+                </a:solidFill>
+                <a:latin typeface="Helvetica Neue"/>
+              </a:rPr>
+              <a:t>—  </a:t>
+            </a:r>
+            <a:r>
+              <a:rPr sz="1150" b="1">
+                <a:solidFill>
+                  <a:srgbClr val="1A1F1D"/>
+                </a:solidFill>
+                <a:latin typeface="Helvetica Neue"/>
+              </a:rPr>
+              <a:t>Üst KPI'lar:</a:t>
+            </a:r>
+            <a:r>
+              <a:rPr sz="1150" b="0">
+                <a:solidFill>
+                  <a:srgbClr val="1A1F1D"/>
+                </a:solidFill>
+                <a:latin typeface="Helvetica Neue"/>
+              </a:rPr>
+              <a:t> tesis OEE'si, toplam plansız duruş ve Fanuc tahmin lift'i.</a:t>
+            </a:r>
+          </a:p>
+          <a:p>
+            <a:pPr>
+              <a:lnSpc>
+                <a:spcPct val="116000"/>
+              </a:lnSpc>
+              <a:spcAft>
+                <a:spcPts val="800"/>
+              </a:spcAft>
+            </a:pPr>
+            <a:r>
+              <a:rPr sz="1150" b="1">
+                <a:solidFill>
+                  <a:srgbClr val="127145"/>
+                </a:solidFill>
+                <a:latin typeface="Helvetica Neue"/>
+              </a:rPr>
+              <a:t>—  </a:t>
+            </a:r>
+            <a:r>
+              <a:rPr sz="1150" b="1">
+                <a:solidFill>
+                  <a:srgbClr val="1A1F1D"/>
+                </a:solidFill>
+                <a:latin typeface="Helvetica Neue"/>
+              </a:rPr>
+              <a:t>Makine kartları:</a:t>
+            </a:r>
+            <a:r>
+              <a:rPr sz="1150" b="0">
+                <a:solidFill>
+                  <a:srgbClr val="1A1F1D"/>
+                </a:solidFill>
+                <a:latin typeface="Helvetica Neue"/>
+              </a:rPr>
+              <a:t> renk rejimi, yüzde OEE'yi; alt satır duruş saatini gösterir.</a:t>
+            </a:r>
+          </a:p>
+          <a:p>
+            <a:pPr>
+              <a:lnSpc>
+                <a:spcPct val="116000"/>
+              </a:lnSpc>
+              <a:spcAft>
+                <a:spcPts val="800"/>
+              </a:spcAft>
+            </a:pPr>
+            <a:r>
+              <a:rPr sz="1150" b="1">
+                <a:solidFill>
+                  <a:srgbClr val="127145"/>
+                </a:solidFill>
+                <a:latin typeface="Helvetica Neue"/>
+              </a:rPr>
+              <a:t>—  </a:t>
+            </a:r>
+            <a:r>
+              <a:rPr sz="1150" b="1">
+                <a:solidFill>
+                  <a:srgbClr val="1A1F1D"/>
+                </a:solidFill>
+                <a:latin typeface="Helvetica Neue"/>
+              </a:rPr>
+              <a:t>Sağ panel:</a:t>
+            </a:r>
+            <a:r>
+              <a:rPr sz="1150" b="0">
+                <a:solidFill>
+                  <a:srgbClr val="1A1F1D"/>
+                </a:solidFill>
+                <a:latin typeface="Helvetica Neue"/>
+              </a:rPr>
+              <a:t> seçilen makinenin A/P/Q ayrışımı ve modelleme rejimi.</a:t>
+            </a:r>
+          </a:p>
+        </p:txBody>
+      </p:sp>
+    </p:spTree>
+  </p:cSld>
+  <p:clrMapOvr>
+    <a:masterClrMapping/>
+  </p:clrMapOvr>
+</p:sld>
+</file>
+
+<file path=ppt/slides/slide13.xml><?xml version="1.0" encoding="utf-8"?>
+<p:sld xmlns:a="http://schemas.openxmlformats.org/drawingml/2006/main" xmlns:p="http://schemas.openxmlformats.org/presentationml/2006/main" xmlns:r="http://schemas.openxmlformats.org/officeDocument/2006/relationships">
+  <p:cSld>
+    <p:spTree>
+      <p:nvGrpSpPr>
+        <p:cNvPr id="1" name=""/>
+        <p:cNvGrpSpPr/>
+        <p:nvPr/>
+      </p:nvGrpSpPr>
+      <p:grpSpPr/>
+      <p:sp>
+        <p:nvSpPr>
+          <p:cNvPr id="2" name="Rectangle 1"/>
+          <p:cNvSpPr/>
+          <p:nvPr/>
+        </p:nvSpPr>
+        <p:spPr>
+          <a:xfrm>
+            <a:off x="0" y="0"/>
+            <a:ext cx="128016" cy="6858000"/>
+          </a:xfrm>
+          <a:prstGeom prst="rect">
+            <a:avLst/>
+          </a:prstGeom>
+          <a:solidFill>
+            <a:srgbClr val="127145"/>
+          </a:solidFill>
+          <a:ln>
+            <a:noFill/>
+          </a:ln>
+          <a:effectLst/>
+        </p:spPr>
+        <p:style>
+          <a:lnRef idx="1">
+            <a:schemeClr val="accent1"/>
+          </a:lnRef>
+          <a:fillRef idx="3">
+            <a:schemeClr val="accent1"/>
+          </a:fillRef>
+          <a:effectRef idx="2">
+            <a:schemeClr val="accent1"/>
+          </a:effectRef>
+          <a:fontRef idx="minor">
+            <a:schemeClr val="lt1"/>
+          </a:fontRef>
+        </p:style>
+        <p:txBody>
+          <a:bodyPr rtlCol="0" anchor="ctr"/>
+          <a:lstStyle/>
+          <a:p>
+            <a:pPr algn="ctr"/>
+          </a:p>
+        </p:txBody>
+      </p:sp>
+      <p:sp>
+        <p:nvSpPr>
+          <p:cNvPr id="3" name="TextBox 2"/>
+          <p:cNvSpPr txBox="1"/>
+          <p:nvPr/>
+        </p:nvSpPr>
+        <p:spPr>
+          <a:xfrm>
+            <a:off x="777240" y="475488"/>
+            <a:ext cx="10637215" cy="274320"/>
+          </a:xfrm>
+          <a:prstGeom prst="rect">
+            <a:avLst/>
+          </a:prstGeom>
+          <a:noFill/>
+        </p:spPr>
+        <p:txBody>
+          <a:bodyPr wrap="square" anchor="t" lIns="0" rIns="0" tIns="0" bIns="0">
+            <a:spAutoFit/>
+          </a:bodyPr>
+          <a:lstStyle/>
+          <a:p>
+            <a:pPr algn="l">
+              <a:lnSpc>
+                <a:spcPct val="112000"/>
+              </a:lnSpc>
+              <a:spcAft>
+                <a:spcPts val="800"/>
+              </a:spcAft>
+            </a:pPr>
+            <a:r>
+              <a:rPr sz="1150" b="1">
+                <a:solidFill>
+                  <a:srgbClr val="127145"/>
+                </a:solidFill>
+                <a:latin typeface="Helvetica Neue"/>
+              </a:rPr>
+              <a:t>CANLI ARAYÜZ REHBERI</a:t>
+            </a:r>
+          </a:p>
+        </p:txBody>
+      </p:sp>
+      <p:sp>
+        <p:nvSpPr>
+          <p:cNvPr id="4" name="TextBox 3"/>
+          <p:cNvSpPr txBox="1"/>
+          <p:nvPr/>
+        </p:nvSpPr>
+        <p:spPr>
+          <a:xfrm>
+            <a:off x="777240" y="841248"/>
+            <a:ext cx="10637215" cy="868680"/>
+          </a:xfrm>
+          <a:prstGeom prst="rect">
+            <a:avLst/>
+          </a:prstGeom>
+          <a:noFill/>
+        </p:spPr>
+        <p:txBody>
+          <a:bodyPr wrap="square" anchor="t" lIns="0" rIns="0" tIns="0" bIns="0">
+            <a:spAutoFit/>
+          </a:bodyPr>
+          <a:lstStyle/>
+          <a:p>
+            <a:pPr algn="l">
+              <a:lnSpc>
+                <a:spcPct val="102000"/>
+              </a:lnSpc>
+              <a:spcAft>
+                <a:spcPts val="800"/>
+              </a:spcAft>
+            </a:pPr>
+            <a:r>
+              <a:rPr sz="2900" b="1">
+                <a:solidFill>
+                  <a:srgbClr val="1A1F1D"/>
+                </a:solidFill>
+                <a:latin typeface="Helvetica Neue"/>
+              </a:rPr>
+              <a:t>Pareto — arıza ile bağlantıyı ayır</a:t>
+            </a:r>
+          </a:p>
+        </p:txBody>
+      </p:sp>
+      <p:sp>
+        <p:nvSpPr>
+          <p:cNvPr id="5" name="Rectangle 4"/>
+          <p:cNvSpPr/>
+          <p:nvPr/>
+        </p:nvSpPr>
+        <p:spPr>
+          <a:xfrm>
+            <a:off x="777240" y="1755648"/>
+            <a:ext cx="10637215" cy="10972"/>
+          </a:xfrm>
+          <a:prstGeom prst="rect">
+            <a:avLst/>
+          </a:prstGeom>
+          <a:solidFill>
+            <a:srgbClr val="D9DFDB"/>
+          </a:solidFill>
+          <a:ln>
+            <a:noFill/>
+          </a:ln>
+          <a:effectLst/>
+        </p:spPr>
+        <p:style>
+          <a:lnRef idx="1">
+            <a:schemeClr val="accent1"/>
+          </a:lnRef>
+          <a:fillRef idx="3">
+            <a:schemeClr val="accent1"/>
+          </a:fillRef>
+          <a:effectRef idx="2">
+            <a:schemeClr val="accent1"/>
+          </a:effectRef>
+          <a:fontRef idx="minor">
+            <a:schemeClr val="lt1"/>
+          </a:fontRef>
+        </p:style>
+        <p:txBody>
+          <a:bodyPr rtlCol="0" anchor="ctr"/>
+          <a:lstStyle/>
+          <a:p>
+            <a:pPr algn="ctr"/>
+          </a:p>
+        </p:txBody>
+      </p:sp>
+      <p:sp>
+        <p:nvSpPr>
+          <p:cNvPr id="6" name="TextBox 5"/>
+          <p:cNvSpPr txBox="1"/>
+          <p:nvPr/>
+        </p:nvSpPr>
+        <p:spPr>
+          <a:xfrm>
+            <a:off x="777240" y="6437376"/>
+            <a:ext cx="10088575" cy="274320"/>
+          </a:xfrm>
+          <a:prstGeom prst="rect">
+            <a:avLst/>
+          </a:prstGeom>
+          <a:noFill/>
+        </p:spPr>
+        <p:txBody>
+          <a:bodyPr wrap="square" anchor="t" lIns="0" rIns="0" tIns="0" bIns="0">
+            <a:spAutoFit/>
+          </a:bodyPr>
+          <a:lstStyle/>
+          <a:p>
+            <a:pPr algn="l">
+              <a:lnSpc>
+                <a:spcPct val="112000"/>
+              </a:lnSpc>
+              <a:spcAft>
+                <a:spcPts val="800"/>
+              </a:spcAft>
+            </a:pPr>
+            <a:r>
+              <a:rPr sz="900" b="0">
+                <a:solidFill>
+                  <a:srgbClr val="6B7771"/>
+                </a:solidFill>
+                <a:latin typeface="Helvetica Neue"/>
+              </a:rPr>
+              <a:t>trexCloud · Öngörücü OEE &amp; Kök-Neden Analizi</a:t>
+            </a:r>
+          </a:p>
+        </p:txBody>
+      </p:sp>
+      <p:sp>
+        <p:nvSpPr>
+          <p:cNvPr id="7" name="TextBox 6"/>
+          <p:cNvSpPr txBox="1"/>
+          <p:nvPr/>
+        </p:nvSpPr>
+        <p:spPr>
+          <a:xfrm>
+            <a:off x="10911535" y="6437376"/>
+            <a:ext cx="502920" cy="274320"/>
+          </a:xfrm>
+          <a:prstGeom prst="rect">
+            <a:avLst/>
+          </a:prstGeom>
+          <a:noFill/>
+        </p:spPr>
+        <p:txBody>
+          <a:bodyPr wrap="square" anchor="t" lIns="0" rIns="0" tIns="0" bIns="0">
+            <a:spAutoFit/>
+          </a:bodyPr>
+          <a:lstStyle/>
+          <a:p>
+            <a:pPr algn="r">
+              <a:lnSpc>
+                <a:spcPct val="112000"/>
+              </a:lnSpc>
+              <a:spcAft>
+                <a:spcPts val="800"/>
+              </a:spcAft>
+            </a:pPr>
+            <a:r>
+              <a:rPr sz="900" b="0">
+                <a:solidFill>
+                  <a:srgbClr val="6B7771"/>
+                </a:solidFill>
+                <a:latin typeface="Helvetica Neue"/>
+              </a:rPr>
+              <a:t>13</a:t>
+            </a:r>
+          </a:p>
+        </p:txBody>
+      </p:sp>
+      <p:pic>
+        <p:nvPicPr>
+          <p:cNvPr id="8" name="Picture 7" descr="overview_pareto.png"/>
+          <p:cNvPicPr>
+            <a:picLocks noChangeAspect="1"/>
+          </p:cNvPicPr>
+          <p:nvPr/>
+        </p:nvPicPr>
+        <p:blipFill>
+          <a:blip r:embed="rId2"/>
+          <a:stretch>
+            <a:fillRect/>
+          </a:stretch>
+        </p:blipFill>
+        <p:spPr>
+          <a:xfrm>
+            <a:off x="777240" y="2267711"/>
+            <a:ext cx="7543800" cy="2606040"/>
+          </a:xfrm>
+          <a:prstGeom prst="rect">
+            <a:avLst/>
+          </a:prstGeom>
+        </p:spPr>
+      </p:pic>
+      <p:sp>
+        <p:nvSpPr>
+          <p:cNvPr id="9" name="Rectangle 8"/>
+          <p:cNvSpPr/>
+          <p:nvPr/>
+        </p:nvSpPr>
+        <p:spPr>
+          <a:xfrm>
+            <a:off x="8549640" y="2084831"/>
+            <a:ext cx="2862072" cy="2971800"/>
+          </a:xfrm>
+          <a:prstGeom prst="rect">
+            <a:avLst/>
+          </a:prstGeom>
+          <a:solidFill>
+            <a:srgbClr val="ECF4EF"/>
+          </a:solidFill>
+          <a:ln w="13970">
+            <a:solidFill>
+              <a:srgbClr val="127145"/>
+            </a:solidFill>
+          </a:ln>
+          <a:effectLst/>
+        </p:spPr>
+        <p:style>
+          <a:lnRef idx="1">
+            <a:schemeClr val="accent1"/>
+          </a:lnRef>
+          <a:fillRef idx="3">
+            <a:schemeClr val="accent1"/>
+          </a:fillRef>
+          <a:effectRef idx="2">
+            <a:schemeClr val="accent1"/>
+          </a:effectRef>
+          <a:fontRef idx="minor">
+            <a:schemeClr val="lt1"/>
+          </a:fontRef>
+        </p:style>
+        <p:txBody>
+          <a:bodyPr rtlCol="0" anchor="ctr"/>
+          <a:lstStyle/>
+          <a:p>
+            <a:pPr algn="ctr"/>
+          </a:p>
+        </p:txBody>
+      </p:sp>
+      <p:sp>
+        <p:nvSpPr>
+          <p:cNvPr id="10" name="TextBox 9"/>
+          <p:cNvSpPr txBox="1"/>
+          <p:nvPr/>
+        </p:nvSpPr>
+        <p:spPr>
+          <a:xfrm>
+            <a:off x="8778240" y="2331720"/>
+            <a:ext cx="2423160" cy="320040"/>
+          </a:xfrm>
+          <a:prstGeom prst="rect">
+            <a:avLst/>
+          </a:prstGeom>
+          <a:noFill/>
+        </p:spPr>
+        <p:txBody>
+          <a:bodyPr wrap="square" anchor="t" lIns="0" rIns="0" tIns="0" bIns="0">
+            <a:spAutoFit/>
+          </a:bodyPr>
+          <a:lstStyle/>
+          <a:p>
+            <a:pPr algn="l">
+              <a:lnSpc>
+                <a:spcPct val="112000"/>
+              </a:lnSpc>
+              <a:spcAft>
+                <a:spcPts val="800"/>
+              </a:spcAft>
+            </a:pPr>
+            <a:r>
+              <a:rPr sz="1100" b="1">
+                <a:solidFill>
+                  <a:srgbClr val="127145"/>
+                </a:solidFill>
+                <a:latin typeface="Helvetica Neue"/>
+              </a:rPr>
+              <a:t>KARAR MESAJI</a:t>
+            </a:r>
+          </a:p>
+        </p:txBody>
+      </p:sp>
+      <p:sp>
+        <p:nvSpPr>
+          <p:cNvPr id="11" name="TextBox 10"/>
+          <p:cNvSpPr txBox="1"/>
+          <p:nvPr/>
+        </p:nvSpPr>
+        <p:spPr>
+          <a:xfrm>
+            <a:off x="8778240" y="2788920"/>
+            <a:ext cx="2331720" cy="3246120"/>
+          </a:xfrm>
+          <a:prstGeom prst="rect">
+            <a:avLst/>
+          </a:prstGeom>
+          <a:noFill/>
+        </p:spPr>
+        <p:txBody>
+          <a:bodyPr wrap="square" lIns="0" rIns="0" tIns="0">
+            <a:spAutoFit/>
+          </a:bodyPr>
+          <a:lstStyle/>
+          <a:p>
+            <a:pPr>
+              <a:lnSpc>
+                <a:spcPct val="116000"/>
+              </a:lnSpc>
+              <a:spcAft>
+                <a:spcPts val="800"/>
+              </a:spcAft>
+            </a:pPr>
+            <a:r>
+              <a:rPr sz="1150" b="1">
+                <a:solidFill>
+                  <a:srgbClr val="127145"/>
+                </a:solidFill>
+                <a:latin typeface="Helvetica Neue"/>
+              </a:rPr>
+              <a:t>—  </a:t>
+            </a:r>
+            <a:r>
+              <a:rPr sz="1150" b="1">
+                <a:solidFill>
+                  <a:srgbClr val="1A1F1D"/>
+                </a:solidFill>
+                <a:latin typeface="Helvetica Neue"/>
+              </a:rPr>
+              <a:t>Kırmızı:</a:t>
+            </a:r>
+            <a:r>
+              <a:rPr sz="1150" b="0">
+                <a:solidFill>
+                  <a:srgbClr val="1A1F1D"/>
+                </a:solidFill>
+                <a:latin typeface="Helvetica Neue"/>
+              </a:rPr>
+              <a:t> giderilebilir makine duruşu.</a:t>
+            </a:r>
+          </a:p>
+          <a:p>
+            <a:pPr>
+              <a:lnSpc>
+                <a:spcPct val="116000"/>
+              </a:lnSpc>
+              <a:spcAft>
+                <a:spcPts val="800"/>
+              </a:spcAft>
+            </a:pPr>
+            <a:r>
+              <a:rPr sz="1150" b="1">
+                <a:solidFill>
+                  <a:srgbClr val="127145"/>
+                </a:solidFill>
+                <a:latin typeface="Helvetica Neue"/>
+              </a:rPr>
+              <a:t>—  </a:t>
+            </a:r>
+            <a:r>
+              <a:rPr sz="1150" b="1">
+                <a:solidFill>
+                  <a:srgbClr val="1A1F1D"/>
+                </a:solidFill>
+                <a:latin typeface="Helvetica Neue"/>
+              </a:rPr>
+              <a:t>Gri:</a:t>
+            </a:r>
+            <a:r>
+              <a:rPr sz="1150" b="0">
+                <a:solidFill>
+                  <a:srgbClr val="1A1F1D"/>
+                </a:solidFill>
+                <a:latin typeface="Helvetica Neue"/>
+              </a:rPr>
+              <a:t> System Offline; IT/ağ sahipliğinde.</a:t>
+            </a:r>
+          </a:p>
+          <a:p>
+            <a:pPr>
+              <a:lnSpc>
+                <a:spcPct val="116000"/>
+              </a:lnSpc>
+              <a:spcAft>
+                <a:spcPts val="800"/>
+              </a:spcAft>
+            </a:pPr>
+            <a:r>
+              <a:rPr sz="1150" b="1">
+                <a:solidFill>
+                  <a:srgbClr val="127145"/>
+                </a:solidFill>
+                <a:latin typeface="Helvetica Neue"/>
+              </a:rPr>
+              <a:t>—  </a:t>
+            </a:r>
+            <a:r>
+              <a:rPr sz="1150" b="0">
+                <a:solidFill>
+                  <a:srgbClr val="1A1F1D"/>
+                </a:solidFill>
+                <a:latin typeface="Helvetica Neue"/>
+              </a:rPr>
+              <a:t>TurboCut büyük kayıp kaynağıdır fakat telemetrisi yoktur.</a:t>
+            </a:r>
+          </a:p>
+        </p:txBody>
+      </p:sp>
+      <p:sp>
+        <p:nvSpPr>
+          <p:cNvPr id="12" name="Rectangle 11"/>
+          <p:cNvSpPr/>
+          <p:nvPr/>
+        </p:nvSpPr>
+        <p:spPr>
+          <a:xfrm>
+            <a:off x="777240" y="5285232"/>
+            <a:ext cx="10637215" cy="566928"/>
+          </a:xfrm>
+          <a:prstGeom prst="rect">
+            <a:avLst/>
+          </a:prstGeom>
+          <a:solidFill>
+            <a:srgbClr val="ECF4EF"/>
+          </a:solidFill>
+          <a:ln w="13970">
+            <a:solidFill>
+              <a:srgbClr val="127145"/>
+            </a:solidFill>
+          </a:ln>
+          <a:effectLst/>
+        </p:spPr>
+        <p:style>
+          <a:lnRef idx="1">
+            <a:schemeClr val="accent1"/>
+          </a:lnRef>
+          <a:fillRef idx="3">
+            <a:schemeClr val="accent1"/>
+          </a:fillRef>
+          <a:effectRef idx="2">
+            <a:schemeClr val="accent1"/>
+          </a:effectRef>
+          <a:fontRef idx="minor">
+            <a:schemeClr val="lt1"/>
+          </a:fontRef>
+        </p:style>
+        <p:txBody>
+          <a:bodyPr rtlCol="0" anchor="ctr"/>
+          <a:lstStyle/>
+          <a:p>
+            <a:pPr algn="ctr"/>
+          </a:p>
+        </p:txBody>
+      </p:sp>
+      <p:sp>
+        <p:nvSpPr>
+          <p:cNvPr id="13" name="TextBox 12"/>
+          <p:cNvSpPr txBox="1"/>
+          <p:nvPr/>
+        </p:nvSpPr>
+        <p:spPr>
+          <a:xfrm>
+            <a:off x="978408" y="5431536"/>
+            <a:ext cx="10234879" cy="274320"/>
+          </a:xfrm>
+          <a:prstGeom prst="rect">
+            <a:avLst/>
+          </a:prstGeom>
+          <a:noFill/>
+        </p:spPr>
+        <p:txBody>
+          <a:bodyPr wrap="square" anchor="t" lIns="0" rIns="0" tIns="0" bIns="0">
+            <a:spAutoFit/>
+          </a:bodyPr>
+          <a:lstStyle/>
+          <a:p>
+            <a:pPr algn="l">
+              <a:lnSpc>
+                <a:spcPct val="112000"/>
+              </a:lnSpc>
+              <a:spcAft>
+                <a:spcPts val="800"/>
+              </a:spcAft>
+            </a:pPr>
+            <a:r>
+              <a:rPr sz="1150" b="0">
+                <a:solidFill>
+                  <a:srgbClr val="1A1F1D"/>
+                </a:solidFill>
+                <a:latin typeface="Helvetica Neue"/>
+              </a:rPr>
+              <a:t>Sunum cümlesi: “Bağlantı kaybını makine arızası sayarsak yanlış ekibe ve yanlış yatırıma gideriz.”</a:t>
+            </a:r>
+          </a:p>
+        </p:txBody>
+      </p:sp>
+    </p:spTree>
+  </p:cSld>
+  <p:clrMapOvr>
+    <a:masterClrMapping/>
+  </p:clrMapOvr>
+</p:sld>
+</file>
+
+<file path=ppt/slides/slide14.xml><?xml version="1.0" encoding="utf-8"?>
+<p:sld xmlns:a="http://schemas.openxmlformats.org/drawingml/2006/main" xmlns:p="http://schemas.openxmlformats.org/presentationml/2006/main" xmlns:r="http://schemas.openxmlformats.org/officeDocument/2006/relationships">
+  <p:cSld>
+    <p:spTree>
+      <p:nvGrpSpPr>
+        <p:cNvPr id="1" name=""/>
+        <p:cNvGrpSpPr/>
+        <p:nvPr/>
+      </p:nvGrpSpPr>
+      <p:grpSpPr/>
+      <p:sp>
+        <p:nvSpPr>
+          <p:cNvPr id="2" name="Rectangle 1"/>
+          <p:cNvSpPr/>
+          <p:nvPr/>
+        </p:nvSpPr>
+        <p:spPr>
+          <a:xfrm>
+            <a:off x="0" y="0"/>
+            <a:ext cx="128016" cy="6858000"/>
+          </a:xfrm>
+          <a:prstGeom prst="rect">
+            <a:avLst/>
+          </a:prstGeom>
+          <a:solidFill>
+            <a:srgbClr val="127145"/>
+          </a:solidFill>
+          <a:ln>
+            <a:noFill/>
+          </a:ln>
+          <a:effectLst/>
+        </p:spPr>
+        <p:style>
+          <a:lnRef idx="1">
+            <a:schemeClr val="accent1"/>
+          </a:lnRef>
+          <a:fillRef idx="3">
+            <a:schemeClr val="accent1"/>
+          </a:fillRef>
+          <a:effectRef idx="2">
+            <a:schemeClr val="accent1"/>
+          </a:effectRef>
+          <a:fontRef idx="minor">
+            <a:schemeClr val="lt1"/>
+          </a:fontRef>
+        </p:style>
+        <p:txBody>
+          <a:bodyPr rtlCol="0" anchor="ctr"/>
+          <a:lstStyle/>
+          <a:p>
+            <a:pPr algn="ctr"/>
+          </a:p>
+        </p:txBody>
+      </p:sp>
+      <p:sp>
+        <p:nvSpPr>
+          <p:cNvPr id="3" name="TextBox 2"/>
+          <p:cNvSpPr txBox="1"/>
+          <p:nvPr/>
+        </p:nvSpPr>
+        <p:spPr>
+          <a:xfrm>
+            <a:off x="777240" y="475488"/>
+            <a:ext cx="10637215" cy="274320"/>
+          </a:xfrm>
+          <a:prstGeom prst="rect">
+            <a:avLst/>
+          </a:prstGeom>
+          <a:noFill/>
+        </p:spPr>
+        <p:txBody>
+          <a:bodyPr wrap="square" anchor="t" lIns="0" rIns="0" tIns="0" bIns="0">
+            <a:spAutoFit/>
+          </a:bodyPr>
+          <a:lstStyle/>
+          <a:p>
+            <a:pPr algn="l">
+              <a:lnSpc>
+                <a:spcPct val="112000"/>
+              </a:lnSpc>
+              <a:spcAft>
+                <a:spcPts val="800"/>
+              </a:spcAft>
+            </a:pPr>
+            <a:r>
+              <a:rPr sz="1150" b="1">
+                <a:solidFill>
+                  <a:srgbClr val="127145"/>
+                </a:solidFill>
+                <a:latin typeface="Helvetica Neue"/>
+              </a:rPr>
+              <a:t>CANLI ARAYÜZ REHBERI</a:t>
+            </a:r>
+          </a:p>
+        </p:txBody>
+      </p:sp>
+      <p:sp>
+        <p:nvSpPr>
+          <p:cNvPr id="4" name="TextBox 3"/>
+          <p:cNvSpPr txBox="1"/>
+          <p:nvPr/>
+        </p:nvSpPr>
+        <p:spPr>
+          <a:xfrm>
+            <a:off x="777240" y="841248"/>
+            <a:ext cx="10637215" cy="868680"/>
+          </a:xfrm>
+          <a:prstGeom prst="rect">
+            <a:avLst/>
+          </a:prstGeom>
+          <a:noFill/>
+        </p:spPr>
+        <p:txBody>
+          <a:bodyPr wrap="square" anchor="t" lIns="0" rIns="0" tIns="0" bIns="0">
+            <a:spAutoFit/>
+          </a:bodyPr>
+          <a:lstStyle/>
+          <a:p>
+            <a:pPr algn="l">
+              <a:lnSpc>
+                <a:spcPct val="102000"/>
+              </a:lnSpc>
+              <a:spcAft>
+                <a:spcPts val="800"/>
+              </a:spcAft>
+            </a:pPr>
+            <a:r>
+              <a:rPr sz="2900" b="1">
+                <a:solidFill>
+                  <a:srgbClr val="1A1F1D"/>
+                </a:solidFill>
+                <a:latin typeface="Helvetica Neue"/>
+              </a:rPr>
+              <a:t>Tahmin — risk zaman çizgisi ve gerçek duruşlar</a:t>
+            </a:r>
+          </a:p>
+        </p:txBody>
+      </p:sp>
+      <p:sp>
+        <p:nvSpPr>
+          <p:cNvPr id="5" name="Rectangle 4"/>
+          <p:cNvSpPr/>
+          <p:nvPr/>
+        </p:nvSpPr>
+        <p:spPr>
+          <a:xfrm>
+            <a:off x="777240" y="1755648"/>
+            <a:ext cx="10637215" cy="10972"/>
+          </a:xfrm>
+          <a:prstGeom prst="rect">
+            <a:avLst/>
+          </a:prstGeom>
+          <a:solidFill>
+            <a:srgbClr val="D9DFDB"/>
+          </a:solidFill>
+          <a:ln>
+            <a:noFill/>
+          </a:ln>
+          <a:effectLst/>
+        </p:spPr>
+        <p:style>
+          <a:lnRef idx="1">
+            <a:schemeClr val="accent1"/>
+          </a:lnRef>
+          <a:fillRef idx="3">
+            <a:schemeClr val="accent1"/>
+          </a:fillRef>
+          <a:effectRef idx="2">
+            <a:schemeClr val="accent1"/>
+          </a:effectRef>
+          <a:fontRef idx="minor">
+            <a:schemeClr val="lt1"/>
+          </a:fontRef>
+        </p:style>
+        <p:txBody>
+          <a:bodyPr rtlCol="0" anchor="ctr"/>
+          <a:lstStyle/>
+          <a:p>
+            <a:pPr algn="ctr"/>
+          </a:p>
+        </p:txBody>
+      </p:sp>
+      <p:sp>
+        <p:nvSpPr>
+          <p:cNvPr id="6" name="TextBox 5"/>
+          <p:cNvSpPr txBox="1"/>
+          <p:nvPr/>
+        </p:nvSpPr>
+        <p:spPr>
+          <a:xfrm>
+            <a:off x="777240" y="6437376"/>
+            <a:ext cx="10088575" cy="274320"/>
+          </a:xfrm>
+          <a:prstGeom prst="rect">
+            <a:avLst/>
+          </a:prstGeom>
+          <a:noFill/>
+        </p:spPr>
+        <p:txBody>
+          <a:bodyPr wrap="square" anchor="t" lIns="0" rIns="0" tIns="0" bIns="0">
+            <a:spAutoFit/>
+          </a:bodyPr>
+          <a:lstStyle/>
+          <a:p>
+            <a:pPr algn="l">
+              <a:lnSpc>
+                <a:spcPct val="112000"/>
+              </a:lnSpc>
+              <a:spcAft>
+                <a:spcPts val="800"/>
+              </a:spcAft>
+            </a:pPr>
+            <a:r>
+              <a:rPr sz="900" b="0">
+                <a:solidFill>
+                  <a:srgbClr val="6B7771"/>
+                </a:solidFill>
+                <a:latin typeface="Helvetica Neue"/>
+              </a:rPr>
+              <a:t>trexCloud · Öngörücü OEE &amp; Kök-Neden Analizi</a:t>
+            </a:r>
+          </a:p>
+        </p:txBody>
+      </p:sp>
+      <p:sp>
+        <p:nvSpPr>
+          <p:cNvPr id="7" name="TextBox 6"/>
+          <p:cNvSpPr txBox="1"/>
+          <p:nvPr/>
+        </p:nvSpPr>
+        <p:spPr>
+          <a:xfrm>
+            <a:off x="10911535" y="6437376"/>
+            <a:ext cx="502920" cy="274320"/>
+          </a:xfrm>
+          <a:prstGeom prst="rect">
+            <a:avLst/>
+          </a:prstGeom>
+          <a:noFill/>
+        </p:spPr>
+        <p:txBody>
+          <a:bodyPr wrap="square" anchor="t" lIns="0" rIns="0" tIns="0" bIns="0">
+            <a:spAutoFit/>
+          </a:bodyPr>
+          <a:lstStyle/>
+          <a:p>
+            <a:pPr algn="r">
+              <a:lnSpc>
+                <a:spcPct val="112000"/>
+              </a:lnSpc>
+              <a:spcAft>
+                <a:spcPts val="800"/>
+              </a:spcAft>
+            </a:pPr>
+            <a:r>
+              <a:rPr sz="900" b="0">
+                <a:solidFill>
+                  <a:srgbClr val="6B7771"/>
+                </a:solidFill>
+                <a:latin typeface="Helvetica Neue"/>
+              </a:rPr>
+              <a:t>14</a:t>
+            </a:r>
+          </a:p>
+        </p:txBody>
+      </p:sp>
+      <p:pic>
+        <p:nvPicPr>
+          <p:cNvPr id="8" name="Picture 7" descr="predict_risk.png"/>
+          <p:cNvPicPr>
+            <a:picLocks noChangeAspect="1"/>
+          </p:cNvPicPr>
+          <p:nvPr/>
+        </p:nvPicPr>
+        <p:blipFill>
+          <a:blip r:embed="rId2"/>
+          <a:stretch>
+            <a:fillRect/>
+          </a:stretch>
+        </p:blipFill>
+        <p:spPr>
+          <a:xfrm>
+            <a:off x="879799" y="1965960"/>
+            <a:ext cx="7338680" cy="4370832"/>
+          </a:xfrm>
+          <a:prstGeom prst="rect">
+            <a:avLst/>
+          </a:prstGeom>
+        </p:spPr>
+      </p:pic>
+      <p:sp>
+        <p:nvSpPr>
+          <p:cNvPr id="9" name="Rectangle 8"/>
+          <p:cNvSpPr/>
+          <p:nvPr/>
+        </p:nvSpPr>
+        <p:spPr>
+          <a:xfrm>
+            <a:off x="8549640" y="1965960"/>
+            <a:ext cx="2862072" cy="4370832"/>
+          </a:xfrm>
+          <a:prstGeom prst="rect">
+            <a:avLst/>
+          </a:prstGeom>
+          <a:solidFill>
+            <a:srgbClr val="ECF4EF"/>
+          </a:solidFill>
+          <a:ln w="13970">
+            <a:solidFill>
+              <a:srgbClr val="127145"/>
+            </a:solidFill>
+          </a:ln>
+          <a:effectLst/>
+        </p:spPr>
+        <p:style>
+          <a:lnRef idx="1">
+            <a:schemeClr val="accent1"/>
+          </a:lnRef>
+          <a:fillRef idx="3">
+            <a:schemeClr val="accent1"/>
+          </a:fillRef>
+          <a:effectRef idx="2">
+            <a:schemeClr val="accent1"/>
+          </a:effectRef>
+          <a:fontRef idx="minor">
+            <a:schemeClr val="lt1"/>
+          </a:fontRef>
+        </p:style>
+        <p:txBody>
+          <a:bodyPr rtlCol="0" anchor="ctr"/>
+          <a:lstStyle/>
+          <a:p>
+            <a:pPr algn="ctr"/>
+          </a:p>
+        </p:txBody>
+      </p:sp>
+      <p:sp>
+        <p:nvSpPr>
+          <p:cNvPr id="10" name="TextBox 9"/>
+          <p:cNvSpPr txBox="1"/>
+          <p:nvPr/>
+        </p:nvSpPr>
+        <p:spPr>
+          <a:xfrm>
+            <a:off x="8778240" y="2240280"/>
+            <a:ext cx="2423160" cy="320040"/>
+          </a:xfrm>
+          <a:prstGeom prst="rect">
+            <a:avLst/>
+          </a:prstGeom>
+          <a:noFill/>
+        </p:spPr>
+        <p:txBody>
+          <a:bodyPr wrap="square" anchor="t" lIns="0" rIns="0" tIns="0" bIns="0">
+            <a:spAutoFit/>
+          </a:bodyPr>
+          <a:lstStyle/>
+          <a:p>
+            <a:pPr algn="l">
+              <a:lnSpc>
+                <a:spcPct val="112000"/>
+              </a:lnSpc>
+              <a:spcAft>
+                <a:spcPts val="800"/>
+              </a:spcAft>
+            </a:pPr>
+            <a:r>
+              <a:rPr sz="1100" b="1">
+                <a:solidFill>
+                  <a:srgbClr val="127145"/>
+                </a:solidFill>
+                <a:latin typeface="Helvetica Neue"/>
+              </a:rPr>
+              <a:t>NE GÖSTERİYOR?</a:t>
+            </a:r>
+          </a:p>
+        </p:txBody>
+      </p:sp>
+      <p:sp>
+        <p:nvSpPr>
+          <p:cNvPr id="11" name="TextBox 10"/>
+          <p:cNvSpPr txBox="1"/>
+          <p:nvPr/>
+        </p:nvSpPr>
+        <p:spPr>
+          <a:xfrm>
+            <a:off x="8778240" y="2697480"/>
+            <a:ext cx="2331720" cy="3337560"/>
+          </a:xfrm>
+          <a:prstGeom prst="rect">
+            <a:avLst/>
+          </a:prstGeom>
+          <a:noFill/>
+        </p:spPr>
+        <p:txBody>
+          <a:bodyPr wrap="square" lIns="0" rIns="0" tIns="0">
+            <a:spAutoFit/>
+          </a:bodyPr>
+          <a:lstStyle/>
+          <a:p>
+            <a:pPr>
+              <a:lnSpc>
+                <a:spcPct val="116000"/>
+              </a:lnSpc>
+              <a:spcAft>
+                <a:spcPts val="700"/>
+              </a:spcAft>
+            </a:pPr>
+            <a:r>
+              <a:rPr sz="1130" b="1">
+                <a:solidFill>
+                  <a:srgbClr val="127145"/>
+                </a:solidFill>
+                <a:latin typeface="Helvetica Neue"/>
+              </a:rPr>
+              <a:t>—  </a:t>
+            </a:r>
+            <a:r>
+              <a:rPr sz="1130" b="1">
+                <a:solidFill>
+                  <a:srgbClr val="1A1F1D"/>
+                </a:solidFill>
+                <a:latin typeface="Helvetica Neue"/>
+              </a:rPr>
+              <a:t>Yeşil çizgi:</a:t>
+            </a:r>
+            <a:r>
+              <a:rPr sz="1130" b="0">
+                <a:solidFill>
+                  <a:srgbClr val="1A1F1D"/>
+                </a:solidFill>
+                <a:latin typeface="Helvetica Neue"/>
+              </a:rPr>
+              <a:t> modelin duruş riski.</a:t>
+            </a:r>
+          </a:p>
+          <a:p>
+            <a:pPr>
+              <a:lnSpc>
+                <a:spcPct val="116000"/>
+              </a:lnSpc>
+              <a:spcAft>
+                <a:spcPts val="700"/>
+              </a:spcAft>
+            </a:pPr>
+            <a:r>
+              <a:rPr sz="1130" b="1">
+                <a:solidFill>
+                  <a:srgbClr val="127145"/>
+                </a:solidFill>
+                <a:latin typeface="Helvetica Neue"/>
+              </a:rPr>
+              <a:t>—  </a:t>
+            </a:r>
+            <a:r>
+              <a:rPr sz="1130" b="1">
+                <a:solidFill>
+                  <a:srgbClr val="1A1F1D"/>
+                </a:solidFill>
+                <a:latin typeface="Helvetica Neue"/>
+              </a:rPr>
+              <a:t>Kırmızı kesik:</a:t>
+            </a:r>
+            <a:r>
+              <a:rPr sz="1130" b="0">
+                <a:solidFill>
+                  <a:srgbClr val="1A1F1D"/>
+                </a:solidFill>
+                <a:latin typeface="Helvetica Neue"/>
+              </a:rPr>
+              <a:t> denetlenen alarm eşiği 0,1778.</a:t>
+            </a:r>
+          </a:p>
+          <a:p>
+            <a:pPr>
+              <a:lnSpc>
+                <a:spcPct val="116000"/>
+              </a:lnSpc>
+              <a:spcAft>
+                <a:spcPts val="700"/>
+              </a:spcAft>
+            </a:pPr>
+            <a:r>
+              <a:rPr sz="1130" b="1">
+                <a:solidFill>
+                  <a:srgbClr val="127145"/>
+                </a:solidFill>
+                <a:latin typeface="Helvetica Neue"/>
+              </a:rPr>
+              <a:t>—  </a:t>
+            </a:r>
+            <a:r>
+              <a:rPr sz="1130" b="1">
+                <a:solidFill>
+                  <a:srgbClr val="1A1F1D"/>
+                </a:solidFill>
+                <a:latin typeface="Helvetica Neue"/>
+              </a:rPr>
+              <a:t>Kırmızı çarpılar:</a:t>
+            </a:r>
+            <a:r>
+              <a:rPr sz="1130" b="0">
+                <a:solidFill>
+                  <a:srgbClr val="1A1F1D"/>
+                </a:solidFill>
+                <a:latin typeface="Helvetica Neue"/>
+              </a:rPr>
+              <a:t> gerçekleşen ≥15 dk plansız duruşlar.</a:t>
+            </a:r>
+          </a:p>
+          <a:p>
+            <a:pPr>
+              <a:lnSpc>
+                <a:spcPct val="116000"/>
+              </a:lnSpc>
+              <a:spcAft>
+                <a:spcPts val="700"/>
+              </a:spcAft>
+            </a:pPr>
+            <a:r>
+              <a:rPr sz="1130" b="1">
+                <a:solidFill>
+                  <a:srgbClr val="127145"/>
+                </a:solidFill>
+                <a:latin typeface="Helvetica Neue"/>
+              </a:rPr>
+              <a:t>—  </a:t>
+            </a:r>
+            <a:r>
+              <a:rPr sz="1130" b="0">
+                <a:solidFill>
+                  <a:srgbClr val="1A1F1D"/>
+                </a:solidFill>
+                <a:latin typeface="Helvetica Neue"/>
+              </a:rPr>
+              <a:t>Alt kutular, yüksek-risk dönemlerini inceleme sırasına koyar.</a:t>
+            </a:r>
+          </a:p>
+        </p:txBody>
+      </p:sp>
+    </p:spTree>
+  </p:cSld>
+  <p:clrMapOvr>
+    <a:masterClrMapping/>
+  </p:clrMapOvr>
+</p:sld>
+</file>
+
+<file path=ppt/slides/slide15.xml><?xml version="1.0" encoding="utf-8"?>
+<p:sld xmlns:a="http://schemas.openxmlformats.org/drawingml/2006/main" xmlns:p="http://schemas.openxmlformats.org/presentationml/2006/main" xmlns:r="http://schemas.openxmlformats.org/officeDocument/2006/relationships">
+  <p:cSld>
+    <p:spTree>
+      <p:nvGrpSpPr>
+        <p:cNvPr id="1" name=""/>
+        <p:cNvGrpSpPr/>
+        <p:nvPr/>
+      </p:nvGrpSpPr>
+      <p:grpSpPr/>
+      <p:sp>
+        <p:nvSpPr>
+          <p:cNvPr id="2" name="Rectangle 1"/>
+          <p:cNvSpPr/>
+          <p:nvPr/>
+        </p:nvSpPr>
+        <p:spPr>
+          <a:xfrm>
+            <a:off x="0" y="0"/>
+            <a:ext cx="128016" cy="6858000"/>
+          </a:xfrm>
+          <a:prstGeom prst="rect">
+            <a:avLst/>
+          </a:prstGeom>
+          <a:solidFill>
+            <a:srgbClr val="127145"/>
+          </a:solidFill>
+          <a:ln>
+            <a:noFill/>
+          </a:ln>
+          <a:effectLst/>
+        </p:spPr>
+        <p:style>
+          <a:lnRef idx="1">
+            <a:schemeClr val="accent1"/>
+          </a:lnRef>
+          <a:fillRef idx="3">
+            <a:schemeClr val="accent1"/>
+          </a:fillRef>
+          <a:effectRef idx="2">
+            <a:schemeClr val="accent1"/>
+          </a:effectRef>
+          <a:fontRef idx="minor">
+            <a:schemeClr val="lt1"/>
+          </a:fontRef>
+        </p:style>
+        <p:txBody>
+          <a:bodyPr rtlCol="0" anchor="ctr"/>
+          <a:lstStyle/>
+          <a:p>
+            <a:pPr algn="ctr"/>
+          </a:p>
+        </p:txBody>
+      </p:sp>
+      <p:sp>
+        <p:nvSpPr>
+          <p:cNvPr id="3" name="TextBox 2"/>
+          <p:cNvSpPr txBox="1"/>
+          <p:nvPr/>
+        </p:nvSpPr>
+        <p:spPr>
+          <a:xfrm>
+            <a:off x="777240" y="475488"/>
+            <a:ext cx="10637215" cy="274320"/>
+          </a:xfrm>
+          <a:prstGeom prst="rect">
+            <a:avLst/>
+          </a:prstGeom>
+          <a:noFill/>
+        </p:spPr>
+        <p:txBody>
+          <a:bodyPr wrap="square" anchor="t" lIns="0" rIns="0" tIns="0" bIns="0">
+            <a:spAutoFit/>
+          </a:bodyPr>
+          <a:lstStyle/>
+          <a:p>
+            <a:pPr algn="l">
+              <a:lnSpc>
+                <a:spcPct val="112000"/>
+              </a:lnSpc>
+              <a:spcAft>
+                <a:spcPts val="800"/>
+              </a:spcAft>
+            </a:pPr>
+            <a:r>
+              <a:rPr sz="1150" b="1">
+                <a:solidFill>
+                  <a:srgbClr val="127145"/>
+                </a:solidFill>
+                <a:latin typeface="Helvetica Neue"/>
+              </a:rPr>
+              <a:t>CANLI ARAYÜZ REHBERI</a:t>
+            </a:r>
+          </a:p>
+        </p:txBody>
+      </p:sp>
+      <p:sp>
+        <p:nvSpPr>
+          <p:cNvPr id="4" name="TextBox 3"/>
+          <p:cNvSpPr txBox="1"/>
+          <p:nvPr/>
+        </p:nvSpPr>
+        <p:spPr>
+          <a:xfrm>
+            <a:off x="777240" y="841248"/>
+            <a:ext cx="10637215" cy="868680"/>
+          </a:xfrm>
+          <a:prstGeom prst="rect">
+            <a:avLst/>
+          </a:prstGeom>
+          <a:noFill/>
+        </p:spPr>
+        <p:txBody>
+          <a:bodyPr wrap="square" anchor="t" lIns="0" rIns="0" tIns="0" bIns="0">
+            <a:spAutoFit/>
+          </a:bodyPr>
+          <a:lstStyle/>
+          <a:p>
+            <a:pPr algn="l">
+              <a:lnSpc>
+                <a:spcPct val="102000"/>
+              </a:lnSpc>
+              <a:spcAft>
+                <a:spcPts val="800"/>
+              </a:spcAft>
+            </a:pPr>
+            <a:r>
+              <a:rPr sz="2900" b="1">
+                <a:solidFill>
+                  <a:srgbClr val="1A1F1D"/>
+                </a:solidFill>
+                <a:latin typeface="Helvetica Neue"/>
+              </a:rPr>
+              <a:t>Kök-Neden — alarm kaskadından aksiyona</a:t>
+            </a:r>
+          </a:p>
+        </p:txBody>
+      </p:sp>
+      <p:sp>
+        <p:nvSpPr>
+          <p:cNvPr id="5" name="Rectangle 4"/>
+          <p:cNvSpPr/>
+          <p:nvPr/>
+        </p:nvSpPr>
+        <p:spPr>
+          <a:xfrm>
+            <a:off x="777240" y="1755648"/>
+            <a:ext cx="10637215" cy="10972"/>
+          </a:xfrm>
+          <a:prstGeom prst="rect">
+            <a:avLst/>
+          </a:prstGeom>
+          <a:solidFill>
+            <a:srgbClr val="D9DFDB"/>
+          </a:solidFill>
+          <a:ln>
+            <a:noFill/>
+          </a:ln>
+          <a:effectLst/>
+        </p:spPr>
+        <p:style>
+          <a:lnRef idx="1">
+            <a:schemeClr val="accent1"/>
+          </a:lnRef>
+          <a:fillRef idx="3">
+            <a:schemeClr val="accent1"/>
+          </a:fillRef>
+          <a:effectRef idx="2">
+            <a:schemeClr val="accent1"/>
+          </a:effectRef>
+          <a:fontRef idx="minor">
+            <a:schemeClr val="lt1"/>
+          </a:fontRef>
+        </p:style>
+        <p:txBody>
+          <a:bodyPr rtlCol="0" anchor="ctr"/>
+          <a:lstStyle/>
+          <a:p>
+            <a:pPr algn="ctr"/>
+          </a:p>
+        </p:txBody>
+      </p:sp>
+      <p:sp>
+        <p:nvSpPr>
+          <p:cNvPr id="6" name="TextBox 5"/>
+          <p:cNvSpPr txBox="1"/>
+          <p:nvPr/>
+        </p:nvSpPr>
+        <p:spPr>
+          <a:xfrm>
+            <a:off x="777240" y="6437376"/>
+            <a:ext cx="10088575" cy="274320"/>
+          </a:xfrm>
+          <a:prstGeom prst="rect">
+            <a:avLst/>
+          </a:prstGeom>
+          <a:noFill/>
+        </p:spPr>
+        <p:txBody>
+          <a:bodyPr wrap="square" anchor="t" lIns="0" rIns="0" tIns="0" bIns="0">
+            <a:spAutoFit/>
+          </a:bodyPr>
+          <a:lstStyle/>
+          <a:p>
+            <a:pPr algn="l">
+              <a:lnSpc>
+                <a:spcPct val="112000"/>
+              </a:lnSpc>
+              <a:spcAft>
+                <a:spcPts val="800"/>
+              </a:spcAft>
+            </a:pPr>
+            <a:r>
+              <a:rPr sz="900" b="0">
+                <a:solidFill>
+                  <a:srgbClr val="6B7771"/>
+                </a:solidFill>
+                <a:latin typeface="Helvetica Neue"/>
+              </a:rPr>
+              <a:t>trexCloud · Öngörücü OEE &amp; Kök-Neden Analizi</a:t>
+            </a:r>
+          </a:p>
+        </p:txBody>
+      </p:sp>
+      <p:sp>
+        <p:nvSpPr>
+          <p:cNvPr id="7" name="TextBox 6"/>
+          <p:cNvSpPr txBox="1"/>
+          <p:nvPr/>
+        </p:nvSpPr>
+        <p:spPr>
+          <a:xfrm>
+            <a:off x="10911535" y="6437376"/>
+            <a:ext cx="502920" cy="274320"/>
+          </a:xfrm>
+          <a:prstGeom prst="rect">
+            <a:avLst/>
+          </a:prstGeom>
+          <a:noFill/>
+        </p:spPr>
+        <p:txBody>
+          <a:bodyPr wrap="square" anchor="t" lIns="0" rIns="0" tIns="0" bIns="0">
+            <a:spAutoFit/>
+          </a:bodyPr>
+          <a:lstStyle/>
+          <a:p>
+            <a:pPr algn="r">
+              <a:lnSpc>
+                <a:spcPct val="112000"/>
+              </a:lnSpc>
+              <a:spcAft>
+                <a:spcPts val="800"/>
+              </a:spcAft>
+            </a:pPr>
+            <a:r>
+              <a:rPr sz="900" b="0">
+                <a:solidFill>
+                  <a:srgbClr val="6B7771"/>
+                </a:solidFill>
+                <a:latin typeface="Helvetica Neue"/>
+              </a:rPr>
+              <a:t>15</a:t>
+            </a:r>
+          </a:p>
+        </p:txBody>
+      </p:sp>
+      <p:pic>
+        <p:nvPicPr>
+          <p:cNvPr id="8" name="Picture 7" descr="predict_rca.png"/>
+          <p:cNvPicPr>
+            <a:picLocks noChangeAspect="1"/>
+          </p:cNvPicPr>
+          <p:nvPr/>
+        </p:nvPicPr>
+        <p:blipFill>
+          <a:blip r:embed="rId2"/>
+          <a:stretch>
+            <a:fillRect/>
+          </a:stretch>
+        </p:blipFill>
+        <p:spPr>
+          <a:xfrm>
+            <a:off x="777240" y="2092564"/>
+            <a:ext cx="7543800" cy="2773455"/>
+          </a:xfrm>
+          <a:prstGeom prst="rect">
+            <a:avLst/>
+          </a:prstGeom>
+        </p:spPr>
+      </p:pic>
+      <p:sp>
+        <p:nvSpPr>
+          <p:cNvPr id="9" name="Rectangle 8"/>
+          <p:cNvSpPr/>
+          <p:nvPr/>
+        </p:nvSpPr>
+        <p:spPr>
+          <a:xfrm>
+            <a:off x="8549640" y="2084831"/>
+            <a:ext cx="2862072" cy="2788920"/>
+          </a:xfrm>
+          <a:prstGeom prst="rect">
+            <a:avLst/>
+          </a:prstGeom>
+          <a:solidFill>
+            <a:srgbClr val="ECF4EF"/>
+          </a:solidFill>
+          <a:ln w="13970">
+            <a:solidFill>
+              <a:srgbClr val="127145"/>
+            </a:solidFill>
+          </a:ln>
+          <a:effectLst/>
+        </p:spPr>
+        <p:style>
+          <a:lnRef idx="1">
+            <a:schemeClr val="accent1"/>
+          </a:lnRef>
+          <a:fillRef idx="3">
+            <a:schemeClr val="accent1"/>
+          </a:fillRef>
+          <a:effectRef idx="2">
+            <a:schemeClr val="accent1"/>
+          </a:effectRef>
+          <a:fontRef idx="minor">
+            <a:schemeClr val="lt1"/>
+          </a:fontRef>
+        </p:style>
+        <p:txBody>
+          <a:bodyPr rtlCol="0" anchor="ctr"/>
+          <a:lstStyle/>
+          <a:p>
+            <a:pPr algn="ctr"/>
+          </a:p>
+        </p:txBody>
+      </p:sp>
+      <p:sp>
+        <p:nvSpPr>
+          <p:cNvPr id="10" name="TextBox 9"/>
+          <p:cNvSpPr txBox="1"/>
+          <p:nvPr/>
+        </p:nvSpPr>
+        <p:spPr>
+          <a:xfrm>
+            <a:off x="8778240" y="2331720"/>
+            <a:ext cx="2423160" cy="320040"/>
+          </a:xfrm>
+          <a:prstGeom prst="rect">
+            <a:avLst/>
+          </a:prstGeom>
+          <a:noFill/>
+        </p:spPr>
+        <p:txBody>
+          <a:bodyPr wrap="square" anchor="t" lIns="0" rIns="0" tIns="0" bIns="0">
+            <a:spAutoFit/>
+          </a:bodyPr>
+          <a:lstStyle/>
+          <a:p>
+            <a:pPr algn="l">
+              <a:lnSpc>
+                <a:spcPct val="112000"/>
+              </a:lnSpc>
+              <a:spcAft>
+                <a:spcPts val="800"/>
+              </a:spcAft>
+            </a:pPr>
+            <a:r>
+              <a:rPr sz="1100" b="1">
+                <a:solidFill>
+                  <a:srgbClr val="127145"/>
+                </a:solidFill>
+                <a:latin typeface="Helvetica Neue"/>
+              </a:rPr>
+              <a:t>ALTIN AKIŞI</a:t>
+            </a:r>
+          </a:p>
+        </p:txBody>
+      </p:sp>
+      <p:sp>
+        <p:nvSpPr>
+          <p:cNvPr id="11" name="TextBox 10"/>
+          <p:cNvSpPr txBox="1"/>
+          <p:nvPr/>
+        </p:nvSpPr>
+        <p:spPr>
+          <a:xfrm>
+            <a:off x="8778240" y="2743200"/>
+            <a:ext cx="2331720" cy="3291840"/>
+          </a:xfrm>
+          <a:prstGeom prst="rect">
+            <a:avLst/>
+          </a:prstGeom>
+          <a:noFill/>
+        </p:spPr>
+        <p:txBody>
+          <a:bodyPr wrap="square" lIns="0" rIns="0" tIns="0">
+            <a:spAutoFit/>
+          </a:bodyPr>
+          <a:lstStyle/>
+          <a:p>
+            <a:pPr>
+              <a:lnSpc>
+                <a:spcPct val="116000"/>
+              </a:lnSpc>
+              <a:spcAft>
+                <a:spcPts val="700"/>
+              </a:spcAft>
+            </a:pPr>
+            <a:r>
+              <a:rPr sz="1130" b="1">
+                <a:solidFill>
+                  <a:srgbClr val="127145"/>
+                </a:solidFill>
+                <a:latin typeface="Helvetica Neue"/>
+              </a:rPr>
+              <a:t>—  </a:t>
+            </a:r>
+            <a:r>
+              <a:rPr sz="1130" b="0">
+                <a:solidFill>
+                  <a:srgbClr val="1A1F1D"/>
+                </a:solidFill>
+                <a:latin typeface="Helvetica Neue"/>
+              </a:rPr>
+              <a:t>Kaskad nedensel önceliğe göre sıralanır.</a:t>
+            </a:r>
+          </a:p>
+          <a:p>
+            <a:pPr>
+              <a:lnSpc>
+                <a:spcPct val="116000"/>
+              </a:lnSpc>
+              <a:spcAft>
+                <a:spcPts val="700"/>
+              </a:spcAft>
+            </a:pPr>
+            <a:r>
+              <a:rPr sz="1130" b="1">
+                <a:solidFill>
+                  <a:srgbClr val="127145"/>
+                </a:solidFill>
+                <a:latin typeface="Helvetica Neue"/>
+              </a:rPr>
+              <a:t>—  </a:t>
+            </a:r>
+            <a:r>
+              <a:rPr sz="1130" b="1">
+                <a:solidFill>
+                  <a:srgbClr val="1A1F1D"/>
+                </a:solidFill>
+                <a:latin typeface="Helvetica Neue"/>
+              </a:rPr>
+              <a:t>AIR PRESSURE</a:t>
+            </a:r>
+            <a:r>
+              <a:rPr sz="1130" b="0">
+                <a:solidFill>
+                  <a:srgbClr val="1A1F1D"/>
+                </a:solidFill>
+                <a:latin typeface="Helvetica Neue"/>
+              </a:rPr>
+              <a:t> kök neden; Z-axis alarmı sonuçtur.</a:t>
+            </a:r>
+          </a:p>
+          <a:p>
+            <a:pPr>
+              <a:lnSpc>
+                <a:spcPct val="116000"/>
+              </a:lnSpc>
+              <a:spcAft>
+                <a:spcPts val="700"/>
+              </a:spcAft>
+            </a:pPr>
+            <a:r>
+              <a:rPr sz="1130" b="1">
+                <a:solidFill>
+                  <a:srgbClr val="127145"/>
+                </a:solidFill>
+                <a:latin typeface="Helvetica Neue"/>
+              </a:rPr>
+              <a:t>—  </a:t>
+            </a:r>
+            <a:r>
+              <a:rPr sz="1130" b="0">
+                <a:solidFill>
+                  <a:srgbClr val="1A1F1D"/>
+                </a:solidFill>
+                <a:latin typeface="Helvetica Neue"/>
+              </a:rPr>
+              <a:t>Telemetri ve hipotezler önerilen aksiyonu destekler.</a:t>
+            </a:r>
+          </a:p>
+        </p:txBody>
+      </p:sp>
+      <p:sp>
+        <p:nvSpPr>
+          <p:cNvPr id="12" name="Rectangle 11"/>
+          <p:cNvSpPr/>
+          <p:nvPr/>
+        </p:nvSpPr>
+        <p:spPr>
+          <a:xfrm>
+            <a:off x="777240" y="5193792"/>
+            <a:ext cx="10637215" cy="658368"/>
+          </a:xfrm>
+          <a:prstGeom prst="rect">
+            <a:avLst/>
+          </a:prstGeom>
+          <a:solidFill>
+            <a:srgbClr val="ECF4EF"/>
+          </a:solidFill>
+          <a:ln w="13970">
+            <a:solidFill>
+              <a:srgbClr val="127145"/>
+            </a:solidFill>
+          </a:ln>
+          <a:effectLst/>
+        </p:spPr>
+        <p:style>
+          <a:lnRef idx="1">
+            <a:schemeClr val="accent1"/>
+          </a:lnRef>
+          <a:fillRef idx="3">
+            <a:schemeClr val="accent1"/>
+          </a:fillRef>
+          <a:effectRef idx="2">
+            <a:schemeClr val="accent1"/>
+          </a:effectRef>
+          <a:fontRef idx="minor">
+            <a:schemeClr val="lt1"/>
+          </a:fontRef>
+        </p:style>
+        <p:txBody>
+          <a:bodyPr rtlCol="0" anchor="ctr"/>
+          <a:lstStyle/>
+          <a:p>
+            <a:pPr algn="ctr"/>
+          </a:p>
+        </p:txBody>
+      </p:sp>
+      <p:sp>
+        <p:nvSpPr>
+          <p:cNvPr id="13" name="TextBox 12"/>
+          <p:cNvSpPr txBox="1"/>
+          <p:nvPr/>
+        </p:nvSpPr>
+        <p:spPr>
+          <a:xfrm>
+            <a:off x="978408" y="5349240"/>
+            <a:ext cx="10234879" cy="347472"/>
+          </a:xfrm>
+          <a:prstGeom prst="rect">
+            <a:avLst/>
+          </a:prstGeom>
+          <a:noFill/>
+        </p:spPr>
+        <p:txBody>
+          <a:bodyPr wrap="square" anchor="t" lIns="0" rIns="0" tIns="0" bIns="0">
+            <a:spAutoFit/>
+          </a:bodyPr>
+          <a:lstStyle/>
+          <a:p>
+            <a:pPr algn="l">
+              <a:lnSpc>
+                <a:spcPct val="112000"/>
+              </a:lnSpc>
+              <a:spcAft>
+                <a:spcPts val="800"/>
+              </a:spcAft>
+            </a:pPr>
+            <a:r>
+              <a:rPr sz="1150" b="0">
+                <a:solidFill>
+                  <a:srgbClr val="1A1F1D"/>
+                </a:solidFill>
+                <a:latin typeface="Helvetica Neue"/>
+              </a:rPr>
+              <a:t>Sunum cümlesi: “Model yalnız alarm vermiyor; alarmı kanıt, hipotez ve uygulanabilir aksiyona çeviriyor.”</a:t>
+            </a:r>
+          </a:p>
+        </p:txBody>
+      </p:sp>
+    </p:spTree>
+  </p:cSld>
+  <p:clrMapOvr>
+    <a:masterClrMapping/>
+  </p:clrMapOvr>
+</p:sld>
+</file>
+
+<file path=ppt/slides/slide16.xml><?xml version="1.0" encoding="utf-8"?>
+<p:sld xmlns:a="http://schemas.openxmlformats.org/drawingml/2006/main" xmlns:p="http://schemas.openxmlformats.org/presentationml/2006/main" xmlns:r="http://schemas.openxmlformats.org/officeDocument/2006/relationships">
+  <p:cSld>
+    <p:spTree>
+      <p:nvGrpSpPr>
+        <p:cNvPr id="1" name=""/>
+        <p:cNvGrpSpPr/>
+        <p:nvPr/>
+      </p:nvGrpSpPr>
+      <p:grpSpPr/>
+      <p:sp>
+        <p:nvSpPr>
+          <p:cNvPr id="2" name="Rectangle 1"/>
+          <p:cNvSpPr/>
+          <p:nvPr/>
+        </p:nvSpPr>
+        <p:spPr>
+          <a:xfrm>
+            <a:off x="0" y="0"/>
+            <a:ext cx="128016" cy="6858000"/>
+          </a:xfrm>
+          <a:prstGeom prst="rect">
+            <a:avLst/>
+          </a:prstGeom>
+          <a:solidFill>
+            <a:srgbClr val="127145"/>
+          </a:solidFill>
+          <a:ln>
+            <a:noFill/>
+          </a:ln>
+          <a:effectLst/>
+        </p:spPr>
+        <p:style>
+          <a:lnRef idx="1">
+            <a:schemeClr val="accent1"/>
+          </a:lnRef>
+          <a:fillRef idx="3">
+            <a:schemeClr val="accent1"/>
+          </a:fillRef>
+          <a:effectRef idx="2">
+            <a:schemeClr val="accent1"/>
+          </a:effectRef>
+          <a:fontRef idx="minor">
+            <a:schemeClr val="lt1"/>
+          </a:fontRef>
+        </p:style>
+        <p:txBody>
+          <a:bodyPr rtlCol="0" anchor="ctr"/>
+          <a:lstStyle/>
+          <a:p>
+            <a:pPr algn="ctr"/>
+          </a:p>
+        </p:txBody>
+      </p:sp>
+      <p:sp>
+        <p:nvSpPr>
+          <p:cNvPr id="3" name="TextBox 2"/>
+          <p:cNvSpPr txBox="1"/>
+          <p:nvPr/>
+        </p:nvSpPr>
+        <p:spPr>
+          <a:xfrm>
+            <a:off x="777240" y="475488"/>
+            <a:ext cx="10637215" cy="274320"/>
+          </a:xfrm>
+          <a:prstGeom prst="rect">
+            <a:avLst/>
+          </a:prstGeom>
+          <a:noFill/>
+        </p:spPr>
+        <p:txBody>
+          <a:bodyPr wrap="square" anchor="t" lIns="0" rIns="0" tIns="0" bIns="0">
+            <a:spAutoFit/>
+          </a:bodyPr>
+          <a:lstStyle/>
+          <a:p>
+            <a:pPr algn="l">
+              <a:lnSpc>
+                <a:spcPct val="112000"/>
+              </a:lnSpc>
+              <a:spcAft>
+                <a:spcPts val="800"/>
+              </a:spcAft>
+            </a:pPr>
+            <a:r>
+              <a:rPr sz="1150" b="1">
+                <a:solidFill>
+                  <a:srgbClr val="127145"/>
+                </a:solidFill>
+                <a:latin typeface="Helvetica Neue"/>
+              </a:rPr>
+              <a:t>CANLI ARAYÜZ REHBERI</a:t>
+            </a:r>
+          </a:p>
+        </p:txBody>
+      </p:sp>
+      <p:sp>
+        <p:nvSpPr>
+          <p:cNvPr id="4" name="TextBox 3"/>
+          <p:cNvSpPr txBox="1"/>
+          <p:nvPr/>
+        </p:nvSpPr>
+        <p:spPr>
+          <a:xfrm>
+            <a:off x="777240" y="841248"/>
+            <a:ext cx="10637215" cy="868680"/>
+          </a:xfrm>
+          <a:prstGeom prst="rect">
+            <a:avLst/>
+          </a:prstGeom>
+          <a:noFill/>
+        </p:spPr>
+        <p:txBody>
+          <a:bodyPr wrap="square" anchor="t" lIns="0" rIns="0" tIns="0" bIns="0">
+            <a:spAutoFit/>
+          </a:bodyPr>
+          <a:lstStyle/>
+          <a:p>
+            <a:pPr algn="l">
+              <a:lnSpc>
+                <a:spcPct val="102000"/>
+              </a:lnSpc>
+              <a:spcAft>
+                <a:spcPts val="800"/>
+              </a:spcAft>
+            </a:pPr>
+            <a:r>
+              <a:rPr sz="2900" b="1">
+                <a:solidFill>
+                  <a:srgbClr val="1A1F1D"/>
+                </a:solidFill>
+                <a:latin typeface="Helvetica Neue"/>
+              </a:rPr>
+              <a:t>Kestirimci bakım değeri ve What-If</a:t>
+            </a:r>
+          </a:p>
+        </p:txBody>
+      </p:sp>
+      <p:sp>
+        <p:nvSpPr>
+          <p:cNvPr id="5" name="Rectangle 4"/>
+          <p:cNvSpPr/>
+          <p:nvPr/>
+        </p:nvSpPr>
+        <p:spPr>
+          <a:xfrm>
+            <a:off x="777240" y="1755648"/>
+            <a:ext cx="10637215" cy="10972"/>
+          </a:xfrm>
+          <a:prstGeom prst="rect">
+            <a:avLst/>
+          </a:prstGeom>
+          <a:solidFill>
+            <a:srgbClr val="D9DFDB"/>
+          </a:solidFill>
+          <a:ln>
+            <a:noFill/>
+          </a:ln>
+          <a:effectLst/>
+        </p:spPr>
+        <p:style>
+          <a:lnRef idx="1">
+            <a:schemeClr val="accent1"/>
+          </a:lnRef>
+          <a:fillRef idx="3">
+            <a:schemeClr val="accent1"/>
+          </a:fillRef>
+          <a:effectRef idx="2">
+            <a:schemeClr val="accent1"/>
+          </a:effectRef>
+          <a:fontRef idx="minor">
+            <a:schemeClr val="lt1"/>
+          </a:fontRef>
+        </p:style>
+        <p:txBody>
+          <a:bodyPr rtlCol="0" anchor="ctr"/>
+          <a:lstStyle/>
+          <a:p>
+            <a:pPr algn="ctr"/>
+          </a:p>
+        </p:txBody>
+      </p:sp>
+      <p:sp>
+        <p:nvSpPr>
+          <p:cNvPr id="6" name="TextBox 5"/>
+          <p:cNvSpPr txBox="1"/>
+          <p:nvPr/>
+        </p:nvSpPr>
+        <p:spPr>
+          <a:xfrm>
+            <a:off x="777240" y="6437376"/>
+            <a:ext cx="10088575" cy="274320"/>
+          </a:xfrm>
+          <a:prstGeom prst="rect">
+            <a:avLst/>
+          </a:prstGeom>
+          <a:noFill/>
+        </p:spPr>
+        <p:txBody>
+          <a:bodyPr wrap="square" anchor="t" lIns="0" rIns="0" tIns="0" bIns="0">
+            <a:spAutoFit/>
+          </a:bodyPr>
+          <a:lstStyle/>
+          <a:p>
+            <a:pPr algn="l">
+              <a:lnSpc>
+                <a:spcPct val="112000"/>
+              </a:lnSpc>
+              <a:spcAft>
+                <a:spcPts val="800"/>
+              </a:spcAft>
+            </a:pPr>
+            <a:r>
+              <a:rPr sz="900" b="0">
+                <a:solidFill>
+                  <a:srgbClr val="6B7771"/>
+                </a:solidFill>
+                <a:latin typeface="Helvetica Neue"/>
+              </a:rPr>
+              <a:t>trexCloud · Öngörücü OEE &amp; Kök-Neden Analizi</a:t>
+            </a:r>
+          </a:p>
+        </p:txBody>
+      </p:sp>
+      <p:sp>
+        <p:nvSpPr>
+          <p:cNvPr id="7" name="TextBox 6"/>
+          <p:cNvSpPr txBox="1"/>
+          <p:nvPr/>
+        </p:nvSpPr>
+        <p:spPr>
+          <a:xfrm>
+            <a:off x="10911535" y="6437376"/>
+            <a:ext cx="502920" cy="274320"/>
+          </a:xfrm>
+          <a:prstGeom prst="rect">
+            <a:avLst/>
+          </a:prstGeom>
+          <a:noFill/>
+        </p:spPr>
+        <p:txBody>
+          <a:bodyPr wrap="square" anchor="t" lIns="0" rIns="0" tIns="0" bIns="0">
+            <a:spAutoFit/>
+          </a:bodyPr>
+          <a:lstStyle/>
+          <a:p>
+            <a:pPr algn="r">
+              <a:lnSpc>
+                <a:spcPct val="112000"/>
+              </a:lnSpc>
+              <a:spcAft>
+                <a:spcPts val="800"/>
+              </a:spcAft>
+            </a:pPr>
+            <a:r>
+              <a:rPr sz="900" b="0">
+                <a:solidFill>
+                  <a:srgbClr val="6B7771"/>
+                </a:solidFill>
+                <a:latin typeface="Helvetica Neue"/>
+              </a:rPr>
+              <a:t>16</a:t>
+            </a:r>
+          </a:p>
+        </p:txBody>
+      </p:sp>
+      <p:pic>
+        <p:nvPicPr>
+          <p:cNvPr id="8" name="Picture 7" descr="predict_value.png"/>
+          <p:cNvPicPr>
+            <a:picLocks noChangeAspect="1"/>
+          </p:cNvPicPr>
+          <p:nvPr/>
+        </p:nvPicPr>
+        <p:blipFill>
+          <a:blip r:embed="rId2"/>
+          <a:stretch>
+            <a:fillRect/>
+          </a:stretch>
+        </p:blipFill>
+        <p:spPr>
+          <a:xfrm>
+            <a:off x="1046073" y="1965960"/>
+            <a:ext cx="6777532" cy="1993392"/>
+          </a:xfrm>
+          <a:prstGeom prst="rect">
+            <a:avLst/>
+          </a:prstGeom>
+        </p:spPr>
+      </p:pic>
+      <p:pic>
+        <p:nvPicPr>
+          <p:cNvPr id="9" name="Picture 8" descr="predict_whatif.png"/>
+          <p:cNvPicPr>
+            <a:picLocks noChangeAspect="1"/>
+          </p:cNvPicPr>
+          <p:nvPr/>
+        </p:nvPicPr>
+        <p:blipFill>
+          <a:blip r:embed="rId3"/>
+          <a:stretch>
+            <a:fillRect/>
+          </a:stretch>
+        </p:blipFill>
+        <p:spPr>
+          <a:xfrm>
+            <a:off x="847578" y="4133087"/>
+            <a:ext cx="7174523" cy="2057400"/>
+          </a:xfrm>
+          <a:prstGeom prst="rect">
+            <a:avLst/>
+          </a:prstGeom>
+        </p:spPr>
+      </p:pic>
+      <p:sp>
+        <p:nvSpPr>
+          <p:cNvPr id="10" name="Rectangle 9"/>
+          <p:cNvSpPr/>
+          <p:nvPr/>
+        </p:nvSpPr>
+        <p:spPr>
+          <a:xfrm>
+            <a:off x="8321040" y="1965960"/>
+            <a:ext cx="3090672" cy="4224528"/>
+          </a:xfrm>
+          <a:prstGeom prst="rect">
+            <a:avLst/>
+          </a:prstGeom>
+          <a:solidFill>
+            <a:srgbClr val="ECF4EF"/>
+          </a:solidFill>
+          <a:ln w="13970">
+            <a:solidFill>
+              <a:srgbClr val="127145"/>
+            </a:solidFill>
+          </a:ln>
+          <a:effectLst/>
+        </p:spPr>
+        <p:style>
+          <a:lnRef idx="1">
+            <a:schemeClr val="accent1"/>
+          </a:lnRef>
+          <a:fillRef idx="3">
+            <a:schemeClr val="accent1"/>
+          </a:fillRef>
+          <a:effectRef idx="2">
+            <a:schemeClr val="accent1"/>
+          </a:effectRef>
+          <a:fontRef idx="minor">
+            <a:schemeClr val="lt1"/>
+          </a:fontRef>
+        </p:style>
+        <p:txBody>
+          <a:bodyPr rtlCol="0" anchor="ctr"/>
+          <a:lstStyle/>
+          <a:p>
+            <a:pPr algn="ctr"/>
+          </a:p>
+        </p:txBody>
+      </p:sp>
+      <p:sp>
+        <p:nvSpPr>
+          <p:cNvPr id="11" name="TextBox 10"/>
+          <p:cNvSpPr txBox="1"/>
+          <p:nvPr/>
+        </p:nvSpPr>
+        <p:spPr>
+          <a:xfrm>
+            <a:off x="8549640" y="2240280"/>
+            <a:ext cx="2651760" cy="320040"/>
+          </a:xfrm>
+          <a:prstGeom prst="rect">
+            <a:avLst/>
+          </a:prstGeom>
+          <a:noFill/>
+        </p:spPr>
+        <p:txBody>
+          <a:bodyPr wrap="square" anchor="t" lIns="0" rIns="0" tIns="0" bIns="0">
+            <a:spAutoFit/>
+          </a:bodyPr>
+          <a:lstStyle/>
+          <a:p>
+            <a:pPr algn="l">
+              <a:lnSpc>
+                <a:spcPct val="112000"/>
+              </a:lnSpc>
+              <a:spcAft>
+                <a:spcPts val="800"/>
+              </a:spcAft>
+            </a:pPr>
+            <a:r>
+              <a:rPr sz="1100" b="1">
+                <a:solidFill>
+                  <a:srgbClr val="127145"/>
+                </a:solidFill>
+                <a:latin typeface="Helvetica Neue"/>
+              </a:rPr>
+              <a:t>İKİ FARKLI HESAP</a:t>
+            </a:r>
+          </a:p>
+        </p:txBody>
+      </p:sp>
+      <p:sp>
+        <p:nvSpPr>
+          <p:cNvPr id="12" name="TextBox 11"/>
+          <p:cNvSpPr txBox="1"/>
+          <p:nvPr/>
+        </p:nvSpPr>
+        <p:spPr>
+          <a:xfrm>
+            <a:off x="8549640" y="2697480"/>
+            <a:ext cx="2606040" cy="3337560"/>
+          </a:xfrm>
+          <a:prstGeom prst="rect">
+            <a:avLst/>
+          </a:prstGeom>
+          <a:noFill/>
+        </p:spPr>
+        <p:txBody>
+          <a:bodyPr wrap="square" lIns="0" rIns="0" tIns="0">
+            <a:spAutoFit/>
+          </a:bodyPr>
+          <a:lstStyle/>
+          <a:p>
+            <a:pPr>
+              <a:lnSpc>
+                <a:spcPct val="116000"/>
+              </a:lnSpc>
+              <a:spcAft>
+                <a:spcPts val="700"/>
+              </a:spcAft>
+            </a:pPr>
+            <a:r>
+              <a:rPr sz="1115" b="1">
+                <a:solidFill>
+                  <a:srgbClr val="127145"/>
+                </a:solidFill>
+                <a:latin typeface="Helvetica Neue"/>
+              </a:rPr>
+              <a:t>—  </a:t>
+            </a:r>
+            <a:r>
+              <a:rPr sz="1115" b="1">
+                <a:solidFill>
+                  <a:srgbClr val="1A1F1D"/>
+                </a:solidFill>
+                <a:latin typeface="Helvetica Neue"/>
+              </a:rPr>
+              <a:t>Üst panel:</a:t>
+            </a:r>
+            <a:r>
+              <a:rPr sz="1115" b="0">
+                <a:solidFill>
+                  <a:srgbClr val="1A1F1D"/>
+                </a:solidFill>
+                <a:latin typeface="Helvetica Neue"/>
+              </a:rPr>
+              <a:t> yalnız modelin yakaladığı duruşlara atfedilen OEE/€.</a:t>
+            </a:r>
+          </a:p>
+          <a:p>
+            <a:pPr>
+              <a:lnSpc>
+                <a:spcPct val="116000"/>
+              </a:lnSpc>
+              <a:spcAft>
+                <a:spcPts val="700"/>
+              </a:spcAft>
+            </a:pPr>
+            <a:r>
+              <a:rPr sz="1115" b="1">
+                <a:solidFill>
+                  <a:srgbClr val="127145"/>
+                </a:solidFill>
+                <a:latin typeface="Helvetica Neue"/>
+              </a:rPr>
+              <a:t>—  </a:t>
+            </a:r>
+            <a:r>
+              <a:rPr sz="1115" b="0">
+                <a:solidFill>
+                  <a:srgbClr val="1A1F1D"/>
+                </a:solidFill>
+                <a:latin typeface="Helvetica Neue"/>
+              </a:rPr>
+              <a:t>Etkililik ve maliyetler varsayımdır; recall/precision held-out ölçümdür.</a:t>
+            </a:r>
+          </a:p>
+          <a:p>
+            <a:pPr>
+              <a:lnSpc>
+                <a:spcPct val="116000"/>
+              </a:lnSpc>
+              <a:spcAft>
+                <a:spcPts val="700"/>
+              </a:spcAft>
+            </a:pPr>
+            <a:r>
+              <a:rPr sz="1115" b="1">
+                <a:solidFill>
+                  <a:srgbClr val="127145"/>
+                </a:solidFill>
+                <a:latin typeface="Helvetica Neue"/>
+              </a:rPr>
+              <a:t>—  </a:t>
+            </a:r>
+            <a:r>
+              <a:rPr sz="1115" b="1">
+                <a:solidFill>
+                  <a:srgbClr val="1A1F1D"/>
+                </a:solidFill>
+                <a:latin typeface="Helvetica Neue"/>
+              </a:rPr>
+              <a:t>Alt panel:</a:t>
+            </a:r>
+            <a:r>
+              <a:rPr sz="1115" b="0">
+                <a:solidFill>
+                  <a:srgbClr val="1A1F1D"/>
+                </a:solidFill>
+                <a:latin typeface="Helvetica Neue"/>
+              </a:rPr>
+              <a:t> kullanıcı seçtiği duruş azaltımını genel What-If motorunda simüle eder.</a:t>
+            </a:r>
+          </a:p>
+          <a:p>
+            <a:pPr>
+              <a:lnSpc>
+                <a:spcPct val="116000"/>
+              </a:lnSpc>
+              <a:spcAft>
+                <a:spcPts val="700"/>
+              </a:spcAft>
+            </a:pPr>
+            <a:r>
+              <a:rPr sz="1115" b="1">
+                <a:solidFill>
+                  <a:srgbClr val="127145"/>
+                </a:solidFill>
+                <a:latin typeface="Helvetica Neue"/>
+              </a:rPr>
+              <a:t>—  </a:t>
+            </a:r>
+            <a:r>
+              <a:rPr sz="1115" b="0">
+                <a:solidFill>
+                  <a:srgbClr val="1A1F1D"/>
+                </a:solidFill>
+                <a:latin typeface="Helvetica Neue"/>
+              </a:rPr>
+              <a:t>Negatif ROI saklanmaz; alarm maliyeti her gerçek/yanlış alarm için yazılır.</a:t>
+            </a:r>
+          </a:p>
+        </p:txBody>
+      </p:sp>
+    </p:spTree>
+  </p:cSld>
+  <p:clrMapOvr>
+    <a:masterClrMapping/>
+  </p:clrMapOvr>
+</p:sld>
+</file>
+
+<file path=ppt/slides/slide17.xml><?xml version="1.0" encoding="utf-8"?>
+<p:sld xmlns:a="http://schemas.openxmlformats.org/drawingml/2006/main" xmlns:p="http://schemas.openxmlformats.org/presentationml/2006/main" xmlns:r="http://schemas.openxmlformats.org/officeDocument/2006/relationships">
+  <p:cSld>
+    <p:spTree>
+      <p:nvGrpSpPr>
+        <p:cNvPr id="1" name=""/>
+        <p:cNvGrpSpPr/>
+        <p:nvPr/>
+      </p:nvGrpSpPr>
+      <p:grpSpPr/>
+      <p:sp>
+        <p:nvSpPr>
+          <p:cNvPr id="2" name="Rectangle 1"/>
+          <p:cNvSpPr/>
+          <p:nvPr/>
+        </p:nvSpPr>
+        <p:spPr>
+          <a:xfrm>
+            <a:off x="0" y="0"/>
+            <a:ext cx="128016" cy="6858000"/>
+          </a:xfrm>
+          <a:prstGeom prst="rect">
+            <a:avLst/>
+          </a:prstGeom>
+          <a:solidFill>
+            <a:srgbClr val="127145"/>
+          </a:solidFill>
+          <a:ln>
+            <a:noFill/>
+          </a:ln>
+          <a:effectLst/>
+        </p:spPr>
+        <p:style>
+          <a:lnRef idx="1">
+            <a:schemeClr val="accent1"/>
+          </a:lnRef>
+          <a:fillRef idx="3">
+            <a:schemeClr val="accent1"/>
+          </a:fillRef>
+          <a:effectRef idx="2">
+            <a:schemeClr val="accent1"/>
+          </a:effectRef>
+          <a:fontRef idx="minor">
+            <a:schemeClr val="lt1"/>
+          </a:fontRef>
+        </p:style>
+        <p:txBody>
+          <a:bodyPr rtlCol="0" anchor="ctr"/>
+          <a:lstStyle/>
+          <a:p>
+            <a:pPr algn="ctr"/>
+          </a:p>
+        </p:txBody>
+      </p:sp>
+      <p:sp>
+        <p:nvSpPr>
+          <p:cNvPr id="3" name="TextBox 2"/>
+          <p:cNvSpPr txBox="1"/>
+          <p:nvPr/>
+        </p:nvSpPr>
+        <p:spPr>
+          <a:xfrm>
+            <a:off x="777240" y="475488"/>
+            <a:ext cx="10637215" cy="274320"/>
+          </a:xfrm>
+          <a:prstGeom prst="rect">
+            <a:avLst/>
+          </a:prstGeom>
+          <a:noFill/>
+        </p:spPr>
+        <p:txBody>
+          <a:bodyPr wrap="square" anchor="t" lIns="0" rIns="0" tIns="0" bIns="0">
+            <a:spAutoFit/>
+          </a:bodyPr>
+          <a:lstStyle/>
+          <a:p>
+            <a:pPr algn="l">
+              <a:lnSpc>
+                <a:spcPct val="112000"/>
+              </a:lnSpc>
+              <a:spcAft>
+                <a:spcPts val="800"/>
+              </a:spcAft>
+            </a:pPr>
+            <a:r>
+              <a:rPr sz="1150" b="1">
+                <a:solidFill>
+                  <a:srgbClr val="127145"/>
+                </a:solidFill>
+                <a:latin typeface="Helvetica Neue"/>
+              </a:rPr>
+              <a:t>CANLI ARAYÜZ REHBERI</a:t>
+            </a:r>
+          </a:p>
+        </p:txBody>
+      </p:sp>
+      <p:sp>
+        <p:nvSpPr>
+          <p:cNvPr id="4" name="TextBox 3"/>
+          <p:cNvSpPr txBox="1"/>
+          <p:nvPr/>
+        </p:nvSpPr>
+        <p:spPr>
+          <a:xfrm>
+            <a:off x="777240" y="841248"/>
+            <a:ext cx="10637215" cy="868680"/>
+          </a:xfrm>
+          <a:prstGeom prst="rect">
+            <a:avLst/>
+          </a:prstGeom>
+          <a:noFill/>
+        </p:spPr>
+        <p:txBody>
+          <a:bodyPr wrap="square" anchor="t" lIns="0" rIns="0" tIns="0" bIns="0">
+            <a:spAutoFit/>
+          </a:bodyPr>
+          <a:lstStyle/>
+          <a:p>
+            <a:pPr algn="l">
+              <a:lnSpc>
+                <a:spcPct val="102000"/>
+              </a:lnSpc>
+              <a:spcAft>
+                <a:spcPts val="800"/>
+              </a:spcAft>
+            </a:pPr>
+            <a:r>
+              <a:rPr sz="2900" b="1">
+                <a:solidFill>
+                  <a:srgbClr val="1A1F1D"/>
+                </a:solidFill>
+                <a:latin typeface="Helvetica Neue"/>
+              </a:rPr>
+              <a:t>Senaryo kataloğu — sonuçlar denetlenebilir</a:t>
+            </a:r>
+          </a:p>
+        </p:txBody>
+      </p:sp>
+      <p:sp>
+        <p:nvSpPr>
+          <p:cNvPr id="5" name="Rectangle 4"/>
+          <p:cNvSpPr/>
+          <p:nvPr/>
+        </p:nvSpPr>
+        <p:spPr>
+          <a:xfrm>
+            <a:off x="777240" y="1755648"/>
+            <a:ext cx="10637215" cy="10972"/>
+          </a:xfrm>
+          <a:prstGeom prst="rect">
+            <a:avLst/>
+          </a:prstGeom>
+          <a:solidFill>
+            <a:srgbClr val="D9DFDB"/>
+          </a:solidFill>
+          <a:ln>
+            <a:noFill/>
+          </a:ln>
+          <a:effectLst/>
+        </p:spPr>
+        <p:style>
+          <a:lnRef idx="1">
+            <a:schemeClr val="accent1"/>
+          </a:lnRef>
+          <a:fillRef idx="3">
+            <a:schemeClr val="accent1"/>
+          </a:fillRef>
+          <a:effectRef idx="2">
+            <a:schemeClr val="accent1"/>
+          </a:effectRef>
+          <a:fontRef idx="minor">
+            <a:schemeClr val="lt1"/>
+          </a:fontRef>
+        </p:style>
+        <p:txBody>
+          <a:bodyPr rtlCol="0" anchor="ctr"/>
+          <a:lstStyle/>
+          <a:p>
+            <a:pPr algn="ctr"/>
+          </a:p>
+        </p:txBody>
+      </p:sp>
+      <p:sp>
+        <p:nvSpPr>
+          <p:cNvPr id="6" name="TextBox 5"/>
+          <p:cNvSpPr txBox="1"/>
+          <p:nvPr/>
+        </p:nvSpPr>
+        <p:spPr>
+          <a:xfrm>
+            <a:off x="777240" y="6437376"/>
+            <a:ext cx="10088575" cy="274320"/>
+          </a:xfrm>
+          <a:prstGeom prst="rect">
+            <a:avLst/>
+          </a:prstGeom>
+          <a:noFill/>
+        </p:spPr>
+        <p:txBody>
+          <a:bodyPr wrap="square" anchor="t" lIns="0" rIns="0" tIns="0" bIns="0">
+            <a:spAutoFit/>
+          </a:bodyPr>
+          <a:lstStyle/>
+          <a:p>
+            <a:pPr algn="l">
+              <a:lnSpc>
+                <a:spcPct val="112000"/>
+              </a:lnSpc>
+              <a:spcAft>
+                <a:spcPts val="800"/>
+              </a:spcAft>
+            </a:pPr>
+            <a:r>
+              <a:rPr sz="900" b="0">
+                <a:solidFill>
+                  <a:srgbClr val="6B7771"/>
+                </a:solidFill>
+                <a:latin typeface="Helvetica Neue"/>
+              </a:rPr>
+              <a:t>trexCloud · Öngörücü OEE &amp; Kök-Neden Analizi</a:t>
+            </a:r>
+          </a:p>
+        </p:txBody>
+      </p:sp>
+      <p:sp>
+        <p:nvSpPr>
+          <p:cNvPr id="7" name="TextBox 6"/>
+          <p:cNvSpPr txBox="1"/>
+          <p:nvPr/>
+        </p:nvSpPr>
+        <p:spPr>
+          <a:xfrm>
+            <a:off x="10911535" y="6437376"/>
+            <a:ext cx="502920" cy="274320"/>
+          </a:xfrm>
+          <a:prstGeom prst="rect">
+            <a:avLst/>
+          </a:prstGeom>
+          <a:noFill/>
+        </p:spPr>
+        <p:txBody>
+          <a:bodyPr wrap="square" anchor="t" lIns="0" rIns="0" tIns="0" bIns="0">
+            <a:spAutoFit/>
+          </a:bodyPr>
+          <a:lstStyle/>
+          <a:p>
+            <a:pPr algn="r">
+              <a:lnSpc>
+                <a:spcPct val="112000"/>
+              </a:lnSpc>
+              <a:spcAft>
+                <a:spcPts val="800"/>
+              </a:spcAft>
+            </a:pPr>
+            <a:r>
+              <a:rPr sz="900" b="0">
+                <a:solidFill>
+                  <a:srgbClr val="6B7771"/>
+                </a:solidFill>
+                <a:latin typeface="Helvetica Neue"/>
+              </a:rPr>
+              <a:t>17</a:t>
+            </a:r>
+          </a:p>
+        </p:txBody>
+      </p:sp>
+      <p:pic>
+        <p:nvPicPr>
+          <p:cNvPr id="8" name="Picture 7" descr="predict_scenarios.png"/>
+          <p:cNvPicPr>
+            <a:picLocks noChangeAspect="1"/>
+          </p:cNvPicPr>
+          <p:nvPr/>
+        </p:nvPicPr>
+        <p:blipFill>
+          <a:blip r:embed="rId2"/>
+          <a:stretch>
+            <a:fillRect/>
+          </a:stretch>
+        </p:blipFill>
+        <p:spPr>
+          <a:xfrm>
+            <a:off x="785469" y="2057400"/>
+            <a:ext cx="7710220" cy="2267712"/>
+          </a:xfrm>
+          <a:prstGeom prst="rect">
+            <a:avLst/>
+          </a:prstGeom>
+        </p:spPr>
+      </p:pic>
+      <p:sp>
+        <p:nvSpPr>
+          <p:cNvPr id="9" name="Rectangle 8"/>
+          <p:cNvSpPr/>
+          <p:nvPr/>
+        </p:nvSpPr>
+        <p:spPr>
+          <a:xfrm>
+            <a:off x="8641080" y="2057400"/>
+            <a:ext cx="2770632" cy="2267712"/>
+          </a:xfrm>
+          <a:prstGeom prst="rect">
+            <a:avLst/>
+          </a:prstGeom>
+          <a:solidFill>
+            <a:srgbClr val="ECF4EF"/>
+          </a:solidFill>
+          <a:ln w="13970">
+            <a:solidFill>
+              <a:srgbClr val="127145"/>
+            </a:solidFill>
+          </a:ln>
+          <a:effectLst/>
+        </p:spPr>
+        <p:style>
+          <a:lnRef idx="1">
+            <a:schemeClr val="accent1"/>
+          </a:lnRef>
+          <a:fillRef idx="3">
+            <a:schemeClr val="accent1"/>
+          </a:fillRef>
+          <a:effectRef idx="2">
+            <a:schemeClr val="accent1"/>
+          </a:effectRef>
+          <a:fontRef idx="minor">
+            <a:schemeClr val="lt1"/>
+          </a:fontRef>
+        </p:style>
+        <p:txBody>
+          <a:bodyPr rtlCol="0" anchor="ctr"/>
+          <a:lstStyle/>
+          <a:p>
+            <a:pPr algn="ctr"/>
+          </a:p>
+        </p:txBody>
+      </p:sp>
+      <p:sp>
+        <p:nvSpPr>
+          <p:cNvPr id="10" name="TextBox 9"/>
+          <p:cNvSpPr txBox="1"/>
+          <p:nvPr/>
+        </p:nvSpPr>
+        <p:spPr>
+          <a:xfrm>
+            <a:off x="8869680" y="2304288"/>
+            <a:ext cx="2331720" cy="320040"/>
+          </a:xfrm>
+          <a:prstGeom prst="rect">
+            <a:avLst/>
+          </a:prstGeom>
+          <a:noFill/>
+        </p:spPr>
+        <p:txBody>
+          <a:bodyPr wrap="square" anchor="t" lIns="0" rIns="0" tIns="0" bIns="0">
+            <a:spAutoFit/>
+          </a:bodyPr>
+          <a:lstStyle/>
+          <a:p>
+            <a:pPr algn="l">
+              <a:lnSpc>
+                <a:spcPct val="112000"/>
+              </a:lnSpc>
+              <a:spcAft>
+                <a:spcPts val="800"/>
+              </a:spcAft>
+            </a:pPr>
+            <a:r>
+              <a:rPr sz="1100" b="1">
+                <a:solidFill>
+                  <a:srgbClr val="127145"/>
+                </a:solidFill>
+                <a:latin typeface="Helvetica Neue"/>
+              </a:rPr>
+              <a:t>TABLO NE İŞE YARAR?</a:t>
+            </a:r>
+          </a:p>
+        </p:txBody>
+      </p:sp>
+      <p:sp>
+        <p:nvSpPr>
+          <p:cNvPr id="11" name="TextBox 10"/>
+          <p:cNvSpPr txBox="1"/>
+          <p:nvPr/>
+        </p:nvSpPr>
+        <p:spPr>
+          <a:xfrm>
+            <a:off x="8869680" y="2697480"/>
+            <a:ext cx="2240280" cy="3337560"/>
+          </a:xfrm>
+          <a:prstGeom prst="rect">
+            <a:avLst/>
+          </a:prstGeom>
+          <a:noFill/>
+        </p:spPr>
+        <p:txBody>
+          <a:bodyPr wrap="square" lIns="0" rIns="0" tIns="0">
+            <a:spAutoFit/>
+          </a:bodyPr>
+          <a:lstStyle/>
+          <a:p>
+            <a:pPr>
+              <a:lnSpc>
+                <a:spcPct val="116000"/>
+              </a:lnSpc>
+              <a:spcAft>
+                <a:spcPts val="700"/>
+              </a:spcAft>
+            </a:pPr>
+            <a:r>
+              <a:rPr sz="1120" b="1">
+                <a:solidFill>
+                  <a:srgbClr val="127145"/>
+                </a:solidFill>
+                <a:latin typeface="Helvetica Neue"/>
+              </a:rPr>
+              <a:t>—  </a:t>
+            </a:r>
+            <a:r>
+              <a:rPr sz="1120" b="0">
+                <a:solidFill>
+                  <a:srgbClr val="1A1F1D"/>
+                </a:solidFill>
+                <a:latin typeface="Helvetica Neue"/>
+              </a:rPr>
+              <a:t>ΔA / ΔP / ΔQ / ΔOEE birlikte görünür.</a:t>
+            </a:r>
+          </a:p>
+          <a:p>
+            <a:pPr>
+              <a:lnSpc>
+                <a:spcPct val="116000"/>
+              </a:lnSpc>
+              <a:spcAft>
+                <a:spcPts val="700"/>
+              </a:spcAft>
+            </a:pPr>
+            <a:r>
+              <a:rPr sz="1120" b="1">
+                <a:solidFill>
+                  <a:srgbClr val="127145"/>
+                </a:solidFill>
+                <a:latin typeface="Helvetica Neue"/>
+              </a:rPr>
+              <a:t>—  </a:t>
+            </a:r>
+            <a:r>
+              <a:rPr sz="1120" b="0">
+                <a:solidFill>
+                  <a:srgbClr val="1A1F1D"/>
+                </a:solidFill>
+                <a:latin typeface="Helvetica Neue"/>
+              </a:rPr>
+              <a:t>Runtime ve schedule kazanımı ayrıdır.</a:t>
+            </a:r>
+          </a:p>
+          <a:p>
+            <a:pPr>
+              <a:lnSpc>
+                <a:spcPct val="116000"/>
+              </a:lnSpc>
+              <a:spcAft>
+                <a:spcPts val="700"/>
+              </a:spcAft>
+            </a:pPr>
+            <a:r>
+              <a:rPr sz="1120" b="1">
+                <a:solidFill>
+                  <a:srgbClr val="127145"/>
+                </a:solidFill>
+                <a:latin typeface="Helvetica Neue"/>
+              </a:rPr>
+              <a:t>—  </a:t>
+            </a:r>
+            <a:r>
+              <a:rPr sz="1120" b="0">
+                <a:solidFill>
+                  <a:srgbClr val="1A1F1D"/>
+                </a:solidFill>
+                <a:latin typeface="Helvetica Neue"/>
+              </a:rPr>
+              <a:t>Sütun başlığına tıklayarak sıralanır.</a:t>
+            </a:r>
+          </a:p>
+        </p:txBody>
+      </p:sp>
+      <p:sp>
+        <p:nvSpPr>
+          <p:cNvPr id="12" name="Rectangle 11"/>
+          <p:cNvSpPr/>
+          <p:nvPr/>
+        </p:nvSpPr>
+        <p:spPr>
+          <a:xfrm>
+            <a:off x="777240" y="4736592"/>
+            <a:ext cx="10637215" cy="1078992"/>
+          </a:xfrm>
+          <a:prstGeom prst="rect">
+            <a:avLst/>
+          </a:prstGeom>
+          <a:solidFill>
+            <a:srgbClr val="ECF4EF"/>
+          </a:solidFill>
+          <a:ln w="13970">
+            <a:solidFill>
+              <a:srgbClr val="127145"/>
+            </a:solidFill>
+          </a:ln>
+          <a:effectLst/>
+        </p:spPr>
+        <p:style>
+          <a:lnRef idx="1">
+            <a:schemeClr val="accent1"/>
+          </a:lnRef>
+          <a:fillRef idx="3">
+            <a:schemeClr val="accent1"/>
+          </a:fillRef>
+          <a:effectRef idx="2">
+            <a:schemeClr val="accent1"/>
+          </a:effectRef>
+          <a:fontRef idx="minor">
+            <a:schemeClr val="lt1"/>
+          </a:fontRef>
+        </p:style>
+        <p:txBody>
+          <a:bodyPr rtlCol="0" anchor="ctr"/>
+          <a:lstStyle/>
+          <a:p>
+            <a:pPr algn="ctr"/>
+          </a:p>
+        </p:txBody>
+      </p:sp>
+      <p:sp>
+        <p:nvSpPr>
+          <p:cNvPr id="13" name="TextBox 12"/>
+          <p:cNvSpPr txBox="1"/>
+          <p:nvPr/>
+        </p:nvSpPr>
+        <p:spPr>
+          <a:xfrm>
+            <a:off x="978408" y="4956048"/>
+            <a:ext cx="10234879" cy="658368"/>
+          </a:xfrm>
+          <a:prstGeom prst="rect">
+            <a:avLst/>
+          </a:prstGeom>
+          <a:noFill/>
+        </p:spPr>
+        <p:txBody>
+          <a:bodyPr wrap="square" anchor="t" lIns="0" rIns="0" tIns="0" bIns="0">
+            <a:spAutoFit/>
+          </a:bodyPr>
+          <a:lstStyle/>
+          <a:p>
+            <a:pPr algn="l">
+              <a:lnSpc>
+                <a:spcPct val="116000"/>
+              </a:lnSpc>
+              <a:spcAft>
+                <a:spcPts val="800"/>
+              </a:spcAft>
+            </a:pPr>
+            <a:r>
+              <a:rPr sz="1200" b="0">
+                <a:solidFill>
+                  <a:srgbClr val="1A1F1D"/>
+                </a:solidFill>
+                <a:latin typeface="Helvetica Neue"/>
+              </a:rPr>
+              <a:t>S1 gerçek zaman/OEE kazanımıdır. S2 yalnız sınıflandırma etkisini, S3 üretim verisi yokluğundaki inert kolu, S4 ise IT sahipliğindeki schedule görünürlüğünü gösterir.</a:t>
+            </a:r>
+          </a:p>
+        </p:txBody>
+      </p:sp>
+    </p:spTree>
+  </p:cSld>
+  <p:clrMapOvr>
+    <a:masterClrMapping/>
+  </p:clrMapOvr>
+</p:sld>
+</file>
+
+<file path=ppt/slides/slide18.xml><?xml version="1.0" encoding="utf-8"?>
+<p:sld xmlns:a="http://schemas.openxmlformats.org/drawingml/2006/main" xmlns:p="http://schemas.openxmlformats.org/presentationml/2006/main" xmlns:r="http://schemas.openxmlformats.org/officeDocument/2006/relationships">
+  <p:cSld>
+    <p:spTree>
+      <p:nvGrpSpPr>
+        <p:cNvPr id="1" name=""/>
+        <p:cNvGrpSpPr/>
+        <p:nvPr/>
+      </p:nvGrpSpPr>
+      <p:grpSpPr/>
+      <p:sp>
+        <p:nvSpPr>
+          <p:cNvPr id="2" name="Rectangle 1"/>
+          <p:cNvSpPr/>
+          <p:nvPr/>
+        </p:nvSpPr>
+        <p:spPr>
+          <a:xfrm>
+            <a:off x="0" y="0"/>
+            <a:ext cx="128016" cy="6858000"/>
+          </a:xfrm>
+          <a:prstGeom prst="rect">
+            <a:avLst/>
+          </a:prstGeom>
+          <a:solidFill>
+            <a:srgbClr val="127145"/>
+          </a:solidFill>
+          <a:ln>
+            <a:noFill/>
+          </a:ln>
+          <a:effectLst/>
+        </p:spPr>
+        <p:style>
+          <a:lnRef idx="1">
+            <a:schemeClr val="accent1"/>
+          </a:lnRef>
+          <a:fillRef idx="3">
+            <a:schemeClr val="accent1"/>
+          </a:fillRef>
+          <a:effectRef idx="2">
+            <a:schemeClr val="accent1"/>
+          </a:effectRef>
+          <a:fontRef idx="minor">
+            <a:schemeClr val="lt1"/>
+          </a:fontRef>
+        </p:style>
+        <p:txBody>
+          <a:bodyPr rtlCol="0" anchor="ctr"/>
+          <a:lstStyle/>
+          <a:p>
+            <a:pPr algn="ctr"/>
+          </a:p>
+        </p:txBody>
+      </p:sp>
+      <p:sp>
+        <p:nvSpPr>
+          <p:cNvPr id="3" name="TextBox 2"/>
+          <p:cNvSpPr txBox="1"/>
+          <p:nvPr/>
+        </p:nvSpPr>
+        <p:spPr>
+          <a:xfrm>
+            <a:off x="777240" y="475488"/>
+            <a:ext cx="10637215" cy="274320"/>
+          </a:xfrm>
+          <a:prstGeom prst="rect">
+            <a:avLst/>
+          </a:prstGeom>
+          <a:noFill/>
+        </p:spPr>
+        <p:txBody>
+          <a:bodyPr wrap="square" anchor="t" lIns="0" rIns="0" tIns="0" bIns="0">
+            <a:spAutoFit/>
+          </a:bodyPr>
+          <a:lstStyle/>
+          <a:p>
+            <a:pPr algn="l">
+              <a:lnSpc>
+                <a:spcPct val="112000"/>
+              </a:lnSpc>
+              <a:spcAft>
+                <a:spcPts val="800"/>
+              </a:spcAft>
+            </a:pPr>
+            <a:r>
+              <a:rPr sz="1150" b="1">
+                <a:solidFill>
+                  <a:srgbClr val="127145"/>
+                </a:solidFill>
+                <a:latin typeface="Helvetica Neue"/>
+              </a:rPr>
+              <a:t>CANLI ARAYÜZ REHBERI</a:t>
+            </a:r>
+          </a:p>
+        </p:txBody>
+      </p:sp>
+      <p:sp>
+        <p:nvSpPr>
+          <p:cNvPr id="4" name="TextBox 3"/>
+          <p:cNvSpPr txBox="1"/>
+          <p:nvPr/>
+        </p:nvSpPr>
+        <p:spPr>
+          <a:xfrm>
+            <a:off x="777240" y="841248"/>
+            <a:ext cx="10637215" cy="868680"/>
+          </a:xfrm>
+          <a:prstGeom prst="rect">
+            <a:avLst/>
+          </a:prstGeom>
+          <a:noFill/>
+        </p:spPr>
+        <p:txBody>
+          <a:bodyPr wrap="square" anchor="t" lIns="0" rIns="0" tIns="0" bIns="0">
+            <a:spAutoFit/>
+          </a:bodyPr>
+          <a:lstStyle/>
+          <a:p>
+            <a:pPr algn="l">
+              <a:lnSpc>
+                <a:spcPct val="102000"/>
+              </a:lnSpc>
+              <a:spcAft>
+                <a:spcPts val="800"/>
+              </a:spcAft>
+            </a:pPr>
+            <a:r>
+              <a:rPr sz="2900" b="1">
+                <a:solidFill>
+                  <a:srgbClr val="1A1F1D"/>
+                </a:solidFill>
+                <a:latin typeface="Helvetica Neue"/>
+              </a:rPr>
+              <a:t>Çapraz Makine — iddiayı null-model ile sınar</a:t>
+            </a:r>
+          </a:p>
+        </p:txBody>
+      </p:sp>
+      <p:sp>
+        <p:nvSpPr>
+          <p:cNvPr id="5" name="Rectangle 4"/>
+          <p:cNvSpPr/>
+          <p:nvPr/>
+        </p:nvSpPr>
+        <p:spPr>
+          <a:xfrm>
+            <a:off x="777240" y="1755648"/>
+            <a:ext cx="10637215" cy="10972"/>
+          </a:xfrm>
+          <a:prstGeom prst="rect">
+            <a:avLst/>
+          </a:prstGeom>
+          <a:solidFill>
+            <a:srgbClr val="D9DFDB"/>
+          </a:solidFill>
+          <a:ln>
+            <a:noFill/>
+          </a:ln>
+          <a:effectLst/>
+        </p:spPr>
+        <p:style>
+          <a:lnRef idx="1">
+            <a:schemeClr val="accent1"/>
+          </a:lnRef>
+          <a:fillRef idx="3">
+            <a:schemeClr val="accent1"/>
+          </a:fillRef>
+          <a:effectRef idx="2">
+            <a:schemeClr val="accent1"/>
+          </a:effectRef>
+          <a:fontRef idx="minor">
+            <a:schemeClr val="lt1"/>
+          </a:fontRef>
+        </p:style>
+        <p:txBody>
+          <a:bodyPr rtlCol="0" anchor="ctr"/>
+          <a:lstStyle/>
+          <a:p>
+            <a:pPr algn="ctr"/>
+          </a:p>
+        </p:txBody>
+      </p:sp>
+      <p:sp>
+        <p:nvSpPr>
+          <p:cNvPr id="6" name="TextBox 5"/>
+          <p:cNvSpPr txBox="1"/>
+          <p:nvPr/>
+        </p:nvSpPr>
+        <p:spPr>
+          <a:xfrm>
+            <a:off x="777240" y="6437376"/>
+            <a:ext cx="10088575" cy="274320"/>
+          </a:xfrm>
+          <a:prstGeom prst="rect">
+            <a:avLst/>
+          </a:prstGeom>
+          <a:noFill/>
+        </p:spPr>
+        <p:txBody>
+          <a:bodyPr wrap="square" anchor="t" lIns="0" rIns="0" tIns="0" bIns="0">
+            <a:spAutoFit/>
+          </a:bodyPr>
+          <a:lstStyle/>
+          <a:p>
+            <a:pPr algn="l">
+              <a:lnSpc>
+                <a:spcPct val="112000"/>
+              </a:lnSpc>
+              <a:spcAft>
+                <a:spcPts val="800"/>
+              </a:spcAft>
+            </a:pPr>
+            <a:r>
+              <a:rPr sz="900" b="0">
+                <a:solidFill>
+                  <a:srgbClr val="6B7771"/>
+                </a:solidFill>
+                <a:latin typeface="Helvetica Neue"/>
+              </a:rPr>
+              <a:t>trexCloud · Öngörücü OEE &amp; Kök-Neden Analizi</a:t>
+            </a:r>
+          </a:p>
+        </p:txBody>
+      </p:sp>
+      <p:sp>
+        <p:nvSpPr>
+          <p:cNvPr id="7" name="TextBox 6"/>
+          <p:cNvSpPr txBox="1"/>
+          <p:nvPr/>
+        </p:nvSpPr>
+        <p:spPr>
+          <a:xfrm>
+            <a:off x="10911535" y="6437376"/>
+            <a:ext cx="502920" cy="274320"/>
+          </a:xfrm>
+          <a:prstGeom prst="rect">
+            <a:avLst/>
+          </a:prstGeom>
+          <a:noFill/>
+        </p:spPr>
+        <p:txBody>
+          <a:bodyPr wrap="square" anchor="t" lIns="0" rIns="0" tIns="0" bIns="0">
+            <a:spAutoFit/>
+          </a:bodyPr>
+          <a:lstStyle/>
+          <a:p>
+            <a:pPr algn="r">
+              <a:lnSpc>
+                <a:spcPct val="112000"/>
+              </a:lnSpc>
+              <a:spcAft>
+                <a:spcPts val="800"/>
+              </a:spcAft>
+            </a:pPr>
+            <a:r>
+              <a:rPr sz="900" b="0">
+                <a:solidFill>
+                  <a:srgbClr val="6B7771"/>
+                </a:solidFill>
+                <a:latin typeface="Helvetica Neue"/>
+              </a:rPr>
+              <a:t>18</a:t>
+            </a:r>
+          </a:p>
+        </p:txBody>
+      </p:sp>
+      <p:pic>
+        <p:nvPicPr>
+          <p:cNvPr id="8" name="Picture 7" descr="cross_machine.png"/>
+          <p:cNvPicPr>
+            <a:picLocks noChangeAspect="1"/>
+          </p:cNvPicPr>
+          <p:nvPr/>
+        </p:nvPicPr>
+        <p:blipFill>
+          <a:blip r:embed="rId2"/>
+          <a:stretch>
+            <a:fillRect/>
+          </a:stretch>
+        </p:blipFill>
+        <p:spPr>
+          <a:xfrm>
+            <a:off x="1390830" y="1938528"/>
+            <a:ext cx="6179458" cy="4407408"/>
+          </a:xfrm>
+          <a:prstGeom prst="rect">
+            <a:avLst/>
+          </a:prstGeom>
+        </p:spPr>
+      </p:pic>
+      <p:sp>
+        <p:nvSpPr>
+          <p:cNvPr id="9" name="Rectangle 8"/>
+          <p:cNvSpPr/>
+          <p:nvPr/>
+        </p:nvSpPr>
+        <p:spPr>
+          <a:xfrm>
+            <a:off x="8275320" y="1938528"/>
+            <a:ext cx="3136392" cy="4407408"/>
+          </a:xfrm>
+          <a:prstGeom prst="rect">
+            <a:avLst/>
+          </a:prstGeom>
+          <a:solidFill>
+            <a:srgbClr val="ECF4EF"/>
+          </a:solidFill>
+          <a:ln w="13970">
+            <a:solidFill>
+              <a:srgbClr val="127145"/>
+            </a:solidFill>
+          </a:ln>
+          <a:effectLst/>
+        </p:spPr>
+        <p:style>
+          <a:lnRef idx="1">
+            <a:schemeClr val="accent1"/>
+          </a:lnRef>
+          <a:fillRef idx="3">
+            <a:schemeClr val="accent1"/>
+          </a:fillRef>
+          <a:effectRef idx="2">
+            <a:schemeClr val="accent1"/>
+          </a:effectRef>
+          <a:fontRef idx="minor">
+            <a:schemeClr val="lt1"/>
+          </a:fontRef>
+        </p:style>
+        <p:txBody>
+          <a:bodyPr rtlCol="0" anchor="ctr"/>
+          <a:lstStyle/>
+          <a:p>
+            <a:pPr algn="ctr"/>
+          </a:p>
+        </p:txBody>
+      </p:sp>
+      <p:sp>
+        <p:nvSpPr>
+          <p:cNvPr id="10" name="TextBox 9"/>
+          <p:cNvSpPr txBox="1"/>
+          <p:nvPr/>
+        </p:nvSpPr>
+        <p:spPr>
+          <a:xfrm>
+            <a:off x="8503920" y="2212848"/>
+            <a:ext cx="2697480" cy="320040"/>
+          </a:xfrm>
+          <a:prstGeom prst="rect">
+            <a:avLst/>
+          </a:prstGeom>
+          <a:noFill/>
+        </p:spPr>
+        <p:txBody>
+          <a:bodyPr wrap="square" anchor="t" lIns="0" rIns="0" tIns="0" bIns="0">
+            <a:spAutoFit/>
+          </a:bodyPr>
+          <a:lstStyle/>
+          <a:p>
+            <a:pPr algn="l">
+              <a:lnSpc>
+                <a:spcPct val="112000"/>
+              </a:lnSpc>
+              <a:spcAft>
+                <a:spcPts val="800"/>
+              </a:spcAft>
+            </a:pPr>
+            <a:r>
+              <a:rPr sz="1100" b="1">
+                <a:solidFill>
+                  <a:srgbClr val="127145"/>
+                </a:solidFill>
+                <a:latin typeface="Helvetica Neue"/>
+              </a:rPr>
+              <a:t>PLATİN EKRANI</a:t>
+            </a:r>
+          </a:p>
+        </p:txBody>
+      </p:sp>
+      <p:sp>
+        <p:nvSpPr>
+          <p:cNvPr id="11" name="TextBox 10"/>
+          <p:cNvSpPr txBox="1"/>
+          <p:nvPr/>
+        </p:nvSpPr>
+        <p:spPr>
+          <a:xfrm>
+            <a:off x="8503920" y="2670048"/>
+            <a:ext cx="2651760" cy="3364992"/>
+          </a:xfrm>
+          <a:prstGeom prst="rect">
+            <a:avLst/>
+          </a:prstGeom>
+          <a:noFill/>
+        </p:spPr>
+        <p:txBody>
+          <a:bodyPr wrap="square" lIns="0" rIns="0" tIns="0">
+            <a:spAutoFit/>
+          </a:bodyPr>
+          <a:lstStyle/>
+          <a:p>
+            <a:pPr>
+              <a:lnSpc>
+                <a:spcPct val="116000"/>
+              </a:lnSpc>
+              <a:spcAft>
+                <a:spcPts val="700"/>
+              </a:spcAft>
+            </a:pPr>
+            <a:r>
+              <a:rPr sz="1105" b="1">
+                <a:solidFill>
+                  <a:srgbClr val="127145"/>
+                </a:solidFill>
+                <a:latin typeface="Helvetica Neue"/>
+              </a:rPr>
+              <a:t>—  </a:t>
+            </a:r>
+            <a:r>
+              <a:rPr sz="1105" b="0">
+                <a:solidFill>
+                  <a:srgbClr val="1A1F1D"/>
+                </a:solidFill>
+                <a:latin typeface="Helvetica Neue"/>
+              </a:rPr>
+              <a:t>Eski connectivity sonucu kayıt tekrarı olarak teşhis edilir.</a:t>
+            </a:r>
+          </a:p>
+          <a:p>
+            <a:pPr>
+              <a:lnSpc>
+                <a:spcPct val="116000"/>
+              </a:lnSpc>
+              <a:spcAft>
+                <a:spcPts val="700"/>
+              </a:spcAft>
+            </a:pPr>
+            <a:r>
+              <a:rPr sz="1105" b="1">
+                <a:solidFill>
+                  <a:srgbClr val="127145"/>
+                </a:solidFill>
+                <a:latin typeface="Helvetica Neue"/>
+              </a:rPr>
+              <a:t>—  </a:t>
+            </a:r>
+            <a:r>
+              <a:rPr sz="1105" b="0">
+                <a:solidFill>
+                  <a:srgbClr val="1A1F1D"/>
+                </a:solidFill>
+                <a:latin typeface="Helvetica Neue"/>
+              </a:rPr>
+              <a:t>708 eşzamanlı duruş, vardiya ritmini koruyan null'ın üstündedir.</a:t>
+            </a:r>
+          </a:p>
+          <a:p>
+            <a:pPr>
+              <a:lnSpc>
+                <a:spcPct val="116000"/>
+              </a:lnSpc>
+              <a:spcAft>
+                <a:spcPts val="700"/>
+              </a:spcAft>
+            </a:pPr>
+            <a:r>
+              <a:rPr sz="1105" b="1">
+                <a:solidFill>
+                  <a:srgbClr val="127145"/>
+                </a:solidFill>
+                <a:latin typeface="Helvetica Neue"/>
+              </a:rPr>
+              <a:t>—  </a:t>
+            </a:r>
+            <a:r>
+              <a:rPr sz="1105" b="0">
+                <a:solidFill>
+                  <a:srgbClr val="1A1F1D"/>
+                </a:solidFill>
+                <a:latin typeface="Helvetica Neue"/>
+              </a:rPr>
+              <a:t>Rejim haritası hangi makinelerin birlikte modellenebileceğini gösterir.</a:t>
+            </a:r>
+          </a:p>
+          <a:p>
+            <a:pPr>
+              <a:lnSpc>
+                <a:spcPct val="116000"/>
+              </a:lnSpc>
+              <a:spcAft>
+                <a:spcPts val="700"/>
+              </a:spcAft>
+            </a:pPr>
+            <a:r>
+              <a:rPr sz="1105" b="1">
+                <a:solidFill>
+                  <a:srgbClr val="127145"/>
+                </a:solidFill>
+                <a:latin typeface="Helvetica Neue"/>
+              </a:rPr>
+              <a:t>—  </a:t>
+            </a:r>
+            <a:r>
+              <a:rPr sz="1105" b="0">
+                <a:solidFill>
+                  <a:srgbClr val="1A1F1D"/>
+                </a:solidFill>
+                <a:latin typeface="Helvetica Neue"/>
+              </a:rPr>
+              <a:t>Küme seviyesi güçlü olsa da türev korelasyonu ≈0: akut yayılım iddia edilmez.</a:t>
+            </a:r>
+          </a:p>
+        </p:txBody>
+      </p:sp>
+    </p:spTree>
+  </p:cSld>
+  <p:clrMapOvr>
+    <a:masterClrMapping/>
+  </p:clrMapOvr>
+</p:sld>
+</file>
+
 <file path=ppt/slides/slide2.xml><?xml version="1.0" encoding="utf-8"?>
 <p:sld xmlns:a="http://schemas.openxmlformats.org/drawingml/2006/main" xmlns:p="http://schemas.openxmlformats.org/presentationml/2006/main" xmlns:r="http://schemas.openxmlformats.org/officeDocument/2006/relationships">
   <p:cSld>
@@ -12201,7 +16620,7 @@
                 </a:solidFill>
                 <a:latin typeface="Helvetica Neue"/>
               </a:rPr>
-              <a:t>26,85</a:t>
+              <a:t>17,99</a:t>
             </a:r>
           </a:p>
         </p:txBody>
@@ -12377,7 +16796,7 @@
                 </a:solidFill>
                 <a:latin typeface="Helvetica Neue"/>
               </a:rPr>
-              <a:t>26,85</a:t>
+              <a:t>17,99</a:t>
             </a:r>
           </a:p>
         </p:txBody>
@@ -12465,7 +16884,7 @@
                 </a:solidFill>
                 <a:latin typeface="Helvetica Neue"/>
               </a:rPr>
-              <a:t>933</a:t>
+              <a:t>625</a:t>
             </a:r>
           </a:p>
         </p:txBody>
@@ -12553,7 +16972,7 @@
                 </a:solidFill>
                 <a:latin typeface="Helvetica Neue"/>
               </a:rPr>
-              <a:t>10,016</a:t>
+              <a:t>6,614</a:t>
             </a:r>
           </a:p>
         </p:txBody>

</xml_diff>